<commit_message>
Simplify all workshop materials for complete beginners after Astra review
</commit_message>
<xml_diff>
--- a/workshop-2/teacher-slides.pptx
+++ b/workshop-2/teacher-slides.pptx
@@ -2,26 +2,25 @@
 <file path=ppt/presentation.xml><?xml version="1.0" encoding="utf-8"?>
 <p:presentation xmlns:p="http://schemas.openxmlformats.org/presentationml/2006/main">
   <p:sldMasterIdLst>
-    <p:sldMasterId xmlns:r="http://schemas.openxmlformats.org/officeDocument/2006/relationships" id="2147483648" r:id="R7d758406757c4bd6"/>
+    <p:sldMasterId xmlns:r="http://schemas.openxmlformats.org/officeDocument/2006/relationships" id="2147483648" r:id="R044cb51daba24384"/>
   </p:sldMasterIdLst>
   <p:notesMasterIdLst>
-    <p:notesMasterId xmlns:r="http://schemas.openxmlformats.org/officeDocument/2006/relationships" r:id="R68e4bf1f92b040d0"/>
+    <p:notesMasterId xmlns:r="http://schemas.openxmlformats.org/officeDocument/2006/relationships" r:id="R042a157311c64ee0"/>
   </p:notesMasterIdLst>
   <p:sldIdLst>
-    <p:sldId xmlns:r="http://schemas.openxmlformats.org/officeDocument/2006/relationships" id="256" r:id="R32388274c9c24b56"/>
-    <p:sldId xmlns:r="http://schemas.openxmlformats.org/officeDocument/2006/relationships" id="257" r:id="R714e16b3486144a3"/>
-    <p:sldId xmlns:r="http://schemas.openxmlformats.org/officeDocument/2006/relationships" id="258" r:id="R2a700402f83e423e"/>
-    <p:sldId xmlns:r="http://schemas.openxmlformats.org/officeDocument/2006/relationships" id="259" r:id="R082674505af04a61"/>
-    <p:sldId xmlns:r="http://schemas.openxmlformats.org/officeDocument/2006/relationships" id="260" r:id="Rcb5bbc638470424c"/>
-    <p:sldId xmlns:r="http://schemas.openxmlformats.org/officeDocument/2006/relationships" id="261" r:id="Re36f5c045cce493e"/>
-    <p:sldId xmlns:r="http://schemas.openxmlformats.org/officeDocument/2006/relationships" id="262" r:id="Rbd79d17c12214f20"/>
-    <p:sldId xmlns:r="http://schemas.openxmlformats.org/officeDocument/2006/relationships" id="263" r:id="Raac47d801091480a"/>
-    <p:sldId xmlns:r="http://schemas.openxmlformats.org/officeDocument/2006/relationships" id="264" r:id="R4bf81b7c604f49db"/>
-    <p:sldId xmlns:r="http://schemas.openxmlformats.org/officeDocument/2006/relationships" id="265" r:id="R0d8dd6e57de64957"/>
-    <p:sldId xmlns:r="http://schemas.openxmlformats.org/officeDocument/2006/relationships" id="266" r:id="R055a9e8a644d4997"/>
-    <p:sldId xmlns:r="http://schemas.openxmlformats.org/officeDocument/2006/relationships" id="267" r:id="Re2f00e4dd3c04596"/>
-    <p:sldId xmlns:r="http://schemas.openxmlformats.org/officeDocument/2006/relationships" id="268" r:id="R0f0460da60944255"/>
-    <p:sldId xmlns:r="http://schemas.openxmlformats.org/officeDocument/2006/relationships" id="269" r:id="R253e020dd0fb4c67"/>
+    <p:sldId xmlns:r="http://schemas.openxmlformats.org/officeDocument/2006/relationships" id="256" r:id="Rdd1bd2c81d584b5d"/>
+    <p:sldId xmlns:r="http://schemas.openxmlformats.org/officeDocument/2006/relationships" id="257" r:id="R0ec89fa631d9450b"/>
+    <p:sldId xmlns:r="http://schemas.openxmlformats.org/officeDocument/2006/relationships" id="258" r:id="R55fef5a7a2324a93"/>
+    <p:sldId xmlns:r="http://schemas.openxmlformats.org/officeDocument/2006/relationships" id="259" r:id="Re2e5c870d4954074"/>
+    <p:sldId xmlns:r="http://schemas.openxmlformats.org/officeDocument/2006/relationships" id="260" r:id="R8fbb0192aafa4746"/>
+    <p:sldId xmlns:r="http://schemas.openxmlformats.org/officeDocument/2006/relationships" id="261" r:id="R72e48cc874bb421a"/>
+    <p:sldId xmlns:r="http://schemas.openxmlformats.org/officeDocument/2006/relationships" id="262" r:id="R857616e79f114935"/>
+    <p:sldId xmlns:r="http://schemas.openxmlformats.org/officeDocument/2006/relationships" id="263" r:id="R86a651d0827d43ce"/>
+    <p:sldId xmlns:r="http://schemas.openxmlformats.org/officeDocument/2006/relationships" id="264" r:id="Rce01e74bb8944a70"/>
+    <p:sldId xmlns:r="http://schemas.openxmlformats.org/officeDocument/2006/relationships" id="265" r:id="R236456ffe4014072"/>
+    <p:sldId xmlns:r="http://schemas.openxmlformats.org/officeDocument/2006/relationships" id="266" r:id="Rb79489bbc8364054"/>
+    <p:sldId xmlns:r="http://schemas.openxmlformats.org/officeDocument/2006/relationships" id="267" r:id="Rdc4c8f5a8f7842ad"/>
+    <p:sldId xmlns:r="http://schemas.openxmlformats.org/officeDocument/2006/relationships" id="268" r:id="Rc7240d0ae77f45e5"/>
   </p:sldIdLst>
   <p:sldSz cx="12192000" cy="6858000"/>
   <p:notesSz cx="6858000" cy="9144000"/>
@@ -665,7 +664,7 @@
           <a:lstStyle xmlns:a="http://schemas.openxmlformats.org/drawingml/2006/main"/>
           <a:p xmlns:a="http://schemas.openxmlformats.org/drawingml/2006/main">
             <a:r>
-              <a:t>Help beginners without a general debugging lecture. Read the last line of the error. Check cell order, matching list lengths, comma/quote/bracket. Do not tell students to execute unreviewed AI-generated code. Use prepared examples or ask the teacher.</a:t>
+              <a:t>Begin the final10-minute reflection block. The model learns a summary from data, then predicts for a new input. Code executing correctly is not the same as a prediction being accurate. Actual unseen cases with known outcomes are needed for accuracy evaluation.</a:t>
             </a:r>
           </a:p>
         </p:txBody>
@@ -696,76 +695,6 @@
 </file>
 
 <file path=ppt/notesSlides/notesSlide13.xml><?xml version="1.0" encoding="utf-8"?>
-<p:notes xmlns:p="http://schemas.openxmlformats.org/presentationml/2006/main">
-  <p:cSld>
-    <p:spTree>
-      <p:nvGrpSpPr>
-        <p:cNvPr id="1" name=""/>
-        <p:cNvGrpSpPr/>
-        <p:nvPr/>
-      </p:nvGrpSpPr>
-      <p:grpSpPr>
-        <a:xfrm xmlns:a="http://schemas.openxmlformats.org/drawingml/2006/main"/>
-      </p:grpSpPr>
-      <p:sp>
-        <p:nvSpPr>
-          <p:cNvPr id="2" name="Slide Image Placeholder 1"/>
-          <p:cNvSpPr>
-            <a:spLocks xmlns:a="http://schemas.openxmlformats.org/drawingml/2006/main" noGrp="1"/>
-          </p:cNvSpPr>
-          <p:nvPr>
-            <p:ph type="sldImg" idx="0"/>
-          </p:nvPr>
-        </p:nvSpPr>
-        <p:spPr/>
-      </p:sp>
-      <p:sp>
-        <p:nvSpPr>
-          <p:cNvPr id="3" name="Notes Placeholder 2"/>
-          <p:cNvSpPr>
-            <a:spLocks xmlns:a="http://schemas.openxmlformats.org/drawingml/2006/main" noGrp="1"/>
-          </p:cNvSpPr>
-          <p:nvPr>
-            <p:ph type="body" idx="1"/>
-          </p:nvPr>
-        </p:nvSpPr>
-        <p:spPr/>
-        <p:txBody>
-          <a:bodyPr xmlns:a="http://schemas.openxmlformats.org/drawingml/2006/main"/>
-          <a:lstStyle xmlns:a="http://schemas.openxmlformats.org/drawingml/2006/main"/>
-          <a:p xmlns:a="http://schemas.openxmlformats.org/drawingml/2006/main">
-            <a:r>
-              <a:t>Begin the final10-minute reflection block. The model learns a summary from data, then predicts for a new input. Code executing correctly is not the same as a prediction being accurate. Actual unseen cases with known outcomes are needed for accuracy evaluation.</a:t>
-            </a:r>
-          </a:p>
-        </p:txBody>
-      </p:sp>
-      <p:sp>
-        <p:nvSpPr>
-          <p:cNvPr id="4" name="Slide Number Placeholder 3"/>
-          <p:cNvSpPr>
-            <a:spLocks xmlns:a="http://schemas.openxmlformats.org/drawingml/2006/main" noGrp="1"/>
-          </p:cNvSpPr>
-          <p:nvPr>
-            <p:ph type="sldNum" idx="5"/>
-          </p:nvPr>
-        </p:nvSpPr>
-        <p:spPr/>
-        <p:txBody>
-          <a:bodyPr xmlns:a="http://schemas.openxmlformats.org/drawingml/2006/main"/>
-          <a:lstStyle xmlns:a="http://schemas.openxmlformats.org/drawingml/2006/main"/>
-          <a:p xmlns:a="http://schemas.openxmlformats.org/drawingml/2006/main"/>
-        </p:txBody>
-      </p:sp>
-    </p:spTree>
-  </p:cSld>
-  <p:clrMapOvr>
-    <a:masterClrMapping xmlns:a="http://schemas.openxmlformats.org/drawingml/2006/main"/>
-  </p:clrMapOvr>
-</p:notes>
-</file>
-
-<file path=ppt/notesSlides/notesSlide14.xml><?xml version="1.0" encoding="utf-8"?>
 <p:notes xmlns:p="http://schemas.openxmlformats.org/presentationml/2006/main">
   <p:cSld>
     <p:spTree>
@@ -1433,7 +1362,7 @@
   </p:cSld>
   <p:clrMap bg1="lt1" tx1="dk1" bg2="lt2" tx2="dk2" accent1="accent1" accent2="accent2" accent3="accent3" accent4="accent4" accent5="accent5" accent6="accent6" hlink="hlink" folHlink="folHlink"/>
   <p:sldLayoutIdLst>
-    <p:sldLayoutId xmlns:r="http://schemas.openxmlformats.org/officeDocument/2006/relationships" id="2147483649" r:id="R8de38083f55a48a6"/>
+    <p:sldLayoutId xmlns:r="http://schemas.openxmlformats.org/officeDocument/2006/relationships" id="2147483649" r:id="R8e0c1c757ab14192"/>
   </p:sldLayoutIdLst>
   <p:txStyles>
     <p:titleStyle>
@@ -3102,7 +3031,7 @@
           <p:cNvPr id="9" name="">
             <a:extLst xmlns:a="http://schemas.openxmlformats.org/drawingml/2006/main">
               <a:ext uri="{FF2B5EF4-FFF2-40B4-BE49-F238E27FC236}">
-                <a16:creationId xmlns:a16="http://schemas.microsoft.com/office/drawing/2014/main" id="{A0F078CB-91FA-446D-B137-0F676B57ADAA}"/>
+                <a16:creationId xmlns:a16="http://schemas.microsoft.com/office/drawing/2014/main" id="{B752A77E-A306-4CC1-BB6E-7AD45562A7D1}"/>
               </a:ext>
             </a:extLst>
           </p:cNvPr>
@@ -3159,7 +3088,7 @@
           <p:cNvPr id="2" name="">
             <a:extLst xmlns:a="http://schemas.openxmlformats.org/drawingml/2006/main">
               <a:ext uri="{FF2B5EF4-FFF2-40B4-BE49-F238E27FC236}">
-                <a16:creationId xmlns:a16="http://schemas.microsoft.com/office/drawing/2014/main" id="{235F1B43-90CB-4DBB-A506-7A84F18AF92E}"/>
+                <a16:creationId xmlns:a16="http://schemas.microsoft.com/office/drawing/2014/main" id="{943B87E2-B325-4EBA-9428-EF22A2B29FFA}"/>
               </a:ext>
             </a:extLst>
           </p:cNvPr>
@@ -3216,7 +3145,7 @@
           <p:cNvPr id="3" name="">
             <a:extLst xmlns:a="http://schemas.openxmlformats.org/drawingml/2006/main">
               <a:ext uri="{FF2B5EF4-FFF2-40B4-BE49-F238E27FC236}">
-                <a16:creationId xmlns:a16="http://schemas.microsoft.com/office/drawing/2014/main" id="{B34CB25C-DA78-43A0-845F-7862F40433A5}"/>
+                <a16:creationId xmlns:a16="http://schemas.microsoft.com/office/drawing/2014/main" id="{874EC583-9FB8-4496-9124-0B329B4503C3}"/>
               </a:ext>
             </a:extLst>
           </p:cNvPr>
@@ -3273,7 +3202,7 @@
           <p:cNvPr id="4" name="">
             <a:extLst xmlns:a="http://schemas.openxmlformats.org/drawingml/2006/main">
               <a:ext uri="{FF2B5EF4-FFF2-40B4-BE49-F238E27FC236}">
-                <a16:creationId xmlns:a16="http://schemas.microsoft.com/office/drawing/2014/main" id="{3C6C3836-27AB-47D8-9680-1EFB94B6EA70}"/>
+                <a16:creationId xmlns:a16="http://schemas.microsoft.com/office/drawing/2014/main" id="{D7B53494-DBE9-475C-A994-70A78EB75C92}"/>
               </a:ext>
             </a:extLst>
           </p:cNvPr>
@@ -3353,7 +3282,7 @@
           <p:cNvPr id="5" name="">
             <a:extLst xmlns:a="http://schemas.openxmlformats.org/drawingml/2006/main">
               <a:ext uri="{FF2B5EF4-FFF2-40B4-BE49-F238E27FC236}">
-                <a16:creationId xmlns:a16="http://schemas.microsoft.com/office/drawing/2014/main" id="{A6EB90CC-3B9F-45A8-B206-ACD436C632C2}"/>
+                <a16:creationId xmlns:a16="http://schemas.microsoft.com/office/drawing/2014/main" id="{4B4411A5-A079-483B-9740-C7182060183A}"/>
               </a:ext>
             </a:extLst>
           </p:cNvPr>
@@ -3410,7 +3339,7 @@
           <p:cNvPr id="6" name="">
             <a:extLst xmlns:a="http://schemas.openxmlformats.org/drawingml/2006/main">
               <a:ext uri="{FF2B5EF4-FFF2-40B4-BE49-F238E27FC236}">
-                <a16:creationId xmlns:a16="http://schemas.microsoft.com/office/drawing/2014/main" id="{9BEA0A08-15E0-4E90-91F6-6C44F86E0E23}"/>
+                <a16:creationId xmlns:a16="http://schemas.microsoft.com/office/drawing/2014/main" id="{17145388-09DF-4B70-A47C-28D2D3BC3C1F}"/>
               </a:ext>
             </a:extLst>
           </p:cNvPr>
@@ -3467,7 +3396,7 @@
           <p:cNvPr id="7" name="">
             <a:extLst xmlns:a="http://schemas.openxmlformats.org/drawingml/2006/main">
               <a:ext uri="{FF2B5EF4-FFF2-40B4-BE49-F238E27FC236}">
-                <a16:creationId xmlns:a16="http://schemas.microsoft.com/office/drawing/2014/main" id="{D0AE2506-B954-4A3D-BFE2-B7986EE66463}"/>
+                <a16:creationId xmlns:a16="http://schemas.microsoft.com/office/drawing/2014/main" id="{29DD5C81-2760-459F-9AAD-FA93457BF77B}"/>
               </a:ext>
             </a:extLst>
           </p:cNvPr>
@@ -3524,7 +3453,7 @@
           <p:cNvPr id="8" name="">
             <a:extLst xmlns:a="http://schemas.openxmlformats.org/drawingml/2006/main">
               <a:ext uri="{FF2B5EF4-FFF2-40B4-BE49-F238E27FC236}">
-                <a16:creationId xmlns:a16="http://schemas.microsoft.com/office/drawing/2014/main" id="{B4F1C29E-7283-4A68-93FD-2888D92FC457}"/>
+                <a16:creationId xmlns:a16="http://schemas.microsoft.com/office/drawing/2014/main" id="{30257F34-C3E7-43D7-A7FC-89EEB49DFE2C}"/>
               </a:ext>
             </a:extLst>
           </p:cNvPr>
@@ -3579,7 +3508,7 @@
     </p:spTree>
     <p:extLst>
       <p:ext uri="{BB962C8B-B14F-4D97-AF65-F5344CB8AC3E}">
-        <p14:creationId xmlns:p14="http://schemas.microsoft.com/office/powerpoint/2010/main" val="2027243489"/>
+        <p14:creationId xmlns:p14="http://schemas.microsoft.com/office/powerpoint/2010/main" val="1447152484"/>
       </p:ext>
     </p:extLst>
   </p:cSld>
@@ -3610,7 +3539,7 @@
           <p:cNvPr id="10" name="">
             <a:extLst xmlns:a="http://schemas.openxmlformats.org/drawingml/2006/main">
               <a:ext uri="{FF2B5EF4-FFF2-40B4-BE49-F238E27FC236}">
-                <a16:creationId xmlns:a16="http://schemas.microsoft.com/office/drawing/2014/main" id="{C6711450-7960-4DA5-8204-0D50329D43D5}"/>
+                <a16:creationId xmlns:a16="http://schemas.microsoft.com/office/drawing/2014/main" id="{57B5B715-C402-4A62-A4E7-B51EA6AAA817}"/>
               </a:ext>
             </a:extLst>
           </p:cNvPr>
@@ -3657,7 +3586,7 @@
                 <a:ea typeface="Heiti TC"/>
                 <a:cs typeface="Heiti TC"/>
               </a:rPr>
-              <a:t>一個奇怪的新點，會搗亂嗎？</a:t>
+              <a:t>加入一個新數據點</a:t>
             </a:r>
           </a:p>
         </p:txBody>
@@ -3667,7 +3596,7 @@
           <p:cNvPr id="2" name="">
             <a:extLst xmlns:a="http://schemas.openxmlformats.org/drawingml/2006/main">
               <a:ext uri="{FF2B5EF4-FFF2-40B4-BE49-F238E27FC236}">
-                <a16:creationId xmlns:a16="http://schemas.microsoft.com/office/drawing/2014/main" id="{CE145A89-4814-4761-B0E3-BB38E7AAADA4}"/>
+                <a16:creationId xmlns:a16="http://schemas.microsoft.com/office/drawing/2014/main" id="{8F6E4AC5-50EE-428B-B2D4-81FEEFE8E7A5}"/>
               </a:ext>
             </a:extLst>
           </p:cNvPr>
@@ -3714,7 +3643,7 @@
                 <a:ea typeface="Arial"/>
                 <a:cs typeface="Arial"/>
               </a:rPr>
-              <a:t>Can one surprising point change the line?</a:t>
+              <a:t>Add a new data point</a:t>
             </a:r>
           </a:p>
         </p:txBody>
@@ -3724,7 +3653,7 @@
           <p:cNvPr id="3" name="">
             <a:extLst xmlns:a="http://schemas.openxmlformats.org/drawingml/2006/main">
               <a:ext uri="{FF2B5EF4-FFF2-40B4-BE49-F238E27FC236}">
-                <a16:creationId xmlns:a16="http://schemas.microsoft.com/office/drawing/2014/main" id="{4A1FFFB0-2DBB-46A6-ABAF-BF8BB839867C}"/>
+                <a16:creationId xmlns:a16="http://schemas.microsoft.com/office/drawing/2014/main" id="{30BB6F86-747F-4E76-A6AC-129B02EB381F}"/>
               </a:ext>
             </a:extLst>
           </p:cNvPr>
@@ -3788,7 +3717,7 @@
         </p:xfrm>
         <a:graphic xmlns:a="http://schemas.openxmlformats.org/drawingml/2006/main">
           <a:graphicData uri="http://schemas.openxmlformats.org/drawingml/2006/chart">
-            <c:chart xmlns:r="http://schemas.openxmlformats.org/officeDocument/2006/relationships" xmlns:c="http://schemas.openxmlformats.org/drawingml/2006/chart" r:id="R6412fb60b8d6421a"/>
+            <c:chart xmlns:r="http://schemas.openxmlformats.org/officeDocument/2006/relationships" xmlns:c="http://schemas.openxmlformats.org/drawingml/2006/chart" r:id="R8ed73304277c4f3c"/>
           </a:graphicData>
         </a:graphic>
       </p:graphicFrame>
@@ -3797,7 +3726,7 @@
           <p:cNvPr id="5" name="">
             <a:extLst xmlns:a="http://schemas.openxmlformats.org/drawingml/2006/main">
               <a:ext uri="{FF2B5EF4-FFF2-40B4-BE49-F238E27FC236}">
-                <a16:creationId xmlns:a16="http://schemas.microsoft.com/office/drawing/2014/main" id="{9042C2B6-3A3F-4035-9D46-EDCEFAC1C344}"/>
+                <a16:creationId xmlns:a16="http://schemas.microsoft.com/office/drawing/2014/main" id="{15799048-06A1-4824-93FA-7A03DF892F31}"/>
               </a:ext>
             </a:extLst>
           </p:cNvPr>
@@ -3854,7 +3783,7 @@
           <p:cNvPr id="6" name="">
             <a:extLst xmlns:a="http://schemas.openxmlformats.org/drawingml/2006/main">
               <a:ext uri="{FF2B5EF4-FFF2-40B4-BE49-F238E27FC236}">
-                <a16:creationId xmlns:a16="http://schemas.microsoft.com/office/drawing/2014/main" id="{62DDC0F5-AFCE-4D85-95E3-C0965CBD83DA}"/>
+                <a16:creationId xmlns:a16="http://schemas.microsoft.com/office/drawing/2014/main" id="{2AFE3545-983A-4D8F-897F-EA30D7582928}"/>
               </a:ext>
             </a:extLst>
           </p:cNvPr>
@@ -3911,7 +3840,7 @@
           <p:cNvPr id="7" name="">
             <a:extLst xmlns:a="http://schemas.openxmlformats.org/drawingml/2006/main">
               <a:ext uri="{FF2B5EF4-FFF2-40B4-BE49-F238E27FC236}">
-                <a16:creationId xmlns:a16="http://schemas.microsoft.com/office/drawing/2014/main" id="{9C342F24-E06D-45AF-A020-E389C84578E0}"/>
+                <a16:creationId xmlns:a16="http://schemas.microsoft.com/office/drawing/2014/main" id="{35CA328C-C135-4AAD-A85A-9C8FF78CE576}"/>
               </a:ext>
             </a:extLst>
           </p:cNvPr>
@@ -3968,7 +3897,7 @@
           <p:cNvPr id="8" name="">
             <a:extLst xmlns:a="http://schemas.openxmlformats.org/drawingml/2006/main">
               <a:ext uri="{FF2B5EF4-FFF2-40B4-BE49-F238E27FC236}">
-                <a16:creationId xmlns:a16="http://schemas.microsoft.com/office/drawing/2014/main" id="{25A779DD-6D56-436E-B6C7-8354F90774AC}"/>
+                <a16:creationId xmlns:a16="http://schemas.microsoft.com/office/drawing/2014/main" id="{60E524E8-B5A9-4B28-BE7E-6ABFD25B67CA}"/>
               </a:ext>
             </a:extLst>
           </p:cNvPr>
@@ -4025,7 +3954,7 @@
           <p:cNvPr id="9" name="">
             <a:extLst xmlns:a="http://schemas.openxmlformats.org/drawingml/2006/main">
               <a:ext uri="{FF2B5EF4-FFF2-40B4-BE49-F238E27FC236}">
-                <a16:creationId xmlns:a16="http://schemas.microsoft.com/office/drawing/2014/main" id="{B26373D6-C1B6-4FCF-BC02-7C620BBDEA53}"/>
+                <a16:creationId xmlns:a16="http://schemas.microsoft.com/office/drawing/2014/main" id="{98D7EFC0-643A-4968-8933-22AE8A947FBB}"/>
               </a:ext>
             </a:extLst>
           </p:cNvPr>
@@ -4080,7 +4009,7 @@
     </p:spTree>
     <p:extLst>
       <p:ext uri="{BB962C8B-B14F-4D97-AF65-F5344CB8AC3E}">
-        <p14:creationId xmlns:p14="http://schemas.microsoft.com/office/powerpoint/2010/main" val="582496211"/>
+        <p14:creationId xmlns:p14="http://schemas.microsoft.com/office/powerpoint/2010/main" val="301690942"/>
       </p:ext>
     </p:extLst>
   </p:cSld>
@@ -4111,7 +4040,7 @@
           <p:cNvPr id="12" name="">
             <a:extLst xmlns:a="http://schemas.openxmlformats.org/drawingml/2006/main">
               <a:ext uri="{FF2B5EF4-FFF2-40B4-BE49-F238E27FC236}">
-                <a16:creationId xmlns:a16="http://schemas.microsoft.com/office/drawing/2014/main" id="{6646EDFB-7242-4228-A5FF-92D61F1A85A7}"/>
+                <a16:creationId xmlns:a16="http://schemas.microsoft.com/office/drawing/2014/main" id="{5902F4C6-3944-47E1-A994-A839E7800B67}"/>
               </a:ext>
             </a:extLst>
           </p:cNvPr>
@@ -4168,7 +4097,7 @@
           <p:cNvPr id="2" name="">
             <a:extLst xmlns:a="http://schemas.openxmlformats.org/drawingml/2006/main">
               <a:ext uri="{FF2B5EF4-FFF2-40B4-BE49-F238E27FC236}">
-                <a16:creationId xmlns:a16="http://schemas.microsoft.com/office/drawing/2014/main" id="{CA25F9C7-6904-49D5-AE29-92B66B95424F}"/>
+                <a16:creationId xmlns:a16="http://schemas.microsoft.com/office/drawing/2014/main" id="{C3B554A7-4CA8-4B98-A922-EB55E5B51715}"/>
               </a:ext>
             </a:extLst>
           </p:cNvPr>
@@ -4225,7 +4154,7 @@
           <p:cNvPr id="3" name="">
             <a:extLst xmlns:a="http://schemas.openxmlformats.org/drawingml/2006/main">
               <a:ext uri="{FF2B5EF4-FFF2-40B4-BE49-F238E27FC236}">
-                <a16:creationId xmlns:a16="http://schemas.microsoft.com/office/drawing/2014/main" id="{936976AE-D9E0-45AB-8ABA-12872B5A478B}"/>
+                <a16:creationId xmlns:a16="http://schemas.microsoft.com/office/drawing/2014/main" id="{3AD58F1E-F0B2-4D86-B3C8-0349ED74767B}"/>
               </a:ext>
             </a:extLst>
           </p:cNvPr>
@@ -4289,7 +4218,7 @@
         </p:xfrm>
         <a:graphic xmlns:a="http://schemas.openxmlformats.org/drawingml/2006/main">
           <a:graphicData uri="http://schemas.openxmlformats.org/drawingml/2006/chart">
-            <c:chart xmlns:r="http://schemas.openxmlformats.org/officeDocument/2006/relationships" xmlns:c="http://schemas.openxmlformats.org/drawingml/2006/chart" r:id="Rb334a7fe1bef434b"/>
+            <c:chart xmlns:r="http://schemas.openxmlformats.org/officeDocument/2006/relationships" xmlns:c="http://schemas.openxmlformats.org/drawingml/2006/chart" r:id="R835d0d0a984a4c85"/>
           </a:graphicData>
         </a:graphic>
       </p:graphicFrame>
@@ -4298,7 +4227,7 @@
           <p:cNvPr id="5" name="">
             <a:extLst xmlns:a="http://schemas.openxmlformats.org/drawingml/2006/main">
               <a:ext uri="{FF2B5EF4-FFF2-40B4-BE49-F238E27FC236}">
-                <a16:creationId xmlns:a16="http://schemas.microsoft.com/office/drawing/2014/main" id="{569FFE63-64E1-48EE-ABCE-8049F16AAC62}"/>
+                <a16:creationId xmlns:a16="http://schemas.microsoft.com/office/drawing/2014/main" id="{5FCCE02A-41FF-48F6-894F-7A308AB8653D}"/>
               </a:ext>
             </a:extLst>
           </p:cNvPr>
@@ -4355,7 +4284,7 @@
           <p:cNvPr id="6" name="">
             <a:extLst xmlns:a="http://schemas.openxmlformats.org/drawingml/2006/main">
               <a:ext uri="{FF2B5EF4-FFF2-40B4-BE49-F238E27FC236}">
-                <a16:creationId xmlns:a16="http://schemas.microsoft.com/office/drawing/2014/main" id="{FBF17A9F-5AC8-4156-9AA5-22E7F4F2776C}"/>
+                <a16:creationId xmlns:a16="http://schemas.microsoft.com/office/drawing/2014/main" id="{C554AFD4-3F51-49F6-940A-AEBCC06876C0}"/>
               </a:ext>
             </a:extLst>
           </p:cNvPr>
@@ -4412,7 +4341,7 @@
           <p:cNvPr id="7" name="">
             <a:extLst xmlns:a="http://schemas.openxmlformats.org/drawingml/2006/main">
               <a:ext uri="{FF2B5EF4-FFF2-40B4-BE49-F238E27FC236}">
-                <a16:creationId xmlns:a16="http://schemas.microsoft.com/office/drawing/2014/main" id="{E1C7C270-37B5-4C65-9223-BC5B736FFEB6}"/>
+                <a16:creationId xmlns:a16="http://schemas.microsoft.com/office/drawing/2014/main" id="{6CE28E4C-33EB-4075-BF04-8BA5D5183EFF}"/>
               </a:ext>
             </a:extLst>
           </p:cNvPr>
@@ -4469,7 +4398,7 @@
           <p:cNvPr id="8" name="">
             <a:extLst xmlns:a="http://schemas.openxmlformats.org/drawingml/2006/main">
               <a:ext uri="{FF2B5EF4-FFF2-40B4-BE49-F238E27FC236}">
-                <a16:creationId xmlns:a16="http://schemas.microsoft.com/office/drawing/2014/main" id="{67A556AF-8386-4F20-877C-ACDF4263B4A4}"/>
+                <a16:creationId xmlns:a16="http://schemas.microsoft.com/office/drawing/2014/main" id="{B1618EFF-B625-4E9C-B108-F344D2E01363}"/>
               </a:ext>
             </a:extLst>
           </p:cNvPr>
@@ -4526,7 +4455,7 @@
           <p:cNvPr id="9" name="">
             <a:extLst xmlns:a="http://schemas.openxmlformats.org/drawingml/2006/main">
               <a:ext uri="{FF2B5EF4-FFF2-40B4-BE49-F238E27FC236}">
-                <a16:creationId xmlns:a16="http://schemas.microsoft.com/office/drawing/2014/main" id="{A6061116-FFB8-4B63-802C-A218195A4C82}"/>
+                <a16:creationId xmlns:a16="http://schemas.microsoft.com/office/drawing/2014/main" id="{6166B76E-4477-4818-9154-AB3D976888C2}"/>
               </a:ext>
             </a:extLst>
           </p:cNvPr>
@@ -4583,7 +4512,7 @@
           <p:cNvPr id="10" name="">
             <a:extLst xmlns:a="http://schemas.openxmlformats.org/drawingml/2006/main">
               <a:ext uri="{FF2B5EF4-FFF2-40B4-BE49-F238E27FC236}">
-                <a16:creationId xmlns:a16="http://schemas.microsoft.com/office/drawing/2014/main" id="{788AE245-BFEA-4E54-AA71-6312E144A668}"/>
+                <a16:creationId xmlns:a16="http://schemas.microsoft.com/office/drawing/2014/main" id="{B5636275-27A7-45AD-B95F-776DD8D275AC}"/>
               </a:ext>
             </a:extLst>
           </p:cNvPr>
@@ -4640,7 +4569,7 @@
           <p:cNvPr id="11" name="">
             <a:extLst xmlns:a="http://schemas.openxmlformats.org/drawingml/2006/main">
               <a:ext uri="{FF2B5EF4-FFF2-40B4-BE49-F238E27FC236}">
-                <a16:creationId xmlns:a16="http://schemas.microsoft.com/office/drawing/2014/main" id="{EF805D47-EFB7-488F-AB11-FA3C8BAA0EB6}"/>
+                <a16:creationId xmlns:a16="http://schemas.microsoft.com/office/drawing/2014/main" id="{87DD987E-82B3-41E2-8FD9-B5C4D59B3733}"/>
               </a:ext>
             </a:extLst>
           </p:cNvPr>
@@ -4695,7 +4624,7 @@
     </p:spTree>
     <p:extLst>
       <p:ext uri="{BB962C8B-B14F-4D97-AF65-F5344CB8AC3E}">
-        <p14:creationId xmlns:p14="http://schemas.microsoft.com/office/powerpoint/2010/main" val="2019773801"/>
+        <p14:creationId xmlns:p14="http://schemas.microsoft.com/office/powerpoint/2010/main" val="187653203"/>
       </p:ext>
     </p:extLst>
   </p:cSld>
@@ -4726,7 +4655,7 @@
           <p:cNvPr id="10" name="">
             <a:extLst xmlns:a="http://schemas.openxmlformats.org/drawingml/2006/main">
               <a:ext uri="{FF2B5EF4-FFF2-40B4-BE49-F238E27FC236}">
-                <a16:creationId xmlns:a16="http://schemas.microsoft.com/office/drawing/2014/main" id="{D46B9AC7-93C4-4005-9B03-D35909E08292}"/>
+                <a16:creationId xmlns:a16="http://schemas.microsoft.com/office/drawing/2014/main" id="{ED61F578-1F7D-4D02-8841-ADF46B9CD4F1}"/>
               </a:ext>
             </a:extLst>
           </p:cNvPr>
@@ -4773,7 +4702,7 @@
                 <a:ea typeface="Heiti TC"/>
                 <a:cs typeface="Heiti TC"/>
               </a:rPr>
-              <a:t>錯誤訊息是提示，不是評分</a:t>
+              <a:t>這和 AI 有甚麼關係？</a:t>
             </a:r>
           </a:p>
         </p:txBody>
@@ -4783,7 +4712,7 @@
           <p:cNvPr id="2" name="">
             <a:extLst xmlns:a="http://schemas.openxmlformats.org/drawingml/2006/main">
               <a:ext uri="{FF2B5EF4-FFF2-40B4-BE49-F238E27FC236}">
-                <a16:creationId xmlns:a16="http://schemas.microsoft.com/office/drawing/2014/main" id="{C76A5106-ED8F-4BBA-8DCF-BBF7FAD32AF1}"/>
+                <a16:creationId xmlns:a16="http://schemas.microsoft.com/office/drawing/2014/main" id="{6987F08A-5179-4B26-BE7F-47F97E27DBA3}"/>
               </a:ext>
             </a:extLst>
           </p:cNvPr>
@@ -4830,7 +4759,7 @@
                 <a:ea typeface="Arial"/>
                 <a:cs typeface="Arial"/>
               </a:rPr>
-              <a:t>An error message is a clue, not a grade</a:t>
+              <a:t>How does this connect to AI?</a:t>
             </a:r>
           </a:p>
         </p:txBody>
@@ -4840,7 +4769,7 @@
           <p:cNvPr id="3" name="">
             <a:extLst xmlns:a="http://schemas.openxmlformats.org/drawingml/2006/main">
               <a:ext uri="{FF2B5EF4-FFF2-40B4-BE49-F238E27FC236}">
-                <a16:creationId xmlns:a16="http://schemas.microsoft.com/office/drawing/2014/main" id="{35095E8C-3C50-4168-9FE2-AD7A8D009A3A}"/>
+                <a16:creationId xmlns:a16="http://schemas.microsoft.com/office/drawing/2014/main" id="{3F2CD407-8877-4BBE-A50D-EE54E6E85974}"/>
               </a:ext>
             </a:extLst>
           </p:cNvPr>
@@ -4897,18 +4826,18 @@
           <p:cNvPr id="4" name="">
             <a:extLst xmlns:a="http://schemas.openxmlformats.org/drawingml/2006/main">
               <a:ext uri="{FF2B5EF4-FFF2-40B4-BE49-F238E27FC236}">
-                <a16:creationId xmlns:a16="http://schemas.microsoft.com/office/drawing/2014/main" id="{7D25AA02-D0B9-4E91-9944-0E39583BF91C}"/>
-              </a:ext>
-            </a:extLst>
-          </p:cNvPr>
-          <p:cNvSpPr>
-            <a:spLocks xmlns:a="http://schemas.openxmlformats.org/drawingml/2006/main" noGrp="1"/>
-          </p:cNvSpPr>
-          <p:nvPr/>
-        </p:nvSpPr>
-        <p:spPr>
-          <a:xfrm xmlns:a="http://schemas.openxmlformats.org/drawingml/2006/main">
-            <a:off x="609600" y="1809750"/>
+                <a16:creationId xmlns:a16="http://schemas.microsoft.com/office/drawing/2014/main" id="{ED285821-CB14-4C26-9349-18618D701F96}"/>
+              </a:ext>
+            </a:extLst>
+          </p:cNvPr>
+          <p:cNvSpPr>
+            <a:spLocks xmlns:a="http://schemas.openxmlformats.org/drawingml/2006/main" noGrp="1"/>
+          </p:cNvSpPr>
+          <p:nvPr/>
+        </p:nvSpPr>
+        <p:spPr>
+          <a:xfrm xmlns:a="http://schemas.openxmlformats.org/drawingml/2006/main">
+            <a:off x="609600" y="1714500"/>
             <a:ext cx="10668000" cy="495300"/>
           </a:xfrm>
           <a:prstGeom xmlns:a="http://schemas.openxmlformats.org/drawingml/2006/main" prst="rect">
@@ -4944,7 +4873,7 @@
                 <a:ea typeface="Heiti TC"/>
                 <a:cs typeface="Heiti TC"/>
               </a:rPr>
-              <a:t>先看最後一行提示，再檢查是否漏了逗號或引號</a:t>
+              <a:t>我們提供例子，工具從例子建立模型</a:t>
             </a:r>
           </a:p>
         </p:txBody>
@@ -4954,18 +4883,18 @@
           <p:cNvPr id="5" name="">
             <a:extLst xmlns:a="http://schemas.openxmlformats.org/drawingml/2006/main">
               <a:ext uri="{FF2B5EF4-FFF2-40B4-BE49-F238E27FC236}">
-                <a16:creationId xmlns:a16="http://schemas.microsoft.com/office/drawing/2014/main" id="{3C19C1AA-C206-4872-A763-B43F26B09664}"/>
-              </a:ext>
-            </a:extLst>
-          </p:cNvPr>
-          <p:cNvSpPr>
-            <a:spLocks xmlns:a="http://schemas.openxmlformats.org/drawingml/2006/main" noGrp="1"/>
-          </p:cNvSpPr>
-          <p:nvPr/>
-        </p:nvSpPr>
-        <p:spPr>
-          <a:xfrm xmlns:a="http://schemas.openxmlformats.org/drawingml/2006/main">
-            <a:off x="609600" y="2276475"/>
+                <a16:creationId xmlns:a16="http://schemas.microsoft.com/office/drawing/2014/main" id="{29BB6A0E-858D-467B-A356-61B041BC9C20}"/>
+              </a:ext>
+            </a:extLst>
+          </p:cNvPr>
+          <p:cNvSpPr>
+            <a:spLocks xmlns:a="http://schemas.openxmlformats.org/drawingml/2006/main" noGrp="1"/>
+          </p:cNvSpPr>
+          <p:nvPr/>
+        </p:nvSpPr>
+        <p:spPr>
+          <a:xfrm xmlns:a="http://schemas.openxmlformats.org/drawingml/2006/main">
+            <a:off x="609600" y="2181225"/>
             <a:ext cx="10668000" cy="457200"/>
           </a:xfrm>
           <a:prstGeom xmlns:a="http://schemas.openxmlformats.org/drawingml/2006/main" prst="rect">
@@ -5001,7 +4930,7 @@
                 <a:ea typeface="Arial"/>
                 <a:cs typeface="Arial"/>
               </a:rPr>
-              <a:t>Read the last clue. Check commas and quotes</a:t>
+              <a:t>We provide examples; the tool fits a model from them</a:t>
             </a:r>
           </a:p>
         </p:txBody>
@@ -5011,18 +4940,18 @@
           <p:cNvPr id="6" name="">
             <a:extLst xmlns:a="http://schemas.openxmlformats.org/drawingml/2006/main">
               <a:ext uri="{FF2B5EF4-FFF2-40B4-BE49-F238E27FC236}">
-                <a16:creationId xmlns:a16="http://schemas.microsoft.com/office/drawing/2014/main" id="{0328283E-5E84-446E-A8D6-A618CFE66766}"/>
-              </a:ext>
-            </a:extLst>
-          </p:cNvPr>
-          <p:cNvSpPr>
-            <a:spLocks xmlns:a="http://schemas.openxmlformats.org/drawingml/2006/main" noGrp="1"/>
-          </p:cNvSpPr>
-          <p:nvPr/>
-        </p:nvSpPr>
-        <p:spPr>
-          <a:xfrm xmlns:a="http://schemas.openxmlformats.org/drawingml/2006/main">
-            <a:off x="609600" y="3190875"/>
+                <a16:creationId xmlns:a16="http://schemas.microsoft.com/office/drawing/2014/main" id="{30F9801A-C74C-4C77-B39F-3AE56AC7C1DB}"/>
+              </a:ext>
+            </a:extLst>
+          </p:cNvPr>
+          <p:cNvSpPr>
+            <a:spLocks xmlns:a="http://schemas.openxmlformats.org/drawingml/2006/main" noGrp="1"/>
+          </p:cNvSpPr>
+          <p:nvPr/>
+        </p:nvSpPr>
+        <p:spPr>
+          <a:xfrm xmlns:a="http://schemas.openxmlformats.org/drawingml/2006/main">
+            <a:off x="609600" y="3057525"/>
             <a:ext cx="10668000" cy="495300"/>
           </a:xfrm>
           <a:prstGeom xmlns:a="http://schemas.openxmlformats.org/drawingml/2006/main" prst="rect">
@@ -5040,7 +4969,7 @@
           <a:lstStyle xmlns:a="http://schemas.openxmlformats.org/drawingml/2006/main"/>
           <a:p xmlns:a="http://schemas.openxmlformats.org/drawingml/2006/main">
             <a:pPr>
-              <a:defRPr sz="2400" b="0">
+              <a:defRPr sz="2550" b="0">
                 <a:solidFill>
                   <a:srgbClr val="173C43"/>
                 </a:solidFill>
@@ -5050,7 +4979,7 @@
               </a:defRPr>
             </a:pPr>
             <a:r>
-              <a:rPr sz="2400" b="0">
+              <a:rPr sz="2550" b="0">
                 <a:solidFill>
                   <a:srgbClr val="173C43"/>
                 </a:solidFill>
@@ -5058,7 +4987,7 @@
                 <a:ea typeface="Heiti TC"/>
                 <a:cs typeface="Heiti TC"/>
               </a:rPr>
-              <a:t>改過原數據？先重跑數據和建立模型的格子</a:t>
+              <a:t>改變數據，模型的預測可能改變</a:t>
             </a:r>
           </a:p>
         </p:txBody>
@@ -5068,18 +4997,18 @@
           <p:cNvPr id="7" name="">
             <a:extLst xmlns:a="http://schemas.openxmlformats.org/drawingml/2006/main">
               <a:ext uri="{FF2B5EF4-FFF2-40B4-BE49-F238E27FC236}">
-                <a16:creationId xmlns:a16="http://schemas.microsoft.com/office/drawing/2014/main" id="{9CAAD61A-ABBA-4F9D-8B77-6CE8555195B4}"/>
-              </a:ext>
-            </a:extLst>
-          </p:cNvPr>
-          <p:cNvSpPr>
-            <a:spLocks xmlns:a="http://schemas.openxmlformats.org/drawingml/2006/main" noGrp="1"/>
-          </p:cNvSpPr>
-          <p:nvPr/>
-        </p:nvSpPr>
-        <p:spPr>
-          <a:xfrm xmlns:a="http://schemas.openxmlformats.org/drawingml/2006/main">
-            <a:off x="609600" y="3657600"/>
+                <a16:creationId xmlns:a16="http://schemas.microsoft.com/office/drawing/2014/main" id="{12F4FF95-5CAA-4E3A-A92D-4F62F33815BB}"/>
+              </a:ext>
+            </a:extLst>
+          </p:cNvPr>
+          <p:cNvSpPr>
+            <a:spLocks xmlns:a="http://schemas.openxmlformats.org/drawingml/2006/main" noGrp="1"/>
+          </p:cNvSpPr>
+          <p:nvPr/>
+        </p:nvSpPr>
+        <p:spPr>
+          <a:xfrm xmlns:a="http://schemas.openxmlformats.org/drawingml/2006/main">
+            <a:off x="609600" y="3524250"/>
             <a:ext cx="10668000" cy="457200"/>
           </a:xfrm>
           <a:prstGeom xmlns:a="http://schemas.openxmlformats.org/drawingml/2006/main" prst="rect">
@@ -5097,25 +5026,25 @@
           <a:lstStyle xmlns:a="http://schemas.openxmlformats.org/drawingml/2006/main"/>
           <a:p xmlns:a="http://schemas.openxmlformats.org/drawingml/2006/main">
             <a:pPr>
-              <a:defRPr sz="1800" b="0">
-                <a:solidFill>
-                  <a:srgbClr val="526B70"/>
-                </a:solidFill>
-                <a:latin typeface="Arial"/>
-                <a:ea typeface="Arial"/>
-                <a:cs typeface="Arial"/>
-              </a:defRPr>
-            </a:pPr>
-            <a:r>
-              <a:rPr sz="1800" b="0">
-                <a:solidFill>
-                  <a:srgbClr val="526B70"/>
-                </a:solidFill>
-                <a:latin typeface="Arial"/>
-                <a:ea typeface="Arial"/>
-                <a:cs typeface="Arial"/>
-              </a:rPr>
-              <a:t>Edited the original data? Rerun the data and model cells first</a:t>
+              <a:defRPr sz="1950" b="0">
+                <a:solidFill>
+                  <a:srgbClr val="526B70"/>
+                </a:solidFill>
+                <a:latin typeface="Arial"/>
+                <a:ea typeface="Arial"/>
+                <a:cs typeface="Arial"/>
+              </a:defRPr>
+            </a:pPr>
+            <a:r>
+              <a:rPr sz="1950" b="0">
+                <a:solidFill>
+                  <a:srgbClr val="526B70"/>
+                </a:solidFill>
+                <a:latin typeface="Arial"/>
+                <a:ea typeface="Arial"/>
+                <a:cs typeface="Arial"/>
+              </a:rPr>
+              <a:t>Change the data, and predictions may change</a:t>
             </a:r>
           </a:p>
         </p:txBody>
@@ -5125,18 +5054,18 @@
           <p:cNvPr id="8" name="">
             <a:extLst xmlns:a="http://schemas.openxmlformats.org/drawingml/2006/main">
               <a:ext uri="{FF2B5EF4-FFF2-40B4-BE49-F238E27FC236}">
-                <a16:creationId xmlns:a16="http://schemas.microsoft.com/office/drawing/2014/main" id="{A5A845D8-66CC-4783-BEDF-55DA7A498CAA}"/>
-              </a:ext>
-            </a:extLst>
-          </p:cNvPr>
-          <p:cNvSpPr>
-            <a:spLocks xmlns:a="http://schemas.openxmlformats.org/drawingml/2006/main" noGrp="1"/>
-          </p:cNvSpPr>
-          <p:nvPr/>
-        </p:nvSpPr>
-        <p:spPr>
-          <a:xfrm xmlns:a="http://schemas.openxmlformats.org/drawingml/2006/main">
-            <a:off x="609600" y="4572000"/>
+                <a16:creationId xmlns:a16="http://schemas.microsoft.com/office/drawing/2014/main" id="{DF43549C-6CEB-436F-B765-0754F58102DB}"/>
+              </a:ext>
+            </a:extLst>
+          </p:cNvPr>
+          <p:cNvSpPr>
+            <a:spLocks xmlns:a="http://schemas.openxmlformats.org/drawingml/2006/main" noGrp="1"/>
+          </p:cNvSpPr>
+          <p:nvPr/>
+        </p:nvSpPr>
+        <p:spPr>
+          <a:xfrm xmlns:a="http://schemas.openxmlformats.org/drawingml/2006/main">
+            <a:off x="609600" y="4400550"/>
             <a:ext cx="10668000" cy="495300"/>
           </a:xfrm>
           <a:prstGeom xmlns:a="http://schemas.openxmlformats.org/drawingml/2006/main" prst="rect">
@@ -5154,7 +5083,7 @@
           <a:lstStyle xmlns:a="http://schemas.openxmlformats.org/drawingml/2006/main"/>
           <a:p xmlns:a="http://schemas.openxmlformats.org/drawingml/2006/main">
             <a:pPr>
-              <a:defRPr sz="2400" b="0">
+              <a:defRPr sz="2550" b="0">
                 <a:solidFill>
                   <a:srgbClr val="173C43"/>
                 </a:solidFill>
@@ -5164,7 +5093,7 @@
               </a:defRPr>
             </a:pPr>
             <a:r>
-              <a:rPr sz="2400" b="0">
+              <a:rPr sz="2550" b="0">
                 <a:solidFill>
                   <a:srgbClr val="173C43"/>
                 </a:solidFill>
@@ -5172,7 +5101,7 @@
                 <a:ea typeface="Heiti TC"/>
                 <a:cs typeface="Heiti TC"/>
               </a:rPr>
-              <a:t>不必亂改。先復原剛才的改動，或請同伴／老師幫忙</a:t>
+              <a:t>程式能執行，不代表模型的答案一定正確</a:t>
             </a:r>
           </a:p>
         </p:txBody>
@@ -5182,18 +5111,18 @@
           <p:cNvPr id="9" name="">
             <a:extLst xmlns:a="http://schemas.openxmlformats.org/drawingml/2006/main">
               <a:ext uri="{FF2B5EF4-FFF2-40B4-BE49-F238E27FC236}">
-                <a16:creationId xmlns:a16="http://schemas.microsoft.com/office/drawing/2014/main" id="{7BECB683-D7EB-4B9E-9237-B572D14D2F38}"/>
-              </a:ext>
-            </a:extLst>
-          </p:cNvPr>
-          <p:cNvSpPr>
-            <a:spLocks xmlns:a="http://schemas.openxmlformats.org/drawingml/2006/main" noGrp="1"/>
-          </p:cNvSpPr>
-          <p:nvPr/>
-        </p:nvSpPr>
-        <p:spPr>
-          <a:xfrm xmlns:a="http://schemas.openxmlformats.org/drawingml/2006/main">
-            <a:off x="609600" y="5038725"/>
+                <a16:creationId xmlns:a16="http://schemas.microsoft.com/office/drawing/2014/main" id="{18111820-0BD1-4EC0-BF8A-1A37978BF450}"/>
+              </a:ext>
+            </a:extLst>
+          </p:cNvPr>
+          <p:cNvSpPr>
+            <a:spLocks xmlns:a="http://schemas.openxmlformats.org/drawingml/2006/main" noGrp="1"/>
+          </p:cNvSpPr>
+          <p:nvPr/>
+        </p:nvSpPr>
+        <p:spPr>
+          <a:xfrm xmlns:a="http://schemas.openxmlformats.org/drawingml/2006/main">
+            <a:off x="609600" y="4867275"/>
             <a:ext cx="10668000" cy="457200"/>
           </a:xfrm>
           <a:prstGeom xmlns:a="http://schemas.openxmlformats.org/drawingml/2006/main" prst="rect">
@@ -5211,25 +5140,25 @@
           <a:lstStyle xmlns:a="http://schemas.openxmlformats.org/drawingml/2006/main"/>
           <a:p xmlns:a="http://schemas.openxmlformats.org/drawingml/2006/main">
             <a:pPr>
-              <a:defRPr sz="1800" b="0">
-                <a:solidFill>
-                  <a:srgbClr val="526B70"/>
-                </a:solidFill>
-                <a:latin typeface="Arial"/>
-                <a:ea typeface="Arial"/>
-                <a:cs typeface="Arial"/>
-              </a:defRPr>
-            </a:pPr>
-            <a:r>
-              <a:rPr sz="1800" b="0">
-                <a:solidFill>
-                  <a:srgbClr val="526B70"/>
-                </a:solidFill>
-                <a:latin typeface="Arial"/>
-                <a:ea typeface="Arial"/>
-                <a:cs typeface="Arial"/>
-              </a:rPr>
-              <a:t>Avoid random edits. Undo your last change or ask for help</a:t>
+              <a:defRPr sz="1950" b="0">
+                <a:solidFill>
+                  <a:srgbClr val="526B70"/>
+                </a:solidFill>
+                <a:latin typeface="Arial"/>
+                <a:ea typeface="Arial"/>
+                <a:cs typeface="Arial"/>
+              </a:defRPr>
+            </a:pPr>
+            <a:r>
+              <a:rPr sz="1950" b="0">
+                <a:solidFill>
+                  <a:srgbClr val="526B70"/>
+                </a:solidFill>
+                <a:latin typeface="Arial"/>
+                <a:ea typeface="Arial"/>
+                <a:cs typeface="Arial"/>
+              </a:rPr>
+              <a:t>Working code does not guarantee a correct prediction</a:t>
             </a:r>
           </a:p>
         </p:txBody>
@@ -5237,7 +5166,7 @@
     </p:spTree>
     <p:extLst>
       <p:ext uri="{BB962C8B-B14F-4D97-AF65-F5344CB8AC3E}">
-        <p14:creationId xmlns:p14="http://schemas.microsoft.com/office/powerpoint/2010/main" val="1920475472"/>
+        <p14:creationId xmlns:p14="http://schemas.microsoft.com/office/powerpoint/2010/main" val="1097599158"/>
       </p:ext>
     </p:extLst>
   </p:cSld>
@@ -5268,7 +5197,7 @@
           <p:cNvPr id="10" name="">
             <a:extLst xmlns:a="http://schemas.openxmlformats.org/drawingml/2006/main">
               <a:ext uri="{FF2B5EF4-FFF2-40B4-BE49-F238E27FC236}">
-                <a16:creationId xmlns:a16="http://schemas.microsoft.com/office/drawing/2014/main" id="{70314CC9-FD8C-4136-94E1-60A036B2AE89}"/>
+                <a16:creationId xmlns:a16="http://schemas.microsoft.com/office/drawing/2014/main" id="{719B08EA-4123-42CF-840D-F9A9AD396067}"/>
               </a:ext>
             </a:extLst>
           </p:cNvPr>
@@ -5315,7 +5244,7 @@
                 <a:ea typeface="Heiti TC"/>
                 <a:cs typeface="Heiti TC"/>
               </a:rPr>
-              <a:t>這和 AI 有甚麼關係？</a:t>
+              <a:t>分享你的觀察</a:t>
             </a:r>
           </a:p>
         </p:txBody>
@@ -5325,7 +5254,7 @@
           <p:cNvPr id="2" name="">
             <a:extLst xmlns:a="http://schemas.openxmlformats.org/drawingml/2006/main">
               <a:ext uri="{FF2B5EF4-FFF2-40B4-BE49-F238E27FC236}">
-                <a16:creationId xmlns:a16="http://schemas.microsoft.com/office/drawing/2014/main" id="{834C12A5-EF7A-4646-8FE3-1D1A33ECB93B}"/>
+                <a16:creationId xmlns:a16="http://schemas.microsoft.com/office/drawing/2014/main" id="{01117647-6BE9-4D29-AD16-6B3F4D868BCD}"/>
               </a:ext>
             </a:extLst>
           </p:cNvPr>
@@ -5372,7 +5301,7 @@
                 <a:ea typeface="Arial"/>
                 <a:cs typeface="Arial"/>
               </a:rPr>
-              <a:t>How does this connect to AI?</a:t>
+              <a:t>Share your observations</a:t>
             </a:r>
           </a:p>
         </p:txBody>
@@ -5382,7 +5311,7 @@
           <p:cNvPr id="3" name="">
             <a:extLst xmlns:a="http://schemas.openxmlformats.org/drawingml/2006/main">
               <a:ext uri="{FF2B5EF4-FFF2-40B4-BE49-F238E27FC236}">
-                <a16:creationId xmlns:a16="http://schemas.microsoft.com/office/drawing/2014/main" id="{822E28CD-8D8A-44F3-9984-F6DFAFC5F854}"/>
+                <a16:creationId xmlns:a16="http://schemas.microsoft.com/office/drawing/2014/main" id="{A9B5C66F-76A2-4931-91D1-DB2A523EB603}"/>
               </a:ext>
             </a:extLst>
           </p:cNvPr>
@@ -5439,18 +5368,18 @@
           <p:cNvPr id="4" name="">
             <a:extLst xmlns:a="http://schemas.openxmlformats.org/drawingml/2006/main">
               <a:ext uri="{FF2B5EF4-FFF2-40B4-BE49-F238E27FC236}">
-                <a16:creationId xmlns:a16="http://schemas.microsoft.com/office/drawing/2014/main" id="{232C62AC-80F4-4545-B6E9-FC1E51C90800}"/>
-              </a:ext>
-            </a:extLst>
-          </p:cNvPr>
-          <p:cNvSpPr>
-            <a:spLocks xmlns:a="http://schemas.openxmlformats.org/drawingml/2006/main" noGrp="1"/>
-          </p:cNvSpPr>
-          <p:nvPr/>
-        </p:nvSpPr>
-        <p:spPr>
-          <a:xfrm xmlns:a="http://schemas.openxmlformats.org/drawingml/2006/main">
-            <a:off x="609600" y="1714500"/>
+                <a16:creationId xmlns:a16="http://schemas.microsoft.com/office/drawing/2014/main" id="{6B541F46-AA0F-414E-ACF0-F1F8CE9EB3BB}"/>
+              </a:ext>
+            </a:extLst>
+          </p:cNvPr>
+          <p:cNvSpPr>
+            <a:spLocks xmlns:a="http://schemas.openxmlformats.org/drawingml/2006/main" noGrp="1"/>
+          </p:cNvSpPr>
+          <p:nvPr/>
+        </p:nvSpPr>
+        <p:spPr>
+          <a:xfrm xmlns:a="http://schemas.openxmlformats.org/drawingml/2006/main">
+            <a:off x="609600" y="1809750"/>
             <a:ext cx="10668000" cy="495300"/>
           </a:xfrm>
           <a:prstGeom xmlns:a="http://schemas.openxmlformats.org/drawingml/2006/main" prst="rect">
@@ -5468,7 +5397,7 @@
           <a:lstStyle xmlns:a="http://schemas.openxmlformats.org/drawingml/2006/main"/>
           <a:p xmlns:a="http://schemas.openxmlformats.org/drawingml/2006/main">
             <a:pPr>
-              <a:defRPr sz="2475" b="0">
+              <a:defRPr sz="2625" b="0">
                 <a:solidFill>
                   <a:srgbClr val="173C43"/>
                 </a:solidFill>
@@ -5478,7 +5407,7 @@
               </a:defRPr>
             </a:pPr>
             <a:r>
-              <a:rPr sz="2475" b="0">
+              <a:rPr sz="2625" b="0">
                 <a:solidFill>
                   <a:srgbClr val="173C43"/>
                 </a:solidFill>
@@ -5486,7 +5415,7 @@
                 <a:ea typeface="Heiti TC"/>
                 <a:cs typeface="Heiti TC"/>
               </a:rPr>
-              <a:t>我們提供例子，工具從例子建立模型</a:t>
+              <a:t>加入新點後，直線或預測有甚麼改變？</a:t>
             </a:r>
           </a:p>
         </p:txBody>
@@ -5496,18 +5425,18 @@
           <p:cNvPr id="5" name="">
             <a:extLst xmlns:a="http://schemas.openxmlformats.org/drawingml/2006/main">
               <a:ext uri="{FF2B5EF4-FFF2-40B4-BE49-F238E27FC236}">
-                <a16:creationId xmlns:a16="http://schemas.microsoft.com/office/drawing/2014/main" id="{EDAEFC4B-1C7A-495A-8F90-5FE35DBB0773}"/>
-              </a:ext>
-            </a:extLst>
-          </p:cNvPr>
-          <p:cNvSpPr>
-            <a:spLocks xmlns:a="http://schemas.openxmlformats.org/drawingml/2006/main" noGrp="1"/>
-          </p:cNvSpPr>
-          <p:nvPr/>
-        </p:nvSpPr>
-        <p:spPr>
-          <a:xfrm xmlns:a="http://schemas.openxmlformats.org/drawingml/2006/main">
-            <a:off x="609600" y="2181225"/>
+                <a16:creationId xmlns:a16="http://schemas.microsoft.com/office/drawing/2014/main" id="{11F02D0B-694B-440E-885B-FA5A0EDD3D7F}"/>
+              </a:ext>
+            </a:extLst>
+          </p:cNvPr>
+          <p:cNvSpPr>
+            <a:spLocks xmlns:a="http://schemas.openxmlformats.org/drawingml/2006/main" noGrp="1"/>
+          </p:cNvSpPr>
+          <p:nvPr/>
+        </p:nvSpPr>
+        <p:spPr>
+          <a:xfrm xmlns:a="http://schemas.openxmlformats.org/drawingml/2006/main">
+            <a:off x="609600" y="2276475"/>
             <a:ext cx="10668000" cy="457200"/>
           </a:xfrm>
           <a:prstGeom xmlns:a="http://schemas.openxmlformats.org/drawingml/2006/main" prst="rect">
@@ -5525,25 +5454,25 @@
           <a:lstStyle xmlns:a="http://schemas.openxmlformats.org/drawingml/2006/main"/>
           <a:p xmlns:a="http://schemas.openxmlformats.org/drawingml/2006/main">
             <a:pPr>
-              <a:defRPr sz="1875" b="0">
-                <a:solidFill>
-                  <a:srgbClr val="526B70"/>
-                </a:solidFill>
-                <a:latin typeface="Arial"/>
-                <a:ea typeface="Arial"/>
-                <a:cs typeface="Arial"/>
-              </a:defRPr>
-            </a:pPr>
-            <a:r>
-              <a:rPr sz="1875" b="0">
-                <a:solidFill>
-                  <a:srgbClr val="526B70"/>
-                </a:solidFill>
-                <a:latin typeface="Arial"/>
-                <a:ea typeface="Arial"/>
-                <a:cs typeface="Arial"/>
-              </a:rPr>
-              <a:t>We provide examples; the tool fits a model from them</a:t>
+              <a:defRPr sz="2025" b="0">
+                <a:solidFill>
+                  <a:srgbClr val="526B70"/>
+                </a:solidFill>
+                <a:latin typeface="Arial"/>
+                <a:ea typeface="Arial"/>
+                <a:cs typeface="Arial"/>
+              </a:defRPr>
+            </a:pPr>
+            <a:r>
+              <a:rPr sz="2025" b="0">
+                <a:solidFill>
+                  <a:srgbClr val="526B70"/>
+                </a:solidFill>
+                <a:latin typeface="Arial"/>
+                <a:ea typeface="Arial"/>
+                <a:cs typeface="Arial"/>
+              </a:rPr>
+              <a:t>How did the line or prediction change after adding the point?</a:t>
             </a:r>
           </a:p>
         </p:txBody>
@@ -5553,18 +5482,18 @@
           <p:cNvPr id="6" name="">
             <a:extLst xmlns:a="http://schemas.openxmlformats.org/drawingml/2006/main">
               <a:ext uri="{FF2B5EF4-FFF2-40B4-BE49-F238E27FC236}">
-                <a16:creationId xmlns:a16="http://schemas.microsoft.com/office/drawing/2014/main" id="{E601EAE2-5F13-4096-9E9D-769B341AD34F}"/>
-              </a:ext>
-            </a:extLst>
-          </p:cNvPr>
-          <p:cNvSpPr>
-            <a:spLocks xmlns:a="http://schemas.openxmlformats.org/drawingml/2006/main" noGrp="1"/>
-          </p:cNvSpPr>
-          <p:nvPr/>
-        </p:nvSpPr>
-        <p:spPr>
-          <a:xfrm xmlns:a="http://schemas.openxmlformats.org/drawingml/2006/main">
-            <a:off x="609600" y="3057525"/>
+                <a16:creationId xmlns:a16="http://schemas.microsoft.com/office/drawing/2014/main" id="{A9A57C2F-1FDA-4C2E-9730-7503B530C198}"/>
+              </a:ext>
+            </a:extLst>
+          </p:cNvPr>
+          <p:cNvSpPr>
+            <a:spLocks xmlns:a="http://schemas.openxmlformats.org/drawingml/2006/main" noGrp="1"/>
+          </p:cNvSpPr>
+          <p:nvPr/>
+        </p:nvSpPr>
+        <p:spPr>
+          <a:xfrm xmlns:a="http://schemas.openxmlformats.org/drawingml/2006/main">
+            <a:off x="609600" y="3190875"/>
             <a:ext cx="10668000" cy="495300"/>
           </a:xfrm>
           <a:prstGeom xmlns:a="http://schemas.openxmlformats.org/drawingml/2006/main" prst="rect">
@@ -5582,7 +5511,7 @@
           <a:lstStyle xmlns:a="http://schemas.openxmlformats.org/drawingml/2006/main"/>
           <a:p xmlns:a="http://schemas.openxmlformats.org/drawingml/2006/main">
             <a:pPr>
-              <a:defRPr sz="2550" b="0">
+              <a:defRPr sz="2625" b="0">
                 <a:solidFill>
                   <a:srgbClr val="173C43"/>
                 </a:solidFill>
@@ -5592,7 +5521,7 @@
               </a:defRPr>
             </a:pPr>
             <a:r>
-              <a:rPr sz="2550" b="0">
+              <a:rPr sz="2625" b="0">
                 <a:solidFill>
                   <a:srgbClr val="173C43"/>
                 </a:solidFill>
@@ -5600,7 +5529,7 @@
                 <a:ea typeface="Heiti TC"/>
                 <a:cs typeface="Heiti TC"/>
               </a:rPr>
-              <a:t>改變數據，模型的預測可能改變</a:t>
+              <a:t>3.5 小時和 10 小時的預測，哪個較值得信賴？</a:t>
             </a:r>
           </a:p>
         </p:txBody>
@@ -5610,18 +5539,18 @@
           <p:cNvPr id="7" name="">
             <a:extLst xmlns:a="http://schemas.openxmlformats.org/drawingml/2006/main">
               <a:ext uri="{FF2B5EF4-FFF2-40B4-BE49-F238E27FC236}">
-                <a16:creationId xmlns:a16="http://schemas.microsoft.com/office/drawing/2014/main" id="{5A9571A7-D151-42EA-9E25-9D366DD90E53}"/>
-              </a:ext>
-            </a:extLst>
-          </p:cNvPr>
-          <p:cNvSpPr>
-            <a:spLocks xmlns:a="http://schemas.openxmlformats.org/drawingml/2006/main" noGrp="1"/>
-          </p:cNvSpPr>
-          <p:nvPr/>
-        </p:nvSpPr>
-        <p:spPr>
-          <a:xfrm xmlns:a="http://schemas.openxmlformats.org/drawingml/2006/main">
-            <a:off x="609600" y="3524250"/>
+                <a16:creationId xmlns:a16="http://schemas.microsoft.com/office/drawing/2014/main" id="{BA19D4D8-8203-4DA7-A116-0A3EEE5D955D}"/>
+              </a:ext>
+            </a:extLst>
+          </p:cNvPr>
+          <p:cNvSpPr>
+            <a:spLocks xmlns:a="http://schemas.openxmlformats.org/drawingml/2006/main" noGrp="1"/>
+          </p:cNvSpPr>
+          <p:nvPr/>
+        </p:nvSpPr>
+        <p:spPr>
+          <a:xfrm xmlns:a="http://schemas.openxmlformats.org/drawingml/2006/main">
+            <a:off x="609600" y="3657600"/>
             <a:ext cx="10668000" cy="457200"/>
           </a:xfrm>
           <a:prstGeom xmlns:a="http://schemas.openxmlformats.org/drawingml/2006/main" prst="rect">
@@ -5639,25 +5568,25 @@
           <a:lstStyle xmlns:a="http://schemas.openxmlformats.org/drawingml/2006/main"/>
           <a:p xmlns:a="http://schemas.openxmlformats.org/drawingml/2006/main">
             <a:pPr>
-              <a:defRPr sz="1950" b="0">
-                <a:solidFill>
-                  <a:srgbClr val="526B70"/>
-                </a:solidFill>
-                <a:latin typeface="Arial"/>
-                <a:ea typeface="Arial"/>
-                <a:cs typeface="Arial"/>
-              </a:defRPr>
-            </a:pPr>
-            <a:r>
-              <a:rPr sz="1950" b="0">
-                <a:solidFill>
-                  <a:srgbClr val="526B70"/>
-                </a:solidFill>
-                <a:latin typeface="Arial"/>
-                <a:ea typeface="Arial"/>
-                <a:cs typeface="Arial"/>
-              </a:rPr>
-              <a:t>Change the data, and predictions may change</a:t>
+              <a:defRPr sz="2025" b="0">
+                <a:solidFill>
+                  <a:srgbClr val="526B70"/>
+                </a:solidFill>
+                <a:latin typeface="Arial"/>
+                <a:ea typeface="Arial"/>
+                <a:cs typeface="Arial"/>
+              </a:defRPr>
+            </a:pPr>
+            <a:r>
+              <a:rPr sz="2025" b="0">
+                <a:solidFill>
+                  <a:srgbClr val="526B70"/>
+                </a:solidFill>
+                <a:latin typeface="Arial"/>
+                <a:ea typeface="Arial"/>
+                <a:cs typeface="Arial"/>
+              </a:rPr>
+              <a:t>Which prediction is more trustworthy: 3.5 or 10 hours?</a:t>
             </a:r>
           </a:p>
         </p:txBody>
@@ -5667,18 +5596,18 @@
           <p:cNvPr id="8" name="">
             <a:extLst xmlns:a="http://schemas.openxmlformats.org/drawingml/2006/main">
               <a:ext uri="{FF2B5EF4-FFF2-40B4-BE49-F238E27FC236}">
-                <a16:creationId xmlns:a16="http://schemas.microsoft.com/office/drawing/2014/main" id="{C9A01980-7817-4082-A343-544D4FC268E3}"/>
-              </a:ext>
-            </a:extLst>
-          </p:cNvPr>
-          <p:cNvSpPr>
-            <a:spLocks xmlns:a="http://schemas.openxmlformats.org/drawingml/2006/main" noGrp="1"/>
-          </p:cNvSpPr>
-          <p:nvPr/>
-        </p:nvSpPr>
-        <p:spPr>
-          <a:xfrm xmlns:a="http://schemas.openxmlformats.org/drawingml/2006/main">
-            <a:off x="609600" y="4400550"/>
+                <a16:creationId xmlns:a16="http://schemas.microsoft.com/office/drawing/2014/main" id="{5D9589DB-016D-49A4-8A82-E48D004D0FB5}"/>
+              </a:ext>
+            </a:extLst>
+          </p:cNvPr>
+          <p:cNvSpPr>
+            <a:spLocks xmlns:a="http://schemas.openxmlformats.org/drawingml/2006/main" noGrp="1"/>
+          </p:cNvSpPr>
+          <p:nvPr/>
+        </p:nvSpPr>
+        <p:spPr>
+          <a:xfrm xmlns:a="http://schemas.openxmlformats.org/drawingml/2006/main">
+            <a:off x="609600" y="4572000"/>
             <a:ext cx="10668000" cy="495300"/>
           </a:xfrm>
           <a:prstGeom xmlns:a="http://schemas.openxmlformats.org/drawingml/2006/main" prst="rect">
@@ -5696,7 +5625,7 @@
           <a:lstStyle xmlns:a="http://schemas.openxmlformats.org/drawingml/2006/main"/>
           <a:p xmlns:a="http://schemas.openxmlformats.org/drawingml/2006/main">
             <a:pPr>
-              <a:defRPr sz="2550" b="0">
+              <a:defRPr sz="2325" b="0">
                 <a:solidFill>
                   <a:srgbClr val="173C43"/>
                 </a:solidFill>
@@ -5706,7 +5635,7 @@
               </a:defRPr>
             </a:pPr>
             <a:r>
-              <a:rPr sz="2550" b="0">
+              <a:rPr sz="2325" b="0">
                 <a:solidFill>
                   <a:srgbClr val="173C43"/>
                 </a:solidFill>
@@ -5714,7 +5643,7 @@
                 <a:ea typeface="Heiti TC"/>
                 <a:cs typeface="Heiti TC"/>
               </a:rPr>
-              <a:t>程式能執行，不代表模型的答案一定正確</a:t>
+              <a:t>下一堂：讓電腦猜「是哪一類」，而不是「幾多分」</a:t>
             </a:r>
           </a:p>
         </p:txBody>
@@ -5724,18 +5653,18 @@
           <p:cNvPr id="9" name="">
             <a:extLst xmlns:a="http://schemas.openxmlformats.org/drawingml/2006/main">
               <a:ext uri="{FF2B5EF4-FFF2-40B4-BE49-F238E27FC236}">
-                <a16:creationId xmlns:a16="http://schemas.microsoft.com/office/drawing/2014/main" id="{78E68BEE-C0E0-44A4-8394-8C75955BC4E1}"/>
-              </a:ext>
-            </a:extLst>
-          </p:cNvPr>
-          <p:cNvSpPr>
-            <a:spLocks xmlns:a="http://schemas.openxmlformats.org/drawingml/2006/main" noGrp="1"/>
-          </p:cNvSpPr>
-          <p:nvPr/>
-        </p:nvSpPr>
-        <p:spPr>
-          <a:xfrm xmlns:a="http://schemas.openxmlformats.org/drawingml/2006/main">
-            <a:off x="609600" y="4867275"/>
+                <a16:creationId xmlns:a16="http://schemas.microsoft.com/office/drawing/2014/main" id="{2070EF26-CB0F-474B-8F27-2E87C5A031E5}"/>
+              </a:ext>
+            </a:extLst>
+          </p:cNvPr>
+          <p:cNvSpPr>
+            <a:spLocks xmlns:a="http://schemas.openxmlformats.org/drawingml/2006/main" noGrp="1"/>
+          </p:cNvSpPr>
+          <p:nvPr/>
+        </p:nvSpPr>
+        <p:spPr>
+          <a:xfrm xmlns:a="http://schemas.openxmlformats.org/drawingml/2006/main">
+            <a:off x="609600" y="5038725"/>
             <a:ext cx="10668000" cy="457200"/>
           </a:xfrm>
           <a:prstGeom xmlns:a="http://schemas.openxmlformats.org/drawingml/2006/main" prst="rect">
@@ -5753,25 +5682,25 @@
           <a:lstStyle xmlns:a="http://schemas.openxmlformats.org/drawingml/2006/main"/>
           <a:p xmlns:a="http://schemas.openxmlformats.org/drawingml/2006/main">
             <a:pPr>
-              <a:defRPr sz="1950" b="0">
-                <a:solidFill>
-                  <a:srgbClr val="526B70"/>
-                </a:solidFill>
-                <a:latin typeface="Arial"/>
-                <a:ea typeface="Arial"/>
-                <a:cs typeface="Arial"/>
-              </a:defRPr>
-            </a:pPr>
-            <a:r>
-              <a:rPr sz="1950" b="0">
-                <a:solidFill>
-                  <a:srgbClr val="526B70"/>
-                </a:solidFill>
-                <a:latin typeface="Arial"/>
-                <a:ea typeface="Arial"/>
-                <a:cs typeface="Arial"/>
-              </a:rPr>
-              <a:t>Working code does not guarantee a correct prediction</a:t>
+              <a:defRPr sz="1800" b="0">
+                <a:solidFill>
+                  <a:srgbClr val="526B70"/>
+                </a:solidFill>
+                <a:latin typeface="Arial"/>
+                <a:ea typeface="Arial"/>
+                <a:cs typeface="Arial"/>
+              </a:defRPr>
+            </a:pPr>
+            <a:r>
+              <a:rPr sz="1800" b="0">
+                <a:solidFill>
+                  <a:srgbClr val="526B70"/>
+                </a:solidFill>
+                <a:latin typeface="Arial"/>
+                <a:ea typeface="Arial"/>
+                <a:cs typeface="Arial"/>
+              </a:rPr>
+              <a:t>Next time: predict which class, instead of how many marks</a:t>
             </a:r>
           </a:p>
         </p:txBody>
@@ -5779,549 +5708,7 @@
     </p:spTree>
     <p:extLst>
       <p:ext uri="{BB962C8B-B14F-4D97-AF65-F5344CB8AC3E}">
-        <p14:creationId xmlns:p14="http://schemas.microsoft.com/office/powerpoint/2010/main" val="1464759993"/>
-      </p:ext>
-    </p:extLst>
-  </p:cSld>
-</p:sld>
-</file>
-
-<file path=ppt/slides/slide14.xml><?xml version="1.0" encoding="utf-8"?>
-<p:sld xmlns:p="http://schemas.openxmlformats.org/presentationml/2006/main">
-  <p:cSld>
-    <p:bg>
-      <p:bgPr>
-        <a:solidFill xmlns:a="http://schemas.openxmlformats.org/drawingml/2006/main">
-          <a:srgbClr val="F5F7F4"/>
-        </a:solidFill>
-      </p:bgPr>
-    </p:bg>
-    <p:spTree>
-      <p:nvGrpSpPr>
-        <p:cNvPr id="1" name=""/>
-        <p:cNvGrpSpPr/>
-        <p:nvPr/>
-      </p:nvGrpSpPr>
-      <p:grpSpPr>
-        <a:xfrm xmlns:a="http://schemas.openxmlformats.org/drawingml/2006/main"/>
-      </p:grpSpPr>
-      <p:sp>
-        <p:nvSpPr>
-          <p:cNvPr id="10" name="">
-            <a:extLst xmlns:a="http://schemas.openxmlformats.org/drawingml/2006/main">
-              <a:ext uri="{FF2B5EF4-FFF2-40B4-BE49-F238E27FC236}">
-                <a16:creationId xmlns:a16="http://schemas.microsoft.com/office/drawing/2014/main" id="{E30AF659-7B84-4DA5-9FED-576D6FDA8D44}"/>
-              </a:ext>
-            </a:extLst>
-          </p:cNvPr>
-          <p:cNvSpPr>
-            <a:spLocks xmlns:a="http://schemas.openxmlformats.org/drawingml/2006/main" noGrp="1"/>
-          </p:cNvSpPr>
-          <p:nvPr/>
-        </p:nvSpPr>
-        <p:spPr>
-          <a:xfrm xmlns:a="http://schemas.openxmlformats.org/drawingml/2006/main">
-            <a:off x="609600" y="400050"/>
-            <a:ext cx="10972800" cy="495300"/>
-          </a:xfrm>
-          <a:prstGeom xmlns:a="http://schemas.openxmlformats.org/drawingml/2006/main" prst="rect">
-            <a:avLst/>
-          </a:prstGeom>
-          <a:noFill xmlns:a="http://schemas.openxmlformats.org/drawingml/2006/main"/>
-          <a:ln xmlns:a="http://schemas.openxmlformats.org/drawingml/2006/main" w="0">
-            <a:noFill/>
-          </a:ln>
-        </p:spPr>
-        <p:txBody>
-          <a:bodyPr xmlns:a="http://schemas.openxmlformats.org/drawingml/2006/main">
-            <a:noAutofit/>
-          </a:bodyPr>
-          <a:lstStyle xmlns:a="http://schemas.openxmlformats.org/drawingml/2006/main"/>
-          <a:p xmlns:a="http://schemas.openxmlformats.org/drawingml/2006/main">
-            <a:pPr>
-              <a:defRPr sz="3300" b="0">
-                <a:solidFill>
-                  <a:srgbClr val="173C43"/>
-                </a:solidFill>
-                <a:latin typeface="Heiti TC"/>
-                <a:ea typeface="Heiti TC"/>
-                <a:cs typeface="Heiti TC"/>
-              </a:defRPr>
-            </a:pPr>
-            <a:r>
-              <a:rPr sz="3300" b="0">
-                <a:solidFill>
-                  <a:srgbClr val="173C43"/>
-                </a:solidFill>
-                <a:latin typeface="Heiti TC"/>
-                <a:ea typeface="Heiti TC"/>
-                <a:cs typeface="Heiti TC"/>
-              </a:rPr>
-              <a:t>把你的發現交給下一位偵探</a:t>
-            </a:r>
-          </a:p>
-        </p:txBody>
-      </p:sp>
-      <p:sp>
-        <p:nvSpPr>
-          <p:cNvPr id="2" name="">
-            <a:extLst xmlns:a="http://schemas.openxmlformats.org/drawingml/2006/main">
-              <a:ext uri="{FF2B5EF4-FFF2-40B4-BE49-F238E27FC236}">
-                <a16:creationId xmlns:a16="http://schemas.microsoft.com/office/drawing/2014/main" id="{CE81F1F5-EF88-4964-8134-F46151B6154E}"/>
-              </a:ext>
-            </a:extLst>
-          </p:cNvPr>
-          <p:cNvSpPr>
-            <a:spLocks xmlns:a="http://schemas.openxmlformats.org/drawingml/2006/main" noGrp="1"/>
-          </p:cNvSpPr>
-          <p:nvPr/>
-        </p:nvSpPr>
-        <p:spPr>
-          <a:xfrm xmlns:a="http://schemas.openxmlformats.org/drawingml/2006/main">
-            <a:off x="609600" y="866775"/>
-            <a:ext cx="10972800" cy="457200"/>
-          </a:xfrm>
-          <a:prstGeom xmlns:a="http://schemas.openxmlformats.org/drawingml/2006/main" prst="rect">
-            <a:avLst/>
-          </a:prstGeom>
-          <a:noFill xmlns:a="http://schemas.openxmlformats.org/drawingml/2006/main"/>
-          <a:ln xmlns:a="http://schemas.openxmlformats.org/drawingml/2006/main" w="0">
-            <a:noFill/>
-          </a:ln>
-        </p:spPr>
-        <p:txBody>
-          <a:bodyPr xmlns:a="http://schemas.openxmlformats.org/drawingml/2006/main">
-            <a:noAutofit/>
-          </a:bodyPr>
-          <a:lstStyle xmlns:a="http://schemas.openxmlformats.org/drawingml/2006/main"/>
-          <a:p xmlns:a="http://schemas.openxmlformats.org/drawingml/2006/main">
-            <a:pPr>
-              <a:defRPr sz="2700" b="0">
-                <a:solidFill>
-                  <a:srgbClr val="526B70"/>
-                </a:solidFill>
-                <a:latin typeface="Arial"/>
-                <a:ea typeface="Arial"/>
-                <a:cs typeface="Arial"/>
-              </a:defRPr>
-            </a:pPr>
-            <a:r>
-              <a:rPr sz="2700" b="0">
-                <a:solidFill>
-                  <a:srgbClr val="526B70"/>
-                </a:solidFill>
-                <a:latin typeface="Arial"/>
-                <a:ea typeface="Arial"/>
-                <a:cs typeface="Arial"/>
-              </a:rPr>
-              <a:t>Share your discovery with another detective</a:t>
-            </a:r>
-          </a:p>
-        </p:txBody>
-      </p:sp>
-      <p:sp>
-        <p:nvSpPr>
-          <p:cNvPr id="3" name="">
-            <a:extLst xmlns:a="http://schemas.openxmlformats.org/drawingml/2006/main">
-              <a:ext uri="{FF2B5EF4-FFF2-40B4-BE49-F238E27FC236}">
-                <a16:creationId xmlns:a16="http://schemas.microsoft.com/office/drawing/2014/main" id="{5C3876D5-1092-4147-B092-D37BDFC8C757}"/>
-              </a:ext>
-            </a:extLst>
-          </p:cNvPr>
-          <p:cNvSpPr>
-            <a:spLocks xmlns:a="http://schemas.openxmlformats.org/drawingml/2006/main" noGrp="1"/>
-          </p:cNvSpPr>
-          <p:nvPr/>
-        </p:nvSpPr>
-        <p:spPr>
-          <a:xfrm xmlns:a="http://schemas.openxmlformats.org/drawingml/2006/main">
-            <a:off x="11144250" y="6381750"/>
-            <a:ext cx="523875" cy="266700"/>
-          </a:xfrm>
-          <a:prstGeom xmlns:a="http://schemas.openxmlformats.org/drawingml/2006/main" prst="rect">
-            <a:avLst/>
-          </a:prstGeom>
-          <a:noFill xmlns:a="http://schemas.openxmlformats.org/drawingml/2006/main"/>
-          <a:ln xmlns:a="http://schemas.openxmlformats.org/drawingml/2006/main" w="0">
-            <a:noFill/>
-          </a:ln>
-        </p:spPr>
-        <p:txBody>
-          <a:bodyPr xmlns:a="http://schemas.openxmlformats.org/drawingml/2006/main">
-            <a:noAutofit/>
-          </a:bodyPr>
-          <a:lstStyle xmlns:a="http://schemas.openxmlformats.org/drawingml/2006/main"/>
-          <a:p xmlns:a="http://schemas.openxmlformats.org/drawingml/2006/main">
-            <a:pPr>
-              <a:defRPr sz="1350" b="0">
-                <a:solidFill>
-                  <a:srgbClr val="526B70"/>
-                </a:solidFill>
-                <a:latin typeface="Arial"/>
-                <a:ea typeface="Arial"/>
-                <a:cs typeface="Arial"/>
-              </a:defRPr>
-            </a:pPr>
-            <a:r>
-              <a:rPr sz="1350" b="0">
-                <a:solidFill>
-                  <a:srgbClr val="526B70"/>
-                </a:solidFill>
-                <a:latin typeface="Arial"/>
-                <a:ea typeface="Arial"/>
-                <a:cs typeface="Arial"/>
-              </a:rPr>
-              <a:t>14</a:t>
-            </a:r>
-          </a:p>
-        </p:txBody>
-      </p:sp>
-      <p:sp>
-        <p:nvSpPr>
-          <p:cNvPr id="4" name="">
-            <a:extLst xmlns:a="http://schemas.openxmlformats.org/drawingml/2006/main">
-              <a:ext uri="{FF2B5EF4-FFF2-40B4-BE49-F238E27FC236}">
-                <a16:creationId xmlns:a16="http://schemas.microsoft.com/office/drawing/2014/main" id="{373C5E57-0AD4-4A0D-8BD2-894571C472D6}"/>
-              </a:ext>
-            </a:extLst>
-          </p:cNvPr>
-          <p:cNvSpPr>
-            <a:spLocks xmlns:a="http://schemas.openxmlformats.org/drawingml/2006/main" noGrp="1"/>
-          </p:cNvSpPr>
-          <p:nvPr/>
-        </p:nvSpPr>
-        <p:spPr>
-          <a:xfrm xmlns:a="http://schemas.openxmlformats.org/drawingml/2006/main">
-            <a:off x="609600" y="1809750"/>
-            <a:ext cx="10668000" cy="495300"/>
-          </a:xfrm>
-          <a:prstGeom xmlns:a="http://schemas.openxmlformats.org/drawingml/2006/main" prst="rect">
-            <a:avLst/>
-          </a:prstGeom>
-          <a:noFill xmlns:a="http://schemas.openxmlformats.org/drawingml/2006/main"/>
-          <a:ln xmlns:a="http://schemas.openxmlformats.org/drawingml/2006/main" w="0">
-            <a:noFill/>
-          </a:ln>
-        </p:spPr>
-        <p:txBody>
-          <a:bodyPr xmlns:a="http://schemas.openxmlformats.org/drawingml/2006/main">
-            <a:noAutofit/>
-          </a:bodyPr>
-          <a:lstStyle xmlns:a="http://schemas.openxmlformats.org/drawingml/2006/main"/>
-          <a:p xmlns:a="http://schemas.openxmlformats.org/drawingml/2006/main">
-            <a:pPr>
-              <a:defRPr sz="2625" b="0">
-                <a:solidFill>
-                  <a:srgbClr val="173C43"/>
-                </a:solidFill>
-                <a:latin typeface="Heiti TC"/>
-                <a:ea typeface="Heiti TC"/>
-                <a:cs typeface="Heiti TC"/>
-              </a:defRPr>
-            </a:pPr>
-            <a:r>
-              <a:rPr sz="2625" b="0">
-                <a:solidFill>
-                  <a:srgbClr val="173C43"/>
-                </a:solidFill>
-                <a:latin typeface="Heiti TC"/>
-                <a:ea typeface="Heiti TC"/>
-                <a:cs typeface="Heiti TC"/>
-              </a:rPr>
-              <a:t>你成功改了甚麼？結果有甚麼變化？</a:t>
-            </a:r>
-          </a:p>
-        </p:txBody>
-      </p:sp>
-      <p:sp>
-        <p:nvSpPr>
-          <p:cNvPr id="5" name="">
-            <a:extLst xmlns:a="http://schemas.openxmlformats.org/drawingml/2006/main">
-              <a:ext uri="{FF2B5EF4-FFF2-40B4-BE49-F238E27FC236}">
-                <a16:creationId xmlns:a16="http://schemas.microsoft.com/office/drawing/2014/main" id="{48DE3504-AA3B-461F-9850-3E19011E6E68}"/>
-              </a:ext>
-            </a:extLst>
-          </p:cNvPr>
-          <p:cNvSpPr>
-            <a:spLocks xmlns:a="http://schemas.openxmlformats.org/drawingml/2006/main" noGrp="1"/>
-          </p:cNvSpPr>
-          <p:nvPr/>
-        </p:nvSpPr>
-        <p:spPr>
-          <a:xfrm xmlns:a="http://schemas.openxmlformats.org/drawingml/2006/main">
-            <a:off x="609600" y="2276475"/>
-            <a:ext cx="10668000" cy="457200"/>
-          </a:xfrm>
-          <a:prstGeom xmlns:a="http://schemas.openxmlformats.org/drawingml/2006/main" prst="rect">
-            <a:avLst/>
-          </a:prstGeom>
-          <a:noFill xmlns:a="http://schemas.openxmlformats.org/drawingml/2006/main"/>
-          <a:ln xmlns:a="http://schemas.openxmlformats.org/drawingml/2006/main" w="0">
-            <a:noFill/>
-          </a:ln>
-        </p:spPr>
-        <p:txBody>
-          <a:bodyPr xmlns:a="http://schemas.openxmlformats.org/drawingml/2006/main">
-            <a:noAutofit/>
-          </a:bodyPr>
-          <a:lstStyle xmlns:a="http://schemas.openxmlformats.org/drawingml/2006/main"/>
-          <a:p xmlns:a="http://schemas.openxmlformats.org/drawingml/2006/main">
-            <a:pPr>
-              <a:defRPr sz="2025" b="0">
-                <a:solidFill>
-                  <a:srgbClr val="526B70"/>
-                </a:solidFill>
-                <a:latin typeface="Arial"/>
-                <a:ea typeface="Arial"/>
-                <a:cs typeface="Arial"/>
-              </a:defRPr>
-            </a:pPr>
-            <a:r>
-              <a:rPr sz="2025" b="0">
-                <a:solidFill>
-                  <a:srgbClr val="526B70"/>
-                </a:solidFill>
-                <a:latin typeface="Arial"/>
-                <a:ea typeface="Arial"/>
-                <a:cs typeface="Arial"/>
-              </a:rPr>
-              <a:t>What did you change successfully? What happened?</a:t>
-            </a:r>
-          </a:p>
-        </p:txBody>
-      </p:sp>
-      <p:sp>
-        <p:nvSpPr>
-          <p:cNvPr id="6" name="">
-            <a:extLst xmlns:a="http://schemas.openxmlformats.org/drawingml/2006/main">
-              <a:ext uri="{FF2B5EF4-FFF2-40B4-BE49-F238E27FC236}">
-                <a16:creationId xmlns:a16="http://schemas.microsoft.com/office/drawing/2014/main" id="{D739F70D-90AA-4191-83CF-B7D8F4A93C90}"/>
-              </a:ext>
-            </a:extLst>
-          </p:cNvPr>
-          <p:cNvSpPr>
-            <a:spLocks xmlns:a="http://schemas.openxmlformats.org/drawingml/2006/main" noGrp="1"/>
-          </p:cNvSpPr>
-          <p:nvPr/>
-        </p:nvSpPr>
-        <p:spPr>
-          <a:xfrm xmlns:a="http://schemas.openxmlformats.org/drawingml/2006/main">
-            <a:off x="609600" y="3190875"/>
-            <a:ext cx="10668000" cy="495300"/>
-          </a:xfrm>
-          <a:prstGeom xmlns:a="http://schemas.openxmlformats.org/drawingml/2006/main" prst="rect">
-            <a:avLst/>
-          </a:prstGeom>
-          <a:noFill xmlns:a="http://schemas.openxmlformats.org/drawingml/2006/main"/>
-          <a:ln xmlns:a="http://schemas.openxmlformats.org/drawingml/2006/main" w="0">
-            <a:noFill/>
-          </a:ln>
-        </p:spPr>
-        <p:txBody>
-          <a:bodyPr xmlns:a="http://schemas.openxmlformats.org/drawingml/2006/main">
-            <a:noAutofit/>
-          </a:bodyPr>
-          <a:lstStyle xmlns:a="http://schemas.openxmlformats.org/drawingml/2006/main"/>
-          <a:p xmlns:a="http://schemas.openxmlformats.org/drawingml/2006/main">
-            <a:pPr>
-              <a:defRPr sz="2625" b="0">
-                <a:solidFill>
-                  <a:srgbClr val="173C43"/>
-                </a:solidFill>
-                <a:latin typeface="Heiti TC"/>
-                <a:ea typeface="Heiti TC"/>
-                <a:cs typeface="Heiti TC"/>
-              </a:defRPr>
-            </a:pPr>
-            <a:r>
-              <a:rPr sz="2625" b="0">
-                <a:solidFill>
-                  <a:srgbClr val="173C43"/>
-                </a:solidFill>
-                <a:latin typeface="Heiti TC"/>
-                <a:ea typeface="Heiti TC"/>
-                <a:cs typeface="Heiti TC"/>
-              </a:rPr>
-              <a:t>你較信賴哪個預測？為甚麼？</a:t>
-            </a:r>
-          </a:p>
-        </p:txBody>
-      </p:sp>
-      <p:sp>
-        <p:nvSpPr>
-          <p:cNvPr id="7" name="">
-            <a:extLst xmlns:a="http://schemas.openxmlformats.org/drawingml/2006/main">
-              <a:ext uri="{FF2B5EF4-FFF2-40B4-BE49-F238E27FC236}">
-                <a16:creationId xmlns:a16="http://schemas.microsoft.com/office/drawing/2014/main" id="{34D619D5-2F34-4CE3-AF3A-3BDDD76DA6B1}"/>
-              </a:ext>
-            </a:extLst>
-          </p:cNvPr>
-          <p:cNvSpPr>
-            <a:spLocks xmlns:a="http://schemas.openxmlformats.org/drawingml/2006/main" noGrp="1"/>
-          </p:cNvSpPr>
-          <p:nvPr/>
-        </p:nvSpPr>
-        <p:spPr>
-          <a:xfrm xmlns:a="http://schemas.openxmlformats.org/drawingml/2006/main">
-            <a:off x="609600" y="3657600"/>
-            <a:ext cx="10668000" cy="457200"/>
-          </a:xfrm>
-          <a:prstGeom xmlns:a="http://schemas.openxmlformats.org/drawingml/2006/main" prst="rect">
-            <a:avLst/>
-          </a:prstGeom>
-          <a:noFill xmlns:a="http://schemas.openxmlformats.org/drawingml/2006/main"/>
-          <a:ln xmlns:a="http://schemas.openxmlformats.org/drawingml/2006/main" w="0">
-            <a:noFill/>
-          </a:ln>
-        </p:spPr>
-        <p:txBody>
-          <a:bodyPr xmlns:a="http://schemas.openxmlformats.org/drawingml/2006/main">
-            <a:noAutofit/>
-          </a:bodyPr>
-          <a:lstStyle xmlns:a="http://schemas.openxmlformats.org/drawingml/2006/main"/>
-          <a:p xmlns:a="http://schemas.openxmlformats.org/drawingml/2006/main">
-            <a:pPr>
-              <a:defRPr sz="2025" b="0">
-                <a:solidFill>
-                  <a:srgbClr val="526B70"/>
-                </a:solidFill>
-                <a:latin typeface="Arial"/>
-                <a:ea typeface="Arial"/>
-                <a:cs typeface="Arial"/>
-              </a:defRPr>
-            </a:pPr>
-            <a:r>
-              <a:rPr sz="2025" b="0">
-                <a:solidFill>
-                  <a:srgbClr val="526B70"/>
-                </a:solidFill>
-                <a:latin typeface="Arial"/>
-                <a:ea typeface="Arial"/>
-                <a:cs typeface="Arial"/>
-              </a:rPr>
-              <a:t>Which prediction do you trust more? Why?</a:t>
-            </a:r>
-          </a:p>
-        </p:txBody>
-      </p:sp>
-      <p:sp>
-        <p:nvSpPr>
-          <p:cNvPr id="8" name="">
-            <a:extLst xmlns:a="http://schemas.openxmlformats.org/drawingml/2006/main">
-              <a:ext uri="{FF2B5EF4-FFF2-40B4-BE49-F238E27FC236}">
-                <a16:creationId xmlns:a16="http://schemas.microsoft.com/office/drawing/2014/main" id="{48D5E75A-E785-44C6-9123-5FC2E06B4CF7}"/>
-              </a:ext>
-            </a:extLst>
-          </p:cNvPr>
-          <p:cNvSpPr>
-            <a:spLocks xmlns:a="http://schemas.openxmlformats.org/drawingml/2006/main" noGrp="1"/>
-          </p:cNvSpPr>
-          <p:nvPr/>
-        </p:nvSpPr>
-        <p:spPr>
-          <a:xfrm xmlns:a="http://schemas.openxmlformats.org/drawingml/2006/main">
-            <a:off x="609600" y="4572000"/>
-            <a:ext cx="10668000" cy="495300"/>
-          </a:xfrm>
-          <a:prstGeom xmlns:a="http://schemas.openxmlformats.org/drawingml/2006/main" prst="rect">
-            <a:avLst/>
-          </a:prstGeom>
-          <a:noFill xmlns:a="http://schemas.openxmlformats.org/drawingml/2006/main"/>
-          <a:ln xmlns:a="http://schemas.openxmlformats.org/drawingml/2006/main" w="0">
-            <a:noFill/>
-          </a:ln>
-        </p:spPr>
-        <p:txBody>
-          <a:bodyPr xmlns:a="http://schemas.openxmlformats.org/drawingml/2006/main">
-            <a:noAutofit/>
-          </a:bodyPr>
-          <a:lstStyle xmlns:a="http://schemas.openxmlformats.org/drawingml/2006/main"/>
-          <a:p xmlns:a="http://schemas.openxmlformats.org/drawingml/2006/main">
-            <a:pPr>
-              <a:defRPr sz="2325" b="0">
-                <a:solidFill>
-                  <a:srgbClr val="173C43"/>
-                </a:solidFill>
-                <a:latin typeface="Heiti TC"/>
-                <a:ea typeface="Heiti TC"/>
-                <a:cs typeface="Heiti TC"/>
-              </a:defRPr>
-            </a:pPr>
-            <a:r>
-              <a:rPr sz="2325" b="0">
-                <a:solidFill>
-                  <a:srgbClr val="173C43"/>
-                </a:solidFill>
-                <a:latin typeface="Heiti TC"/>
-                <a:ea typeface="Heiti TC"/>
-                <a:cs typeface="Heiti TC"/>
-              </a:rPr>
-              <a:t>下一堂：讓電腦猜「是哪一類」，而不是「幾多分」</a:t>
-            </a:r>
-          </a:p>
-        </p:txBody>
-      </p:sp>
-      <p:sp>
-        <p:nvSpPr>
-          <p:cNvPr id="9" name="">
-            <a:extLst xmlns:a="http://schemas.openxmlformats.org/drawingml/2006/main">
-              <a:ext uri="{FF2B5EF4-FFF2-40B4-BE49-F238E27FC236}">
-                <a16:creationId xmlns:a16="http://schemas.microsoft.com/office/drawing/2014/main" id="{F5FFFF5B-F55E-449D-9355-33D7FA28A719}"/>
-              </a:ext>
-            </a:extLst>
-          </p:cNvPr>
-          <p:cNvSpPr>
-            <a:spLocks xmlns:a="http://schemas.openxmlformats.org/drawingml/2006/main" noGrp="1"/>
-          </p:cNvSpPr>
-          <p:nvPr/>
-        </p:nvSpPr>
-        <p:spPr>
-          <a:xfrm xmlns:a="http://schemas.openxmlformats.org/drawingml/2006/main">
-            <a:off x="609600" y="5038725"/>
-            <a:ext cx="10668000" cy="457200"/>
-          </a:xfrm>
-          <a:prstGeom xmlns:a="http://schemas.openxmlformats.org/drawingml/2006/main" prst="rect">
-            <a:avLst/>
-          </a:prstGeom>
-          <a:noFill xmlns:a="http://schemas.openxmlformats.org/drawingml/2006/main"/>
-          <a:ln xmlns:a="http://schemas.openxmlformats.org/drawingml/2006/main" w="0">
-            <a:noFill/>
-          </a:ln>
-        </p:spPr>
-        <p:txBody>
-          <a:bodyPr xmlns:a="http://schemas.openxmlformats.org/drawingml/2006/main">
-            <a:noAutofit/>
-          </a:bodyPr>
-          <a:lstStyle xmlns:a="http://schemas.openxmlformats.org/drawingml/2006/main"/>
-          <a:p xmlns:a="http://schemas.openxmlformats.org/drawingml/2006/main">
-            <a:pPr>
-              <a:defRPr sz="1800" b="0">
-                <a:solidFill>
-                  <a:srgbClr val="526B70"/>
-                </a:solidFill>
-                <a:latin typeface="Arial"/>
-                <a:ea typeface="Arial"/>
-                <a:cs typeface="Arial"/>
-              </a:defRPr>
-            </a:pPr>
-            <a:r>
-              <a:rPr sz="1800" b="0">
-                <a:solidFill>
-                  <a:srgbClr val="526B70"/>
-                </a:solidFill>
-                <a:latin typeface="Arial"/>
-                <a:ea typeface="Arial"/>
-                <a:cs typeface="Arial"/>
-              </a:rPr>
-              <a:t>Next time: predict which class, instead of how many marks</a:t>
-            </a:r>
-          </a:p>
-        </p:txBody>
-      </p:sp>
-    </p:spTree>
-    <p:extLst>
-      <p:ext uri="{BB962C8B-B14F-4D97-AF65-F5344CB8AC3E}">
-        <p14:creationId xmlns:p14="http://schemas.microsoft.com/office/powerpoint/2010/main" val="1515774974"/>
+        <p14:creationId xmlns:p14="http://schemas.microsoft.com/office/powerpoint/2010/main" val="406683300"/>
       </p:ext>
     </p:extLst>
   </p:cSld>
@@ -6352,7 +5739,7 @@
           <p:cNvPr id="9" name="">
             <a:extLst xmlns:a="http://schemas.openxmlformats.org/drawingml/2006/main">
               <a:ext uri="{FF2B5EF4-FFF2-40B4-BE49-F238E27FC236}">
-                <a16:creationId xmlns:a16="http://schemas.microsoft.com/office/drawing/2014/main" id="{BD8D5584-91CA-479C-B26F-27EF07ABA7BB}"/>
+                <a16:creationId xmlns:a16="http://schemas.microsoft.com/office/drawing/2014/main" id="{A088A73E-B6E8-462B-B76E-0458BE1C15A4}"/>
               </a:ext>
             </a:extLst>
           </p:cNvPr>
@@ -6409,7 +5796,7 @@
           <p:cNvPr id="2" name="">
             <a:extLst xmlns:a="http://schemas.openxmlformats.org/drawingml/2006/main">
               <a:ext uri="{FF2B5EF4-FFF2-40B4-BE49-F238E27FC236}">
-                <a16:creationId xmlns:a16="http://schemas.microsoft.com/office/drawing/2014/main" id="{65BE3DF3-4659-4830-9B3E-6EB159288099}"/>
+                <a16:creationId xmlns:a16="http://schemas.microsoft.com/office/drawing/2014/main" id="{44D48024-152D-4E0E-A375-CF11AF3DACD2}"/>
               </a:ext>
             </a:extLst>
           </p:cNvPr>
@@ -6466,7 +5853,7 @@
           <p:cNvPr id="3" name="">
             <a:extLst xmlns:a="http://schemas.openxmlformats.org/drawingml/2006/main">
               <a:ext uri="{FF2B5EF4-FFF2-40B4-BE49-F238E27FC236}">
-                <a16:creationId xmlns:a16="http://schemas.microsoft.com/office/drawing/2014/main" id="{E196BC11-A444-4B61-B48B-E94227499C51}"/>
+                <a16:creationId xmlns:a16="http://schemas.microsoft.com/office/drawing/2014/main" id="{27EC04FC-FEF0-4D1F-9F3F-65BCC238EB18}"/>
               </a:ext>
             </a:extLst>
           </p:cNvPr>
@@ -6523,7 +5910,7 @@
           <p:cNvPr id="4" name="">
             <a:extLst xmlns:a="http://schemas.openxmlformats.org/drawingml/2006/main">
               <a:ext uri="{FF2B5EF4-FFF2-40B4-BE49-F238E27FC236}">
-                <a16:creationId xmlns:a16="http://schemas.microsoft.com/office/drawing/2014/main" id="{3E98D0E4-01D4-488A-8571-6B68F974743D}"/>
+                <a16:creationId xmlns:a16="http://schemas.microsoft.com/office/drawing/2014/main" id="{2334BAA0-C686-4CD5-B39D-CFAD52891368}"/>
               </a:ext>
             </a:extLst>
           </p:cNvPr>
@@ -6603,7 +5990,7 @@
           <p:cNvPr id="5" name="">
             <a:extLst xmlns:a="http://schemas.openxmlformats.org/drawingml/2006/main">
               <a:ext uri="{FF2B5EF4-FFF2-40B4-BE49-F238E27FC236}">
-                <a16:creationId xmlns:a16="http://schemas.microsoft.com/office/drawing/2014/main" id="{7732DAFC-2FBF-4D7F-809E-30B2A2AF055A}"/>
+                <a16:creationId xmlns:a16="http://schemas.microsoft.com/office/drawing/2014/main" id="{94527732-EBCA-4EA7-9835-F9ECCBF765F7}"/>
               </a:ext>
             </a:extLst>
           </p:cNvPr>
@@ -6660,7 +6047,7 @@
           <p:cNvPr id="6" name="">
             <a:extLst xmlns:a="http://schemas.openxmlformats.org/drawingml/2006/main">
               <a:ext uri="{FF2B5EF4-FFF2-40B4-BE49-F238E27FC236}">
-                <a16:creationId xmlns:a16="http://schemas.microsoft.com/office/drawing/2014/main" id="{B9702768-7D02-4151-B712-E0BC3AB62F9C}"/>
+                <a16:creationId xmlns:a16="http://schemas.microsoft.com/office/drawing/2014/main" id="{456F07E0-83B4-42C5-9C1F-62BCA4011D65}"/>
               </a:ext>
             </a:extLst>
           </p:cNvPr>
@@ -6717,7 +6104,7 @@
           <p:cNvPr id="7" name="">
             <a:extLst xmlns:a="http://schemas.openxmlformats.org/drawingml/2006/main">
               <a:ext uri="{FF2B5EF4-FFF2-40B4-BE49-F238E27FC236}">
-                <a16:creationId xmlns:a16="http://schemas.microsoft.com/office/drawing/2014/main" id="{363318BD-59B8-43E4-909A-3BABEBDF731F}"/>
+                <a16:creationId xmlns:a16="http://schemas.microsoft.com/office/drawing/2014/main" id="{B7ACD42B-48E0-4509-B2EF-C1BC9C2141CE}"/>
               </a:ext>
             </a:extLst>
           </p:cNvPr>
@@ -6764,7 +6151,7 @@
                 <a:ea typeface="Heiti TC"/>
                 <a:cs typeface="Heiti TC"/>
               </a:rPr>
-              <a:t>成功了？你已經完成第一個 Python 小實驗</a:t>
+              <a:t>先把文字存成 message，再用 print 顯示</a:t>
             </a:r>
           </a:p>
         </p:txBody>
@@ -6774,7 +6161,7 @@
           <p:cNvPr id="8" name="">
             <a:extLst xmlns:a="http://schemas.openxmlformats.org/drawingml/2006/main">
               <a:ext uri="{FF2B5EF4-FFF2-40B4-BE49-F238E27FC236}">
-                <a16:creationId xmlns:a16="http://schemas.microsoft.com/office/drawing/2014/main" id="{FAAD12D9-0119-4374-B1CA-DA689A7E8FBE}"/>
+                <a16:creationId xmlns:a16="http://schemas.microsoft.com/office/drawing/2014/main" id="{71E794FF-B60D-4CAD-A6C5-08931C0A671D}"/>
               </a:ext>
             </a:extLst>
           </p:cNvPr>
@@ -6821,7 +6208,7 @@
                 <a:ea typeface="Arial"/>
                 <a:cs typeface="Arial"/>
               </a:rPr>
-              <a:t>Did it work? You have completed your first Python experiment</a:t>
+              <a:t>Store the text as message, then display it with print</a:t>
             </a:r>
           </a:p>
         </p:txBody>
@@ -6829,7 +6216,7 @@
     </p:spTree>
     <p:extLst>
       <p:ext uri="{BB962C8B-B14F-4D97-AF65-F5344CB8AC3E}">
-        <p14:creationId xmlns:p14="http://schemas.microsoft.com/office/powerpoint/2010/main" val="1406891811"/>
+        <p14:creationId xmlns:p14="http://schemas.microsoft.com/office/powerpoint/2010/main" val="973998016"/>
       </p:ext>
     </p:extLst>
   </p:cSld>
@@ -6860,7 +6247,7 @@
           <p:cNvPr id="10" name="">
             <a:extLst xmlns:a="http://schemas.openxmlformats.org/drawingml/2006/main">
               <a:ext uri="{FF2B5EF4-FFF2-40B4-BE49-F238E27FC236}">
-                <a16:creationId xmlns:a16="http://schemas.microsoft.com/office/drawing/2014/main" id="{F7A5E924-C3EA-4AAC-9BA8-023CD4B892B5}"/>
+                <a16:creationId xmlns:a16="http://schemas.microsoft.com/office/drawing/2014/main" id="{2DC13A20-2366-4AFB-BC2D-914FD8D1956C}"/>
               </a:ext>
             </a:extLst>
           </p:cNvPr>
@@ -6917,7 +6304,7 @@
           <p:cNvPr id="2" name="">
             <a:extLst xmlns:a="http://schemas.openxmlformats.org/drawingml/2006/main">
               <a:ext uri="{FF2B5EF4-FFF2-40B4-BE49-F238E27FC236}">
-                <a16:creationId xmlns:a16="http://schemas.microsoft.com/office/drawing/2014/main" id="{FDF30673-3809-4EA3-88F3-41DA3BCF5F6A}"/>
+                <a16:creationId xmlns:a16="http://schemas.microsoft.com/office/drawing/2014/main" id="{76AB8C8E-999C-4431-B50D-B2DCB45DF78A}"/>
               </a:ext>
             </a:extLst>
           </p:cNvPr>
@@ -6974,7 +6361,7 @@
           <p:cNvPr id="3" name="">
             <a:extLst xmlns:a="http://schemas.openxmlformats.org/drawingml/2006/main">
               <a:ext uri="{FF2B5EF4-FFF2-40B4-BE49-F238E27FC236}">
-                <a16:creationId xmlns:a16="http://schemas.microsoft.com/office/drawing/2014/main" id="{A1405D65-A673-4392-924B-C79B02440E65}"/>
+                <a16:creationId xmlns:a16="http://schemas.microsoft.com/office/drawing/2014/main" id="{26D84D69-BFB9-4237-94E4-755A5B8B2BFB}"/>
               </a:ext>
             </a:extLst>
           </p:cNvPr>
@@ -7031,7 +6418,7 @@
           <p:cNvPr id="4" name="">
             <a:extLst xmlns:a="http://schemas.openxmlformats.org/drawingml/2006/main">
               <a:ext uri="{FF2B5EF4-FFF2-40B4-BE49-F238E27FC236}">
-                <a16:creationId xmlns:a16="http://schemas.microsoft.com/office/drawing/2014/main" id="{6BB0B1A4-080D-4D15-8DEA-C76C6EC0F4D6}"/>
+                <a16:creationId xmlns:a16="http://schemas.microsoft.com/office/drawing/2014/main" id="{2D9AFDDE-336F-4F0A-A65B-2545F585C293}"/>
               </a:ext>
             </a:extLst>
           </p:cNvPr>
@@ -7088,7 +6475,7 @@
           <p:cNvPr id="5" name="">
             <a:extLst xmlns:a="http://schemas.openxmlformats.org/drawingml/2006/main">
               <a:ext uri="{FF2B5EF4-FFF2-40B4-BE49-F238E27FC236}">
-                <a16:creationId xmlns:a16="http://schemas.microsoft.com/office/drawing/2014/main" id="{CF28EDFF-2F1C-4822-90DE-6A9DD012BDE4}"/>
+                <a16:creationId xmlns:a16="http://schemas.microsoft.com/office/drawing/2014/main" id="{73A45860-4DB6-4526-9DC7-44A027A31810}"/>
               </a:ext>
             </a:extLst>
           </p:cNvPr>
@@ -7145,7 +6532,7 @@
           <p:cNvPr id="6" name="">
             <a:extLst xmlns:a="http://schemas.openxmlformats.org/drawingml/2006/main">
               <a:ext uri="{FF2B5EF4-FFF2-40B4-BE49-F238E27FC236}">
-                <a16:creationId xmlns:a16="http://schemas.microsoft.com/office/drawing/2014/main" id="{9080817C-4330-4151-B2C4-0511EA9ACBEA}"/>
+                <a16:creationId xmlns:a16="http://schemas.microsoft.com/office/drawing/2014/main" id="{7089C1BE-46C7-42B4-AF04-13934BEE6F72}"/>
               </a:ext>
             </a:extLst>
           </p:cNvPr>
@@ -7202,7 +6589,7 @@
           <p:cNvPr id="7" name="">
             <a:extLst xmlns:a="http://schemas.openxmlformats.org/drawingml/2006/main">
               <a:ext uri="{FF2B5EF4-FFF2-40B4-BE49-F238E27FC236}">
-                <a16:creationId xmlns:a16="http://schemas.microsoft.com/office/drawing/2014/main" id="{F44F3694-D3DD-48ED-A142-2CDFF7798C6C}"/>
+                <a16:creationId xmlns:a16="http://schemas.microsoft.com/office/drawing/2014/main" id="{2072495F-F663-45D2-8C71-9B32599EA6C9}"/>
               </a:ext>
             </a:extLst>
           </p:cNvPr>
@@ -7259,7 +6646,7 @@
           <p:cNvPr id="8" name="">
             <a:extLst xmlns:a="http://schemas.openxmlformats.org/drawingml/2006/main">
               <a:ext uri="{FF2B5EF4-FFF2-40B4-BE49-F238E27FC236}">
-                <a16:creationId xmlns:a16="http://schemas.microsoft.com/office/drawing/2014/main" id="{0E99A807-1361-4D92-9F09-CF957AA4B2FB}"/>
+                <a16:creationId xmlns:a16="http://schemas.microsoft.com/office/drawing/2014/main" id="{450F2DB3-428E-41FE-A547-622EEA9B20D9}"/>
               </a:ext>
             </a:extLst>
           </p:cNvPr>
@@ -7316,7 +6703,7 @@
           <p:cNvPr id="9" name="">
             <a:extLst xmlns:a="http://schemas.openxmlformats.org/drawingml/2006/main">
               <a:ext uri="{FF2B5EF4-FFF2-40B4-BE49-F238E27FC236}">
-                <a16:creationId xmlns:a16="http://schemas.microsoft.com/office/drawing/2014/main" id="{39371BEC-3E7C-4A4C-8470-7EF813DAFF1F}"/>
+                <a16:creationId xmlns:a16="http://schemas.microsoft.com/office/drawing/2014/main" id="{9255CE37-9803-412C-AA43-49601F3CA632}"/>
               </a:ext>
             </a:extLst>
           </p:cNvPr>
@@ -7371,7 +6758,7 @@
     </p:spTree>
     <p:extLst>
       <p:ext uri="{BB962C8B-B14F-4D97-AF65-F5344CB8AC3E}">
-        <p14:creationId xmlns:p14="http://schemas.microsoft.com/office/powerpoint/2010/main" val="65354577"/>
+        <p14:creationId xmlns:p14="http://schemas.microsoft.com/office/powerpoint/2010/main" val="2039365930"/>
       </p:ext>
     </p:extLst>
   </p:cSld>
@@ -7402,7 +6789,7 @@
           <p:cNvPr id="10" name="">
             <a:extLst xmlns:a="http://schemas.openxmlformats.org/drawingml/2006/main">
               <a:ext uri="{FF2B5EF4-FFF2-40B4-BE49-F238E27FC236}">
-                <a16:creationId xmlns:a16="http://schemas.microsoft.com/office/drawing/2014/main" id="{9D2E8FE2-7BF0-44F5-BDA6-B78D13033496}"/>
+                <a16:creationId xmlns:a16="http://schemas.microsoft.com/office/drawing/2014/main" id="{1CE682BC-3570-4B3D-91D7-E61D37C90020}"/>
               </a:ext>
             </a:extLst>
           </p:cNvPr>
@@ -7459,7 +6846,7 @@
           <p:cNvPr id="2" name="">
             <a:extLst xmlns:a="http://schemas.openxmlformats.org/drawingml/2006/main">
               <a:ext uri="{FF2B5EF4-FFF2-40B4-BE49-F238E27FC236}">
-                <a16:creationId xmlns:a16="http://schemas.microsoft.com/office/drawing/2014/main" id="{FEF81CE4-1521-4C6C-A9CE-88E263A10A5B}"/>
+                <a16:creationId xmlns:a16="http://schemas.microsoft.com/office/drawing/2014/main" id="{BC1BA1DC-8300-4A03-8637-A0CBCE64A29F}"/>
               </a:ext>
             </a:extLst>
           </p:cNvPr>
@@ -7516,7 +6903,7 @@
           <p:cNvPr id="3" name="">
             <a:extLst xmlns:a="http://schemas.openxmlformats.org/drawingml/2006/main">
               <a:ext uri="{FF2B5EF4-FFF2-40B4-BE49-F238E27FC236}">
-                <a16:creationId xmlns:a16="http://schemas.microsoft.com/office/drawing/2014/main" id="{B17A31BB-5176-44C3-BDA3-70F3B0850A57}"/>
+                <a16:creationId xmlns:a16="http://schemas.microsoft.com/office/drawing/2014/main" id="{1FD56343-E4C1-44EB-8BD0-52D00FB08610}"/>
               </a:ext>
             </a:extLst>
           </p:cNvPr>
@@ -7573,7 +6960,7 @@
           <p:cNvPr id="4" name="">
             <a:extLst xmlns:a="http://schemas.openxmlformats.org/drawingml/2006/main">
               <a:ext uri="{FF2B5EF4-FFF2-40B4-BE49-F238E27FC236}">
-                <a16:creationId xmlns:a16="http://schemas.microsoft.com/office/drawing/2014/main" id="{13161813-1831-4180-A0AC-8465F4974337}"/>
+                <a16:creationId xmlns:a16="http://schemas.microsoft.com/office/drawing/2014/main" id="{7AC7B7BB-FA9A-4330-AE33-9201D2A937A7}"/>
               </a:ext>
             </a:extLst>
           </p:cNvPr>
@@ -7630,7 +7017,7 @@
           <p:cNvPr id="5" name="">
             <a:extLst xmlns:a="http://schemas.openxmlformats.org/drawingml/2006/main">
               <a:ext uri="{FF2B5EF4-FFF2-40B4-BE49-F238E27FC236}">
-                <a16:creationId xmlns:a16="http://schemas.microsoft.com/office/drawing/2014/main" id="{875B46A3-DDBC-422D-AB9D-F7C08E3D82D6}"/>
+                <a16:creationId xmlns:a16="http://schemas.microsoft.com/office/drawing/2014/main" id="{20DDF2D7-DF26-4446-94A7-86AEE991C4B4}"/>
               </a:ext>
             </a:extLst>
           </p:cNvPr>
@@ -7687,7 +7074,7 @@
           <p:cNvPr id="6" name="">
             <a:extLst xmlns:a="http://schemas.openxmlformats.org/drawingml/2006/main">
               <a:ext uri="{FF2B5EF4-FFF2-40B4-BE49-F238E27FC236}">
-                <a16:creationId xmlns:a16="http://schemas.microsoft.com/office/drawing/2014/main" id="{DDEEDAF8-B752-4D30-A950-0628194D9F60}"/>
+                <a16:creationId xmlns:a16="http://schemas.microsoft.com/office/drawing/2014/main" id="{001F0F9A-C872-496E-8E62-A812C25695C6}"/>
               </a:ext>
             </a:extLst>
           </p:cNvPr>
@@ -7744,7 +7131,7 @@
           <p:cNvPr id="7" name="">
             <a:extLst xmlns:a="http://schemas.openxmlformats.org/drawingml/2006/main">
               <a:ext uri="{FF2B5EF4-FFF2-40B4-BE49-F238E27FC236}">
-                <a16:creationId xmlns:a16="http://schemas.microsoft.com/office/drawing/2014/main" id="{3F7B67E6-8292-4CE4-9F9F-5D7533FE6E72}"/>
+                <a16:creationId xmlns:a16="http://schemas.microsoft.com/office/drawing/2014/main" id="{952FF252-9E69-4428-9DB8-7B80B8E7563F}"/>
               </a:ext>
             </a:extLst>
           </p:cNvPr>
@@ -7801,7 +7188,7 @@
           <p:cNvPr id="8" name="">
             <a:extLst xmlns:a="http://schemas.openxmlformats.org/drawingml/2006/main">
               <a:ext uri="{FF2B5EF4-FFF2-40B4-BE49-F238E27FC236}">
-                <a16:creationId xmlns:a16="http://schemas.microsoft.com/office/drawing/2014/main" id="{0D019CA5-4FD0-4AF9-9005-6110CB5C20C9}"/>
+                <a16:creationId xmlns:a16="http://schemas.microsoft.com/office/drawing/2014/main" id="{64CAFD10-CD66-4830-ACDC-A00A0995BD3F}"/>
               </a:ext>
             </a:extLst>
           </p:cNvPr>
@@ -7858,7 +7245,7 @@
           <p:cNvPr id="9" name="">
             <a:extLst xmlns:a="http://schemas.openxmlformats.org/drawingml/2006/main">
               <a:ext uri="{FF2B5EF4-FFF2-40B4-BE49-F238E27FC236}">
-                <a16:creationId xmlns:a16="http://schemas.microsoft.com/office/drawing/2014/main" id="{3405C776-9EA4-45F7-8C65-0172CA61EE0E}"/>
+                <a16:creationId xmlns:a16="http://schemas.microsoft.com/office/drawing/2014/main" id="{522C5492-43E0-4941-BB68-76544B16771B}"/>
               </a:ext>
             </a:extLst>
           </p:cNvPr>
@@ -7913,7 +7300,7 @@
     </p:spTree>
     <p:extLst>
       <p:ext uri="{BB962C8B-B14F-4D97-AF65-F5344CB8AC3E}">
-        <p14:creationId xmlns:p14="http://schemas.microsoft.com/office/powerpoint/2010/main" val="1138073895"/>
+        <p14:creationId xmlns:p14="http://schemas.microsoft.com/office/powerpoint/2010/main" val="77048718"/>
       </p:ext>
     </p:extLst>
   </p:cSld>
@@ -7944,7 +7331,7 @@
           <p:cNvPr id="11" name="">
             <a:extLst xmlns:a="http://schemas.openxmlformats.org/drawingml/2006/main">
               <a:ext uri="{FF2B5EF4-FFF2-40B4-BE49-F238E27FC236}">
-                <a16:creationId xmlns:a16="http://schemas.microsoft.com/office/drawing/2014/main" id="{231E978A-BBB2-4B2F-BF59-4ACABBEE3772}"/>
+                <a16:creationId xmlns:a16="http://schemas.microsoft.com/office/drawing/2014/main" id="{575BA699-A21A-4639-991F-29D86D5D7B04}"/>
               </a:ext>
             </a:extLst>
           </p:cNvPr>
@@ -8001,7 +7388,7 @@
           <p:cNvPr id="2" name="">
             <a:extLst xmlns:a="http://schemas.openxmlformats.org/drawingml/2006/main">
               <a:ext uri="{FF2B5EF4-FFF2-40B4-BE49-F238E27FC236}">
-                <a16:creationId xmlns:a16="http://schemas.microsoft.com/office/drawing/2014/main" id="{005435B3-4663-42B2-9422-7A2B35CA9DD9}"/>
+                <a16:creationId xmlns:a16="http://schemas.microsoft.com/office/drawing/2014/main" id="{B4F5ECCF-DE22-49BB-8363-04238E85D69F}"/>
               </a:ext>
             </a:extLst>
           </p:cNvPr>
@@ -8058,7 +7445,7 @@
           <p:cNvPr id="3" name="">
             <a:extLst xmlns:a="http://schemas.openxmlformats.org/drawingml/2006/main">
               <a:ext uri="{FF2B5EF4-FFF2-40B4-BE49-F238E27FC236}">
-                <a16:creationId xmlns:a16="http://schemas.microsoft.com/office/drawing/2014/main" id="{0CDACD66-A058-4599-A084-953AC1D9C03F}"/>
+                <a16:creationId xmlns:a16="http://schemas.microsoft.com/office/drawing/2014/main" id="{00CB7B4B-A86B-4D0E-8DF5-240C0057A812}"/>
               </a:ext>
             </a:extLst>
           </p:cNvPr>
@@ -8115,7 +7502,7 @@
           <p:cNvPr id="4" name="">
             <a:extLst xmlns:a="http://schemas.openxmlformats.org/drawingml/2006/main">
               <a:ext uri="{FF2B5EF4-FFF2-40B4-BE49-F238E27FC236}">
-                <a16:creationId xmlns:a16="http://schemas.microsoft.com/office/drawing/2014/main" id="{1AD8E1CD-4770-4C12-A937-5E5263D605C2}"/>
+                <a16:creationId xmlns:a16="http://schemas.microsoft.com/office/drawing/2014/main" id="{44D11384-4589-44D5-864F-A3093CD7C611}"/>
               </a:ext>
             </a:extLst>
           </p:cNvPr>
@@ -8172,7 +7559,7 @@
           <p:cNvPr id="5" name="">
             <a:extLst xmlns:a="http://schemas.openxmlformats.org/drawingml/2006/main">
               <a:ext uri="{FF2B5EF4-FFF2-40B4-BE49-F238E27FC236}">
-                <a16:creationId xmlns:a16="http://schemas.microsoft.com/office/drawing/2014/main" id="{263A471A-30AB-48C5-B4D7-BE5816C4BFE0}"/>
+                <a16:creationId xmlns:a16="http://schemas.microsoft.com/office/drawing/2014/main" id="{1D7E2269-99D9-4101-99FD-AC83DBBE8D9D}"/>
               </a:ext>
             </a:extLst>
           </p:cNvPr>
@@ -8229,7 +7616,7 @@
           <p:cNvPr id="6" name="">
             <a:extLst xmlns:a="http://schemas.openxmlformats.org/drawingml/2006/main">
               <a:ext uri="{FF2B5EF4-FFF2-40B4-BE49-F238E27FC236}">
-                <a16:creationId xmlns:a16="http://schemas.microsoft.com/office/drawing/2014/main" id="{A2C6C5C1-15A8-4566-BF68-1FD477066FB4}"/>
+                <a16:creationId xmlns:a16="http://schemas.microsoft.com/office/drawing/2014/main" id="{5459F528-3C8D-476B-9DEA-6FD261911C77}"/>
               </a:ext>
             </a:extLst>
           </p:cNvPr>
@@ -8286,7 +7673,7 @@
           <p:cNvPr id="7" name="">
             <a:extLst xmlns:a="http://schemas.openxmlformats.org/drawingml/2006/main">
               <a:ext uri="{FF2B5EF4-FFF2-40B4-BE49-F238E27FC236}">
-                <a16:creationId xmlns:a16="http://schemas.microsoft.com/office/drawing/2014/main" id="{C5A89068-EFD7-483C-AAD4-3848436DF770}"/>
+                <a16:creationId xmlns:a16="http://schemas.microsoft.com/office/drawing/2014/main" id="{8AD74615-82DC-4B29-B32E-1ED4DA5887CB}"/>
               </a:ext>
             </a:extLst>
           </p:cNvPr>
@@ -8343,7 +7730,7 @@
           <p:cNvPr id="8" name="">
             <a:extLst xmlns:a="http://schemas.openxmlformats.org/drawingml/2006/main">
               <a:ext uri="{FF2B5EF4-FFF2-40B4-BE49-F238E27FC236}">
-                <a16:creationId xmlns:a16="http://schemas.microsoft.com/office/drawing/2014/main" id="{BBBB70A9-477E-4597-B930-3F3EE8E12915}"/>
+                <a16:creationId xmlns:a16="http://schemas.microsoft.com/office/drawing/2014/main" id="{4151C2AA-0153-46A8-AC6B-2123C9139957}"/>
               </a:ext>
             </a:extLst>
           </p:cNvPr>
@@ -8390,7 +7777,7 @@
                 <a:ea typeface="Heiti TC"/>
                 <a:cs typeface="Heiti TC"/>
               </a:rPr>
-              <a:t>由上至下執行。結果會出現在格子下方</a:t>
+              <a:t>按程式格左邊的 ▶，每次執行一格。結果顯示在下方</a:t>
             </a:r>
           </a:p>
         </p:txBody>
@@ -8400,7 +7787,7 @@
           <p:cNvPr id="9" name="">
             <a:extLst xmlns:a="http://schemas.openxmlformats.org/drawingml/2006/main">
               <a:ext uri="{FF2B5EF4-FFF2-40B4-BE49-F238E27FC236}">
-                <a16:creationId xmlns:a16="http://schemas.microsoft.com/office/drawing/2014/main" id="{630A1F6E-CE73-4E22-8FE3-76AFACD68F8B}"/>
+                <a16:creationId xmlns:a16="http://schemas.microsoft.com/office/drawing/2014/main" id="{891F7909-D7AE-4E8A-BEDF-1AEEE5385A55}"/>
               </a:ext>
             </a:extLst>
           </p:cNvPr>
@@ -8447,7 +7834,7 @@
                 <a:ea typeface="Arial"/>
                 <a:cs typeface="Arial"/>
               </a:rPr>
-              <a:t>Run from top to bottom. Results appear below each cell</a:t>
+              <a:t>Click ▶ on the left of a code cell. Run one cell at a time</a:t>
             </a:r>
           </a:p>
         </p:txBody>
@@ -8457,7 +7844,7 @@
           <p:cNvPr id="10" name="">
             <a:extLst xmlns:a="http://schemas.openxmlformats.org/drawingml/2006/main">
               <a:ext uri="{FF2B5EF4-FFF2-40B4-BE49-F238E27FC236}">
-                <a16:creationId xmlns:a16="http://schemas.microsoft.com/office/drawing/2014/main" id="{092248AF-6783-4B1D-87EF-F23EBE6A2B4F}"/>
+                <a16:creationId xmlns:a16="http://schemas.microsoft.com/office/drawing/2014/main" id="{9A5D4704-454D-40BA-951B-4476A2D9E52B}"/>
               </a:ext>
             </a:extLst>
           </p:cNvPr>
@@ -8512,7 +7899,7 @@
     </p:spTree>
     <p:extLst>
       <p:ext uri="{BB962C8B-B14F-4D97-AF65-F5344CB8AC3E}">
-        <p14:creationId xmlns:p14="http://schemas.microsoft.com/office/powerpoint/2010/main" val="484002489"/>
+        <p14:creationId xmlns:p14="http://schemas.microsoft.com/office/powerpoint/2010/main" val="1398512731"/>
       </p:ext>
     </p:extLst>
   </p:cSld>
@@ -8543,7 +7930,7 @@
           <p:cNvPr id="9" name="">
             <a:extLst xmlns:a="http://schemas.openxmlformats.org/drawingml/2006/main">
               <a:ext uri="{FF2B5EF4-FFF2-40B4-BE49-F238E27FC236}">
-                <a16:creationId xmlns:a16="http://schemas.microsoft.com/office/drawing/2014/main" id="{D6753F0F-3881-4998-8790-AAB1190EB8F3}"/>
+                <a16:creationId xmlns:a16="http://schemas.microsoft.com/office/drawing/2014/main" id="{A03E7D3C-46F6-43FE-A7EC-209ABDC005CC}"/>
               </a:ext>
             </a:extLst>
           </p:cNvPr>
@@ -8600,7 +7987,7 @@
           <p:cNvPr id="2" name="">
             <a:extLst xmlns:a="http://schemas.openxmlformats.org/drawingml/2006/main">
               <a:ext uri="{FF2B5EF4-FFF2-40B4-BE49-F238E27FC236}">
-                <a16:creationId xmlns:a16="http://schemas.microsoft.com/office/drawing/2014/main" id="{D2056C5B-BC45-4352-B7BA-F333AFB0060C}"/>
+                <a16:creationId xmlns:a16="http://schemas.microsoft.com/office/drawing/2014/main" id="{E46D5B82-B02F-4766-B338-65645260C0C0}"/>
               </a:ext>
             </a:extLst>
           </p:cNvPr>
@@ -8657,7 +8044,7 @@
           <p:cNvPr id="3" name="">
             <a:extLst xmlns:a="http://schemas.openxmlformats.org/drawingml/2006/main">
               <a:ext uri="{FF2B5EF4-FFF2-40B4-BE49-F238E27FC236}">
-                <a16:creationId xmlns:a16="http://schemas.microsoft.com/office/drawing/2014/main" id="{3E8A0C08-6C1A-4384-992C-D6ADDB2FDE47}"/>
+                <a16:creationId xmlns:a16="http://schemas.microsoft.com/office/drawing/2014/main" id="{05C50630-2CEE-4076-A4DD-612303BFDD5D}"/>
               </a:ext>
             </a:extLst>
           </p:cNvPr>
@@ -8714,7 +8101,7 @@
           <p:cNvPr id="4" name="">
             <a:extLst xmlns:a="http://schemas.openxmlformats.org/drawingml/2006/main">
               <a:ext uri="{FF2B5EF4-FFF2-40B4-BE49-F238E27FC236}">
-                <a16:creationId xmlns:a16="http://schemas.microsoft.com/office/drawing/2014/main" id="{254F8240-14DA-44FF-8B78-7023B6645C63}"/>
+                <a16:creationId xmlns:a16="http://schemas.microsoft.com/office/drawing/2014/main" id="{FFD2CBE9-FC28-426E-B2F8-898860B5D43C}"/>
               </a:ext>
             </a:extLst>
           </p:cNvPr>
@@ -8794,7 +8181,7 @@
           <p:cNvPr id="5" name="">
             <a:extLst xmlns:a="http://schemas.openxmlformats.org/drawingml/2006/main">
               <a:ext uri="{FF2B5EF4-FFF2-40B4-BE49-F238E27FC236}">
-                <a16:creationId xmlns:a16="http://schemas.microsoft.com/office/drawing/2014/main" id="{0320E7B0-F8E5-4A70-BB5D-C2104224777B}"/>
+                <a16:creationId xmlns:a16="http://schemas.microsoft.com/office/drawing/2014/main" id="{8DA51167-4488-4280-A97C-0E0180C2A302}"/>
               </a:ext>
             </a:extLst>
           </p:cNvPr>
@@ -8851,7 +8238,7 @@
           <p:cNvPr id="6" name="">
             <a:extLst xmlns:a="http://schemas.openxmlformats.org/drawingml/2006/main">
               <a:ext uri="{FF2B5EF4-FFF2-40B4-BE49-F238E27FC236}">
-                <a16:creationId xmlns:a16="http://schemas.microsoft.com/office/drawing/2014/main" id="{A9BC8A7C-2765-4209-8488-EA590FBBB229}"/>
+                <a16:creationId xmlns:a16="http://schemas.microsoft.com/office/drawing/2014/main" id="{B55E5D4A-C1C4-4F2A-8BEE-30AC2A3D68EA}"/>
               </a:ext>
             </a:extLst>
           </p:cNvPr>
@@ -8908,7 +8295,7 @@
           <p:cNvPr id="7" name="">
             <a:extLst xmlns:a="http://schemas.openxmlformats.org/drawingml/2006/main">
               <a:ext uri="{FF2B5EF4-FFF2-40B4-BE49-F238E27FC236}">
-                <a16:creationId xmlns:a16="http://schemas.microsoft.com/office/drawing/2014/main" id="{ABD0C944-8E9D-4301-8907-AC6128997595}"/>
+                <a16:creationId xmlns:a16="http://schemas.microsoft.com/office/drawing/2014/main" id="{BB8CA6FD-131B-4959-A06A-D63BE936A35A}"/>
               </a:ext>
             </a:extLst>
           </p:cNvPr>
@@ -8965,7 +8352,7 @@
           <p:cNvPr id="8" name="">
             <a:extLst xmlns:a="http://schemas.openxmlformats.org/drawingml/2006/main">
               <a:ext uri="{FF2B5EF4-FFF2-40B4-BE49-F238E27FC236}">
-                <a16:creationId xmlns:a16="http://schemas.microsoft.com/office/drawing/2014/main" id="{4AA9A86F-8885-4CE0-99F2-A73684F0822D}"/>
+                <a16:creationId xmlns:a16="http://schemas.microsoft.com/office/drawing/2014/main" id="{4CF92596-AAEA-420D-B170-58DFDDEF2A70}"/>
               </a:ext>
             </a:extLst>
           </p:cNvPr>
@@ -9020,7 +8407,7 @@
     </p:spTree>
     <p:extLst>
       <p:ext uri="{BB962C8B-B14F-4D97-AF65-F5344CB8AC3E}">
-        <p14:creationId xmlns:p14="http://schemas.microsoft.com/office/powerpoint/2010/main" val="1417608982"/>
+        <p14:creationId xmlns:p14="http://schemas.microsoft.com/office/powerpoint/2010/main" val="1800504184"/>
       </p:ext>
     </p:extLst>
   </p:cSld>
@@ -9051,7 +8438,7 @@
           <p:cNvPr id="9" name="">
             <a:extLst xmlns:a="http://schemas.openxmlformats.org/drawingml/2006/main">
               <a:ext uri="{FF2B5EF4-FFF2-40B4-BE49-F238E27FC236}">
-                <a16:creationId xmlns:a16="http://schemas.microsoft.com/office/drawing/2014/main" id="{C94AA287-823B-4116-AF4D-B691DCF0106E}"/>
+                <a16:creationId xmlns:a16="http://schemas.microsoft.com/office/drawing/2014/main" id="{3E762B36-BAFB-462F-A29E-E00379E0F341}"/>
               </a:ext>
             </a:extLst>
           </p:cNvPr>
@@ -9108,7 +8495,7 @@
           <p:cNvPr id="2" name="">
             <a:extLst xmlns:a="http://schemas.openxmlformats.org/drawingml/2006/main">
               <a:ext uri="{FF2B5EF4-FFF2-40B4-BE49-F238E27FC236}">
-                <a16:creationId xmlns:a16="http://schemas.microsoft.com/office/drawing/2014/main" id="{5D6DE3F8-8BDC-42AF-BD01-3DEC12DC0BA8}"/>
+                <a16:creationId xmlns:a16="http://schemas.microsoft.com/office/drawing/2014/main" id="{5A32A8C5-E6FC-4973-A2C6-AB5DDF92B224}"/>
               </a:ext>
             </a:extLst>
           </p:cNvPr>
@@ -9165,7 +8552,7 @@
           <p:cNvPr id="3" name="">
             <a:extLst xmlns:a="http://schemas.openxmlformats.org/drawingml/2006/main">
               <a:ext uri="{FF2B5EF4-FFF2-40B4-BE49-F238E27FC236}">
-                <a16:creationId xmlns:a16="http://schemas.microsoft.com/office/drawing/2014/main" id="{EC2CED75-E281-4241-AA3C-2ED41361A9B1}"/>
+                <a16:creationId xmlns:a16="http://schemas.microsoft.com/office/drawing/2014/main" id="{F835B5A4-3849-49A6-9F8F-49E101DC6D2B}"/>
               </a:ext>
             </a:extLst>
           </p:cNvPr>
@@ -9229,7 +8616,7 @@
         </p:xfrm>
         <a:graphic xmlns:a="http://schemas.openxmlformats.org/drawingml/2006/main">
           <a:graphicData uri="http://schemas.openxmlformats.org/drawingml/2006/chart">
-            <c:chart xmlns:r="http://schemas.openxmlformats.org/officeDocument/2006/relationships" xmlns:c="http://schemas.openxmlformats.org/drawingml/2006/chart" r:id="R9c05588698f44b1c"/>
+            <c:chart xmlns:r="http://schemas.openxmlformats.org/officeDocument/2006/relationships" xmlns:c="http://schemas.openxmlformats.org/drawingml/2006/chart" r:id="Ra86112d2856942a1"/>
           </a:graphicData>
         </a:graphic>
       </p:graphicFrame>
@@ -9238,7 +8625,7 @@
           <p:cNvPr id="5" name="">
             <a:extLst xmlns:a="http://schemas.openxmlformats.org/drawingml/2006/main">
               <a:ext uri="{FF2B5EF4-FFF2-40B4-BE49-F238E27FC236}">
-                <a16:creationId xmlns:a16="http://schemas.microsoft.com/office/drawing/2014/main" id="{BFF5438A-2417-46F8-81C6-A8D3BC66E2E5}"/>
+                <a16:creationId xmlns:a16="http://schemas.microsoft.com/office/drawing/2014/main" id="{254B8271-7CD4-40FE-B87D-755135BFB372}"/>
               </a:ext>
             </a:extLst>
           </p:cNvPr>
@@ -9295,7 +8682,7 @@
           <p:cNvPr id="6" name="">
             <a:extLst xmlns:a="http://schemas.openxmlformats.org/drawingml/2006/main">
               <a:ext uri="{FF2B5EF4-FFF2-40B4-BE49-F238E27FC236}">
-                <a16:creationId xmlns:a16="http://schemas.microsoft.com/office/drawing/2014/main" id="{30E3D237-F32E-40D8-9E2B-E01F5F8C5C8A}"/>
+                <a16:creationId xmlns:a16="http://schemas.microsoft.com/office/drawing/2014/main" id="{B1CC640B-9A78-4D67-9580-AFF3CB8A119B}"/>
               </a:ext>
             </a:extLst>
           </p:cNvPr>
@@ -9352,7 +8739,7 @@
           <p:cNvPr id="7" name="">
             <a:extLst xmlns:a="http://schemas.openxmlformats.org/drawingml/2006/main">
               <a:ext uri="{FF2B5EF4-FFF2-40B4-BE49-F238E27FC236}">
-                <a16:creationId xmlns:a16="http://schemas.microsoft.com/office/drawing/2014/main" id="{CB2E002C-6DEB-4B9A-B4F1-786AAE647D69}"/>
+                <a16:creationId xmlns:a16="http://schemas.microsoft.com/office/drawing/2014/main" id="{A7E3FD5C-F7E0-4A24-B05D-F4669589E359}"/>
               </a:ext>
             </a:extLst>
           </p:cNvPr>
@@ -9409,7 +8796,7 @@
           <p:cNvPr id="8" name="">
             <a:extLst xmlns:a="http://schemas.openxmlformats.org/drawingml/2006/main">
               <a:ext uri="{FF2B5EF4-FFF2-40B4-BE49-F238E27FC236}">
-                <a16:creationId xmlns:a16="http://schemas.microsoft.com/office/drawing/2014/main" id="{0DDCF9DC-1E4E-4CBD-A732-C22B068229C6}"/>
+                <a16:creationId xmlns:a16="http://schemas.microsoft.com/office/drawing/2014/main" id="{0DA20E27-0C81-42BA-BB5D-5FAA7983B518}"/>
               </a:ext>
             </a:extLst>
           </p:cNvPr>
@@ -9464,7 +8851,7 @@
     </p:spTree>
     <p:extLst>
       <p:ext uri="{BB962C8B-B14F-4D97-AF65-F5344CB8AC3E}">
-        <p14:creationId xmlns:p14="http://schemas.microsoft.com/office/powerpoint/2010/main" val="373628861"/>
+        <p14:creationId xmlns:p14="http://schemas.microsoft.com/office/powerpoint/2010/main" val="1227967201"/>
       </p:ext>
     </p:extLst>
   </p:cSld>
@@ -9495,7 +8882,7 @@
           <p:cNvPr id="9" name="">
             <a:extLst xmlns:a="http://schemas.openxmlformats.org/drawingml/2006/main">
               <a:ext uri="{FF2B5EF4-FFF2-40B4-BE49-F238E27FC236}">
-                <a16:creationId xmlns:a16="http://schemas.microsoft.com/office/drawing/2014/main" id="{B3DB5AE9-E9CE-4579-9655-D599B04AF0B2}"/>
+                <a16:creationId xmlns:a16="http://schemas.microsoft.com/office/drawing/2014/main" id="{3BBFF7EF-9CAC-4851-972D-B6189A90AC88}"/>
               </a:ext>
             </a:extLst>
           </p:cNvPr>
@@ -9552,7 +8939,7 @@
           <p:cNvPr id="2" name="">
             <a:extLst xmlns:a="http://schemas.openxmlformats.org/drawingml/2006/main">
               <a:ext uri="{FF2B5EF4-FFF2-40B4-BE49-F238E27FC236}">
-                <a16:creationId xmlns:a16="http://schemas.microsoft.com/office/drawing/2014/main" id="{69D9F1DB-D9D8-4933-A8A1-B43C1B997C29}"/>
+                <a16:creationId xmlns:a16="http://schemas.microsoft.com/office/drawing/2014/main" id="{9A295109-42D0-4067-B4F1-3BC9C767F1DB}"/>
               </a:ext>
             </a:extLst>
           </p:cNvPr>
@@ -9609,7 +8996,7 @@
           <p:cNvPr id="3" name="">
             <a:extLst xmlns:a="http://schemas.openxmlformats.org/drawingml/2006/main">
               <a:ext uri="{FF2B5EF4-FFF2-40B4-BE49-F238E27FC236}">
-                <a16:creationId xmlns:a16="http://schemas.microsoft.com/office/drawing/2014/main" id="{E62B4DC2-DC99-4BA6-9999-18D0A0424885}"/>
+                <a16:creationId xmlns:a16="http://schemas.microsoft.com/office/drawing/2014/main" id="{98355867-FF96-4D9F-A61A-C07D2098F633}"/>
               </a:ext>
             </a:extLst>
           </p:cNvPr>
@@ -9666,7 +9053,7 @@
           <p:cNvPr id="4" name="">
             <a:extLst xmlns:a="http://schemas.openxmlformats.org/drawingml/2006/main">
               <a:ext uri="{FF2B5EF4-FFF2-40B4-BE49-F238E27FC236}">
-                <a16:creationId xmlns:a16="http://schemas.microsoft.com/office/drawing/2014/main" id="{C854E359-8C54-4C56-9E29-D8FC0F526390}"/>
+                <a16:creationId xmlns:a16="http://schemas.microsoft.com/office/drawing/2014/main" id="{D071E3C9-DFA8-4BA4-9DF7-9C21983DCED6}"/>
               </a:ext>
             </a:extLst>
           </p:cNvPr>
@@ -9746,7 +9133,7 @@
           <p:cNvPr id="5" name="">
             <a:extLst xmlns:a="http://schemas.openxmlformats.org/drawingml/2006/main">
               <a:ext uri="{FF2B5EF4-FFF2-40B4-BE49-F238E27FC236}">
-                <a16:creationId xmlns:a16="http://schemas.microsoft.com/office/drawing/2014/main" id="{53BE977D-DFAD-4828-A908-167CCA3AE470}"/>
+                <a16:creationId xmlns:a16="http://schemas.microsoft.com/office/drawing/2014/main" id="{99B8E5F0-51FF-4162-85AB-45A55B4E98B3}"/>
               </a:ext>
             </a:extLst>
           </p:cNvPr>
@@ -9793,7 +9180,7 @@
                 <a:ea typeface="Heiti TC"/>
                 <a:cs typeface="Heiti TC"/>
               </a:rPr>
-              <a:t>X 是整理好的輸入，y 是相應成績</a:t>
+              <a:t>X 是溫習時間資料，y 是相應成績</a:t>
             </a:r>
           </a:p>
         </p:txBody>
@@ -9803,7 +9190,7 @@
           <p:cNvPr id="6" name="">
             <a:extLst xmlns:a="http://schemas.openxmlformats.org/drawingml/2006/main">
               <a:ext uri="{FF2B5EF4-FFF2-40B4-BE49-F238E27FC236}">
-                <a16:creationId xmlns:a16="http://schemas.microsoft.com/office/drawing/2014/main" id="{BE44DB6E-14B3-489C-9D47-B68FE435D881}"/>
+                <a16:creationId xmlns:a16="http://schemas.microsoft.com/office/drawing/2014/main" id="{E4BC3695-36E0-4CFA-BA80-E5A3CE14870C}"/>
               </a:ext>
             </a:extLst>
           </p:cNvPr>
@@ -9850,7 +9237,7 @@
                 <a:ea typeface="Arial"/>
                 <a:cs typeface="Arial"/>
               </a:rPr>
-              <a:t>X contains prepared inputs; y contains their scores</a:t>
+              <a:t>X holds the study hours; y holds the matching scores</a:t>
             </a:r>
           </a:p>
         </p:txBody>
@@ -9860,7 +9247,7 @@
           <p:cNvPr id="7" name="">
             <a:extLst xmlns:a="http://schemas.openxmlformats.org/drawingml/2006/main">
               <a:ext uri="{FF2B5EF4-FFF2-40B4-BE49-F238E27FC236}">
-                <a16:creationId xmlns:a16="http://schemas.microsoft.com/office/drawing/2014/main" id="{AFEA4A9D-FE16-4B7A-B6A5-96CD522FABF6}"/>
+                <a16:creationId xmlns:a16="http://schemas.microsoft.com/office/drawing/2014/main" id="{8DCC6F62-3896-455C-B741-4FC523E40BA4}"/>
               </a:ext>
             </a:extLst>
           </p:cNvPr>
@@ -9917,7 +9304,7 @@
           <p:cNvPr id="8" name="">
             <a:extLst xmlns:a="http://schemas.openxmlformats.org/drawingml/2006/main">
               <a:ext uri="{FF2B5EF4-FFF2-40B4-BE49-F238E27FC236}">
-                <a16:creationId xmlns:a16="http://schemas.microsoft.com/office/drawing/2014/main" id="{D8BBAFA4-CA31-4686-8669-E9AD0E78B7C8}"/>
+                <a16:creationId xmlns:a16="http://schemas.microsoft.com/office/drawing/2014/main" id="{10257E78-B3B8-4102-AC48-E665CDBFAB16}"/>
               </a:ext>
             </a:extLst>
           </p:cNvPr>
@@ -9972,7 +9359,7 @@
     </p:spTree>
     <p:extLst>
       <p:ext uri="{BB962C8B-B14F-4D97-AF65-F5344CB8AC3E}">
-        <p14:creationId xmlns:p14="http://schemas.microsoft.com/office/powerpoint/2010/main" val="614054860"/>
+        <p14:creationId xmlns:p14="http://schemas.microsoft.com/office/powerpoint/2010/main" val="1039075646"/>
       </p:ext>
     </p:extLst>
   </p:cSld>
@@ -10003,7 +9390,7 @@
           <p:cNvPr id="9" name="">
             <a:extLst xmlns:a="http://schemas.openxmlformats.org/drawingml/2006/main">
               <a:ext uri="{FF2B5EF4-FFF2-40B4-BE49-F238E27FC236}">
-                <a16:creationId xmlns:a16="http://schemas.microsoft.com/office/drawing/2014/main" id="{233AB54C-052C-4D43-9A54-4B1975209806}"/>
+                <a16:creationId xmlns:a16="http://schemas.microsoft.com/office/drawing/2014/main" id="{CB701D4E-AED3-4A67-94E8-440AE1599FAE}"/>
               </a:ext>
             </a:extLst>
           </p:cNvPr>
@@ -10060,7 +9447,7 @@
           <p:cNvPr id="2" name="">
             <a:extLst xmlns:a="http://schemas.openxmlformats.org/drawingml/2006/main">
               <a:ext uri="{FF2B5EF4-FFF2-40B4-BE49-F238E27FC236}">
-                <a16:creationId xmlns:a16="http://schemas.microsoft.com/office/drawing/2014/main" id="{D9A4E7B3-01E1-4A07-91DB-F241FFBF3099}"/>
+                <a16:creationId xmlns:a16="http://schemas.microsoft.com/office/drawing/2014/main" id="{75D3D782-EE0F-43FC-BDB4-11DA1E6D7F26}"/>
               </a:ext>
             </a:extLst>
           </p:cNvPr>
@@ -10117,7 +9504,7 @@
           <p:cNvPr id="3" name="">
             <a:extLst xmlns:a="http://schemas.openxmlformats.org/drawingml/2006/main">
               <a:ext uri="{FF2B5EF4-FFF2-40B4-BE49-F238E27FC236}">
-                <a16:creationId xmlns:a16="http://schemas.microsoft.com/office/drawing/2014/main" id="{EDEC931E-89B7-4192-B6EE-5F8C59B9A6CD}"/>
+                <a16:creationId xmlns:a16="http://schemas.microsoft.com/office/drawing/2014/main" id="{74D22455-BD61-4FDC-A15C-5458FF189CDE}"/>
               </a:ext>
             </a:extLst>
           </p:cNvPr>
@@ -10174,7 +9561,7 @@
           <p:cNvPr id="4" name="">
             <a:extLst xmlns:a="http://schemas.openxmlformats.org/drawingml/2006/main">
               <a:ext uri="{FF2B5EF4-FFF2-40B4-BE49-F238E27FC236}">
-                <a16:creationId xmlns:a16="http://schemas.microsoft.com/office/drawing/2014/main" id="{4A4D9516-09FD-49A6-B38D-930C8C059DCE}"/>
+                <a16:creationId xmlns:a16="http://schemas.microsoft.com/office/drawing/2014/main" id="{09454130-A2ED-40C8-BADF-477771F61BB6}"/>
               </a:ext>
             </a:extLst>
           </p:cNvPr>
@@ -10254,7 +9641,7 @@
           <p:cNvPr id="5" name="">
             <a:extLst xmlns:a="http://schemas.openxmlformats.org/drawingml/2006/main">
               <a:ext uri="{FF2B5EF4-FFF2-40B4-BE49-F238E27FC236}">
-                <a16:creationId xmlns:a16="http://schemas.microsoft.com/office/drawing/2014/main" id="{E7757093-C657-49D4-A14E-CA6A2B7D2185}"/>
+                <a16:creationId xmlns:a16="http://schemas.microsoft.com/office/drawing/2014/main" id="{4CC9D1B8-D62E-442F-A15E-743E595DD8F9}"/>
               </a:ext>
             </a:extLst>
           </p:cNvPr>
@@ -10311,7 +9698,7 @@
           <p:cNvPr id="6" name="">
             <a:extLst xmlns:a="http://schemas.openxmlformats.org/drawingml/2006/main">
               <a:ext uri="{FF2B5EF4-FFF2-40B4-BE49-F238E27FC236}">
-                <a16:creationId xmlns:a16="http://schemas.microsoft.com/office/drawing/2014/main" id="{3CB41141-E72F-46A1-819B-89F1D05A5060}"/>
+                <a16:creationId xmlns:a16="http://schemas.microsoft.com/office/drawing/2014/main" id="{06867057-3A7E-41B2-8B6D-C3599792876D}"/>
               </a:ext>
             </a:extLst>
           </p:cNvPr>
@@ -10368,7 +9755,7 @@
           <p:cNvPr id="7" name="">
             <a:extLst xmlns:a="http://schemas.openxmlformats.org/drawingml/2006/main">
               <a:ext uri="{FF2B5EF4-FFF2-40B4-BE49-F238E27FC236}">
-                <a16:creationId xmlns:a16="http://schemas.microsoft.com/office/drawing/2014/main" id="{10A64BED-BC94-4CB0-AB89-3AD8C94053C5}"/>
+                <a16:creationId xmlns:a16="http://schemas.microsoft.com/office/drawing/2014/main" id="{45B7C552-6E38-46DD-8BF5-75562C1E19E4}"/>
               </a:ext>
             </a:extLst>
           </p:cNvPr>
@@ -10425,7 +9812,7 @@
           <p:cNvPr id="8" name="">
             <a:extLst xmlns:a="http://schemas.openxmlformats.org/drawingml/2006/main">
               <a:ext uri="{FF2B5EF4-FFF2-40B4-BE49-F238E27FC236}">
-                <a16:creationId xmlns:a16="http://schemas.microsoft.com/office/drawing/2014/main" id="{4D42B215-77B4-4C0C-88E1-9608B3A5DC5F}"/>
+                <a16:creationId xmlns:a16="http://schemas.microsoft.com/office/drawing/2014/main" id="{AE1C27BB-50FF-46E7-9423-442819C02C6D}"/>
               </a:ext>
             </a:extLst>
           </p:cNvPr>
@@ -10480,7 +9867,7 @@
     </p:spTree>
     <p:extLst>
       <p:ext uri="{BB962C8B-B14F-4D97-AF65-F5344CB8AC3E}">
-        <p14:creationId xmlns:p14="http://schemas.microsoft.com/office/powerpoint/2010/main" val="1875721145"/>
+        <p14:creationId xmlns:p14="http://schemas.microsoft.com/office/powerpoint/2010/main" val="860516238"/>
       </p:ext>
     </p:extLst>
   </p:cSld>

</xml_diff>

<commit_message>
Apply Astra review and add short Colab link to workshop 2
</commit_message>
<xml_diff>
--- a/workshop-2/teacher-slides.pptx
+++ b/workshop-2/teacher-slides.pptx
@@ -2,29 +2,28 @@
 <file path=ppt/presentation.xml><?xml version="1.0" encoding="utf-8"?>
 <p:presentation xmlns:p="http://schemas.openxmlformats.org/presentationml/2006/main">
   <p:sldMasterIdLst>
-    <p:sldMasterId xmlns:r="http://schemas.openxmlformats.org/officeDocument/2006/relationships" id="2147483648" r:id="R4d853885bebe4b9f"/>
+    <p:sldMasterId xmlns:r="http://schemas.openxmlformats.org/officeDocument/2006/relationships" id="2147483648" r:id="Re5f78708689c45d6"/>
   </p:sldMasterIdLst>
   <p:notesMasterIdLst>
-    <p:notesMasterId xmlns:r="http://schemas.openxmlformats.org/officeDocument/2006/relationships" r:id="R4abf4ac4412f4df6"/>
+    <p:notesMasterId xmlns:r="http://schemas.openxmlformats.org/officeDocument/2006/relationships" r:id="Rb26249ba71f142fc"/>
   </p:notesMasterIdLst>
   <p:sldIdLst>
-    <p:sldId xmlns:r="http://schemas.openxmlformats.org/officeDocument/2006/relationships" id="256" r:id="R7cb5a5eb75384b36"/>
-    <p:sldId xmlns:r="http://schemas.openxmlformats.org/officeDocument/2006/relationships" id="257" r:id="Rc861f560b2b246fb"/>
-    <p:sldId xmlns:r="http://schemas.openxmlformats.org/officeDocument/2006/relationships" id="258" r:id="R71b9f726fc7e4553"/>
-    <p:sldId xmlns:r="http://schemas.openxmlformats.org/officeDocument/2006/relationships" id="259" r:id="Rac5c713caee540c3"/>
-    <p:sldId xmlns:r="http://schemas.openxmlformats.org/officeDocument/2006/relationships" id="260" r:id="Rab78994253d84cfe"/>
-    <p:sldId xmlns:r="http://schemas.openxmlformats.org/officeDocument/2006/relationships" id="261" r:id="Rb07753d74254472e"/>
-    <p:sldId xmlns:r="http://schemas.openxmlformats.org/officeDocument/2006/relationships" id="262" r:id="Raa2792253998411f"/>
-    <p:sldId xmlns:r="http://schemas.openxmlformats.org/officeDocument/2006/relationships" id="263" r:id="R2a248d05d3a04054"/>
-    <p:sldId xmlns:r="http://schemas.openxmlformats.org/officeDocument/2006/relationships" id="264" r:id="Raf71432f082f4fb6"/>
-    <p:sldId xmlns:r="http://schemas.openxmlformats.org/officeDocument/2006/relationships" id="265" r:id="R993b5c9c0fbf426c"/>
-    <p:sldId xmlns:r="http://schemas.openxmlformats.org/officeDocument/2006/relationships" id="266" r:id="Re7f79c2c5e924d4c"/>
-    <p:sldId xmlns:r="http://schemas.openxmlformats.org/officeDocument/2006/relationships" id="267" r:id="Ra88626799e234296"/>
-    <p:sldId xmlns:r="http://schemas.openxmlformats.org/officeDocument/2006/relationships" id="268" r:id="R76f9fe003ab34a14"/>
-    <p:sldId xmlns:r="http://schemas.openxmlformats.org/officeDocument/2006/relationships" id="269" r:id="R7d93d974cbf14319"/>
-    <p:sldId xmlns:r="http://schemas.openxmlformats.org/officeDocument/2006/relationships" id="270" r:id="R209fff09d97b4f40"/>
-    <p:sldId xmlns:r="http://schemas.openxmlformats.org/officeDocument/2006/relationships" id="271" r:id="Ra3c5540b3b4b485c"/>
-    <p:sldId xmlns:r="http://schemas.openxmlformats.org/officeDocument/2006/relationships" id="272" r:id="R11c8d36a040b45f3"/>
+    <p:sldId xmlns:r="http://schemas.openxmlformats.org/officeDocument/2006/relationships" id="256" r:id="R33d92ae6c49a4975"/>
+    <p:sldId xmlns:r="http://schemas.openxmlformats.org/officeDocument/2006/relationships" id="257" r:id="Rf9d22dc1b7eb4228"/>
+    <p:sldId xmlns:r="http://schemas.openxmlformats.org/officeDocument/2006/relationships" id="258" r:id="R37b1676c188f4630"/>
+    <p:sldId xmlns:r="http://schemas.openxmlformats.org/officeDocument/2006/relationships" id="259" r:id="Rc76415c92c184a6f"/>
+    <p:sldId xmlns:r="http://schemas.openxmlformats.org/officeDocument/2006/relationships" id="260" r:id="Rac2ecc3f55204a08"/>
+    <p:sldId xmlns:r="http://schemas.openxmlformats.org/officeDocument/2006/relationships" id="261" r:id="Rc87340ac42f54904"/>
+    <p:sldId xmlns:r="http://schemas.openxmlformats.org/officeDocument/2006/relationships" id="262" r:id="R443059c9b5374d7a"/>
+    <p:sldId xmlns:r="http://schemas.openxmlformats.org/officeDocument/2006/relationships" id="263" r:id="Rad916c281e524747"/>
+    <p:sldId xmlns:r="http://schemas.openxmlformats.org/officeDocument/2006/relationships" id="264" r:id="R7e3e20db77094e95"/>
+    <p:sldId xmlns:r="http://schemas.openxmlformats.org/officeDocument/2006/relationships" id="265" r:id="R1dac2c8546d842a6"/>
+    <p:sldId xmlns:r="http://schemas.openxmlformats.org/officeDocument/2006/relationships" id="266" r:id="R9fc4e5b4ad7d4c25"/>
+    <p:sldId xmlns:r="http://schemas.openxmlformats.org/officeDocument/2006/relationships" id="267" r:id="Rba25109f9f6c492b"/>
+    <p:sldId xmlns:r="http://schemas.openxmlformats.org/officeDocument/2006/relationships" id="268" r:id="Rcd03eb230a194fd9"/>
+    <p:sldId xmlns:r="http://schemas.openxmlformats.org/officeDocument/2006/relationships" id="269" r:id="R7696bc19ddda449b"/>
+    <p:sldId xmlns:r="http://schemas.openxmlformats.org/officeDocument/2006/relationships" id="270" r:id="R5a452f86f661455e"/>
+    <p:sldId xmlns:r="http://schemas.openxmlformats.org/officeDocument/2006/relationships" id="271" r:id="Rc69f08de105e4437"/>
   </p:sldIdLst>
   <p:sldSz cx="12192000" cy="6858000"/>
   <p:notesSz cx="6858000" cy="9144000"/>
@@ -458,7 +457,7 @@
           <a:lstStyle xmlns:a="http://schemas.openxmlformats.org/drawingml/2006/main"/>
           <a:p xmlns:a="http://schemas.openxmlformats.org/drawingml/2006/main">
             <a:r>
-              <a:t>Plain cover. Removed both previous opening pages as requested. Go directly into brief cloud/Colab, Python/Jupyter and sklearn introductions. 60 minutes:10 setup;15 exploration;15 score model/R²;15 comparisons;5 reflection.</a:t>
+              <a:t>Workshop 2, 60 minutes:10 setup;15 exploration;15 score model/R²;15 comparisons;5 reflection. Brief introductions in this order: Python/Jupyter, cloud/Colab, then sklearn.</a:t>
             </a:r>
           </a:p>
         </p:txBody>
@@ -948,77 +947,7 @@
           <a:lstStyle xmlns:a="http://schemas.openxmlformats.org/drawingml/2006/main"/>
           <a:p xmlns:a="http://schemas.openxmlformats.org/drawingml/2006/main">
             <a:r>
-              <a:t>Briefconnection, about1minute. Linearregressionisasimplesupervisedmodel. LargerAI systemsalsouseexamples andneedtestingbutarenotjustasingleline orallCNNs. R²appropriateforthisregressiondemo, notuniversalAIscore. Nextworkshopclassificationinsteadnumericprediction.</a:t>
-            </a:r>
-          </a:p>
-        </p:txBody>
-      </p:sp>
-      <p:sp>
-        <p:nvSpPr>
-          <p:cNvPr id="4" name="Slide Number Placeholder 3"/>
-          <p:cNvSpPr>
-            <a:spLocks xmlns:a="http://schemas.openxmlformats.org/drawingml/2006/main" noGrp="1"/>
-          </p:cNvSpPr>
-          <p:nvPr>
-            <p:ph type="sldNum" idx="5"/>
-          </p:nvPr>
-        </p:nvSpPr>
-        <p:spPr/>
-        <p:txBody>
-          <a:bodyPr xmlns:a="http://schemas.openxmlformats.org/drawingml/2006/main"/>
-          <a:lstStyle xmlns:a="http://schemas.openxmlformats.org/drawingml/2006/main"/>
-          <a:p xmlns:a="http://schemas.openxmlformats.org/drawingml/2006/main"/>
-        </p:txBody>
-      </p:sp>
-    </p:spTree>
-  </p:cSld>
-  <p:clrMapOvr>
-    <a:masterClrMapping xmlns:a="http://schemas.openxmlformats.org/drawingml/2006/main"/>
-  </p:clrMapOvr>
-</p:notes>
-</file>
-
-<file path=ppt/notesSlides/notesSlide17.xml><?xml version="1.0" encoding="utf-8"?>
-<p:notes xmlns:p="http://schemas.openxmlformats.org/presentationml/2006/main">
-  <p:cSld>
-    <p:spTree>
-      <p:nvGrpSpPr>
-        <p:cNvPr id="1" name=""/>
-        <p:cNvGrpSpPr/>
-        <p:nvPr/>
-      </p:nvGrpSpPr>
-      <p:grpSpPr>
-        <a:xfrm xmlns:a="http://schemas.openxmlformats.org/drawingml/2006/main"/>
-      </p:grpSpPr>
-      <p:sp>
-        <p:nvSpPr>
-          <p:cNvPr id="2" name="Slide Image Placeholder 1"/>
-          <p:cNvSpPr>
-            <a:spLocks xmlns:a="http://schemas.openxmlformats.org/drawingml/2006/main" noGrp="1"/>
-          </p:cNvSpPr>
-          <p:nvPr>
-            <p:ph type="sldImg" idx="0"/>
-          </p:nvPr>
-        </p:nvSpPr>
-        <p:spPr/>
-      </p:sp>
-      <p:sp>
-        <p:nvSpPr>
-          <p:cNvPr id="3" name="Notes Placeholder 2"/>
-          <p:cNvSpPr>
-            <a:spLocks xmlns:a="http://schemas.openxmlformats.org/drawingml/2006/main" noGrp="1"/>
-          </p:cNvSpPr>
-          <p:nvPr>
-            <p:ph type="body" idx="1"/>
-          </p:nvPr>
-        </p:nvSpPr>
-        <p:spPr/>
-        <p:txBody>
-          <a:bodyPr xmlns:a="http://schemas.openxmlformats.org/drawingml/2006/main"/>
-          <a:lstStyle xmlns:a="http://schemas.openxmlformats.org/drawingml/2006/main"/>
-          <a:p xmlns:a="http://schemas.openxmlformats.org/drawingml/2006/main">
-            <a:r>
-              <a:t>Final5minutesincludingdiscussion. Inviteonepairperpoint,noadditionalworksheetrequirements. Collectworksheetanswers. Codeandplotsranlocally;teacherrehearseColabclassroomaccess.</a:t>
+              <a:t>Final discussion. Invite one pair per takeaway. Teacher transition only: next workshop predicts a class rather than a number. Explain that R² is specific to this regression task, not a universal AI score. No extra slide or worksheet question. Few observations limit confidence; an association does not establish cause. Rehearse classroom Colab access before class.</a:t>
             </a:r>
           </a:p>
         </p:txBody>
@@ -1088,7 +1017,7 @@
           <a:lstStyle xmlns:a="http://schemas.openxmlformats.org/drawingml/2006/main"/>
           <a:p xmlns:a="http://schemas.openxmlformats.org/drawingml/2006/main">
             <a:r>
-              <a:t>Brief introduction, about1 minute. Cloud computing uses remote computers accessed via internet. In Colab the browser displays the notebook and results while a remote runtime executes code. Avoid infrastructure, GPUs or networking detail. Use approved accounts and classroom access. Source:https://research.google.com/colaboratory/faq.html</a:t>
+              <a:t>Sources:https://www.python.org/doc/essays/blurb/ and https://jupyter.org/. Brief introduction, about1 minute. Python is a programming language, Jupyter Notebook a format/interface combining prose, code and outputs. Colab is a hosted notebook service, not a separate programming language. Demonstrate one cell, no installation lecture.</a:t>
             </a:r>
           </a:p>
         </p:txBody>
@@ -1158,7 +1087,7 @@
           <a:lstStyle xmlns:a="http://schemas.openxmlformats.org/drawingml/2006/main"/>
           <a:p xmlns:a="http://schemas.openxmlformats.org/drawingml/2006/main">
             <a:r>
-              <a:t>Sources:https://www.python.org/doc/essays/blurb/ and https://jupyter.org/. Brief introduction, about1 minute. Python is a programming language, Jupyter Notebook a format/interface combining prose, code and outputs. Colab is a hosted notebook service, not a separate programming language. Demonstrate one cell, no installation lecture.</a:t>
+              <a:t>Brief introduction, about1 minute. Cloud computing uses remote computers accessed via internet. In Colab the browser displays the notebook and results while a remote runtime executes code. Avoid infrastructure, GPUs or networking detail. Use approved accounts and classroom access. Source:https://research.google.com/colaboratory/faq.html</a:t>
             </a:r>
           </a:p>
         </p:txBody>
@@ -1625,7 +1554,7 @@
           <p:cNvPr id="3" name="Title">
             <a:extLst xmlns:a="http://schemas.openxmlformats.org/drawingml/2006/main">
               <a:ext uri="{FF2B5EF4-FFF2-40B4-BE49-F238E27FC236}">
-                <a16:creationId xmlns:a16="http://schemas.microsoft.com/office/drawing/2014/main" id="{81022BD8-0415-45E2-B847-481C95FADEDF}"/>
+                <a16:creationId xmlns:a16="http://schemas.microsoft.com/office/drawing/2014/main" id="{02595561-DF2B-41BE-A61C-3F39D5C21D6A}"/>
               </a:ext>
             </a:extLst>
           </p:cNvPr>
@@ -1782,7 +1711,7 @@
           <p:cNvPr id="2" name="Subtitle">
             <a:extLst xmlns:a="http://schemas.openxmlformats.org/drawingml/2006/main">
               <a:ext uri="{FF2B5EF4-FFF2-40B4-BE49-F238E27FC236}">
-                <a16:creationId xmlns:a16="http://schemas.microsoft.com/office/drawing/2014/main" id="{C7129FCE-3D46-4FE5-B2F7-C26A659DC7A3}"/>
+                <a16:creationId xmlns:a16="http://schemas.microsoft.com/office/drawing/2014/main" id="{DCBCE4F2-F01F-4AF9-B61D-F15AD75A2DD8}"/>
               </a:ext>
             </a:extLst>
           </p:cNvPr>
@@ -1956,7 +1885,7 @@
           <p:cNvPr id="2" name="Section title">
             <a:extLst xmlns:a="http://schemas.openxmlformats.org/drawingml/2006/main">
               <a:ext uri="{FF2B5EF4-FFF2-40B4-BE49-F238E27FC236}">
-                <a16:creationId xmlns:a16="http://schemas.microsoft.com/office/drawing/2014/main" id="{E8B4B7F0-BBFD-423E-9AF5-3206A41F2B58}"/>
+                <a16:creationId xmlns:a16="http://schemas.microsoft.com/office/drawing/2014/main" id="{75C691F6-9DB5-4F97-B655-C6E9E39C1FCA}"/>
               </a:ext>
             </a:extLst>
           </p:cNvPr>
@@ -2130,7 +2059,7 @@
           <p:cNvPr id="3" name="Title">
             <a:extLst xmlns:a="http://schemas.openxmlformats.org/drawingml/2006/main">
               <a:ext uri="{FF2B5EF4-FFF2-40B4-BE49-F238E27FC236}">
-                <a16:creationId xmlns:a16="http://schemas.microsoft.com/office/drawing/2014/main" id="{8B337800-F81B-46F6-8997-09F5EF32D3D7}"/>
+                <a16:creationId xmlns:a16="http://schemas.microsoft.com/office/drawing/2014/main" id="{BEBCEDA5-EA3E-43BC-AED0-0FFB7B632FFE}"/>
               </a:ext>
             </a:extLst>
           </p:cNvPr>
@@ -2287,7 +2216,7 @@
           <p:cNvPr id="2" name="Body">
             <a:extLst xmlns:a="http://schemas.openxmlformats.org/drawingml/2006/main">
               <a:ext uri="{FF2B5EF4-FFF2-40B4-BE49-F238E27FC236}">
-                <a16:creationId xmlns:a16="http://schemas.microsoft.com/office/drawing/2014/main" id="{D2CC83BF-FB09-4D1F-A03F-A86269798452}"/>
+                <a16:creationId xmlns:a16="http://schemas.microsoft.com/office/drawing/2014/main" id="{99EE3BCF-1C84-4344-8D41-575DFD6D9E19}"/>
               </a:ext>
             </a:extLst>
           </p:cNvPr>
@@ -2461,7 +2390,7 @@
           <p:cNvPr id="4" name="Title">
             <a:extLst xmlns:a="http://schemas.openxmlformats.org/drawingml/2006/main">
               <a:ext uri="{FF2B5EF4-FFF2-40B4-BE49-F238E27FC236}">
-                <a16:creationId xmlns:a16="http://schemas.microsoft.com/office/drawing/2014/main" id="{FEA45157-7923-492D-BCDE-2CC8114D473E}"/>
+                <a16:creationId xmlns:a16="http://schemas.microsoft.com/office/drawing/2014/main" id="{08518AC7-6F6E-48B5-8375-9795D63DBD1C}"/>
               </a:ext>
             </a:extLst>
           </p:cNvPr>
@@ -2618,7 +2547,7 @@
           <p:cNvPr id="2" name="Left column">
             <a:extLst xmlns:a="http://schemas.openxmlformats.org/drawingml/2006/main">
               <a:ext uri="{FF2B5EF4-FFF2-40B4-BE49-F238E27FC236}">
-                <a16:creationId xmlns:a16="http://schemas.microsoft.com/office/drawing/2014/main" id="{84A44EE1-3B15-4E79-BD45-DD27C500AA2D}"/>
+                <a16:creationId xmlns:a16="http://schemas.microsoft.com/office/drawing/2014/main" id="{B1BF3BBA-79C8-4EEC-B5A8-83256F8F27B9}"/>
               </a:ext>
             </a:extLst>
           </p:cNvPr>
@@ -2775,7 +2704,7 @@
           <p:cNvPr id="3" name="Right column">
             <a:extLst xmlns:a="http://schemas.openxmlformats.org/drawingml/2006/main">
               <a:ext uri="{FF2B5EF4-FFF2-40B4-BE49-F238E27FC236}">
-                <a16:creationId xmlns:a16="http://schemas.microsoft.com/office/drawing/2014/main" id="{53CF0093-4AE9-42B6-9F0F-DC2ACAA949D3}"/>
+                <a16:creationId xmlns:a16="http://schemas.microsoft.com/office/drawing/2014/main" id="{B845BC24-54E1-42AE-8727-44690BA2C47D}"/>
               </a:ext>
             </a:extLst>
           </p:cNvPr>
@@ -2949,7 +2878,7 @@
           <p:cNvPr id="3" name="Title">
             <a:extLst xmlns:a="http://schemas.openxmlformats.org/drawingml/2006/main">
               <a:ext uri="{FF2B5EF4-FFF2-40B4-BE49-F238E27FC236}">
-                <a16:creationId xmlns:a16="http://schemas.microsoft.com/office/drawing/2014/main" id="{CD1B5833-392E-44BC-BE5D-9FB29FB23CAC}"/>
+                <a16:creationId xmlns:a16="http://schemas.microsoft.com/office/drawing/2014/main" id="{8BA98C5A-8B1F-4B7B-B66B-AFAEE2636693}"/>
               </a:ext>
             </a:extLst>
           </p:cNvPr>
@@ -3106,7 +3035,7 @@
           <p:cNvPr id="2" name="Left column">
             <a:extLst xmlns:a="http://schemas.openxmlformats.org/drawingml/2006/main">
               <a:ext uri="{FF2B5EF4-FFF2-40B4-BE49-F238E27FC236}">
-                <a16:creationId xmlns:a16="http://schemas.microsoft.com/office/drawing/2014/main" id="{1B56DB60-AE0D-4E4A-A20B-6F091080ABBF}"/>
+                <a16:creationId xmlns:a16="http://schemas.microsoft.com/office/drawing/2014/main" id="{C5C3B41B-53B8-4D70-85BB-E8CF3F57DF70}"/>
               </a:ext>
             </a:extLst>
           </p:cNvPr>
@@ -3301,12 +3230,12 @@
   </p:cSld>
   <p:clrMap bg1="lt1" tx1="dk1" bg2="lt2" tx2="dk2" accent1="accent1" accent2="accent2" accent3="accent3" accent4="accent4" accent5="accent5" accent6="accent6" hlink="hlink" folHlink="folHlink"/>
   <p:sldLayoutIdLst>
-    <p:sldLayoutId xmlns:r="http://schemas.openxmlformats.org/officeDocument/2006/relationships" id="2147483649" r:id="R0bb1d2b51be94b80"/>
-    <p:sldLayoutId xmlns:r="http://schemas.openxmlformats.org/officeDocument/2006/relationships" id="2147483650" r:id="R0376a1f64c7b4751"/>
-    <p:sldLayoutId xmlns:r="http://schemas.openxmlformats.org/officeDocument/2006/relationships" id="2147483651" r:id="Rba7198dc865943b6"/>
-    <p:sldLayoutId xmlns:r="http://schemas.openxmlformats.org/officeDocument/2006/relationships" id="2147483652" r:id="R81833541569f4054"/>
-    <p:sldLayoutId xmlns:r="http://schemas.openxmlformats.org/officeDocument/2006/relationships" id="2147483653" r:id="R65f55f1cdffb4661"/>
-    <p:sldLayoutId xmlns:r="http://schemas.openxmlformats.org/officeDocument/2006/relationships" id="2147483654" r:id="Rd2c5babfb37846a3"/>
+    <p:sldLayoutId xmlns:r="http://schemas.openxmlformats.org/officeDocument/2006/relationships" id="2147483649" r:id="Rb812df659f1d4424"/>
+    <p:sldLayoutId xmlns:r="http://schemas.openxmlformats.org/officeDocument/2006/relationships" id="2147483650" r:id="Rec614fb0798f4429"/>
+    <p:sldLayoutId xmlns:r="http://schemas.openxmlformats.org/officeDocument/2006/relationships" id="2147483651" r:id="Raff620927a6f4a90"/>
+    <p:sldLayoutId xmlns:r="http://schemas.openxmlformats.org/officeDocument/2006/relationships" id="2147483652" r:id="Re62b8e56adac4138"/>
+    <p:sldLayoutId xmlns:r="http://schemas.openxmlformats.org/officeDocument/2006/relationships" id="2147483653" r:id="R6c24f1b86926449a"/>
+    <p:sldLayoutId xmlns:r="http://schemas.openxmlformats.org/officeDocument/2006/relationships" id="2147483654" r:id="Rc37cdc6e96934c0a"/>
   </p:sldLayoutIdLst>
   <p:txStyles>
     <p:titleStyle>
@@ -8612,7 +8541,7 @@
           <p:cNvPr id="6" name="">
             <a:extLst xmlns:a="http://schemas.openxmlformats.org/drawingml/2006/main">
               <a:ext uri="{FF2B5EF4-FFF2-40B4-BE49-F238E27FC236}">
-                <a16:creationId xmlns:a16="http://schemas.microsoft.com/office/drawing/2014/main" id="{2FB0E66B-A6A7-46EC-B862-AB9A15F8749F}"/>
+                <a16:creationId xmlns:a16="http://schemas.microsoft.com/office/drawing/2014/main" id="{8A0CD298-574D-48E3-B809-CBF860A5AB10}"/>
               </a:ext>
             </a:extLst>
           </p:cNvPr>
@@ -8680,7 +8609,7 @@
           <p:cNvPr id="2" name="">
             <a:extLst xmlns:a="http://schemas.openxmlformats.org/drawingml/2006/main">
               <a:ext uri="{FF2B5EF4-FFF2-40B4-BE49-F238E27FC236}">
-                <a16:creationId xmlns:a16="http://schemas.microsoft.com/office/drawing/2014/main" id="{49AD2669-1DDD-4CA3-B6A9-E1A5148F7144}"/>
+                <a16:creationId xmlns:a16="http://schemas.microsoft.com/office/drawing/2014/main" id="{90F4A3DD-9E44-42E0-9216-C7C0CBBB2D43}"/>
               </a:ext>
             </a:extLst>
           </p:cNvPr>
@@ -8748,7 +8677,7 @@
           <p:cNvPr id="3" name="">
             <a:extLst xmlns:a="http://schemas.openxmlformats.org/drawingml/2006/main">
               <a:ext uri="{FF2B5EF4-FFF2-40B4-BE49-F238E27FC236}">
-                <a16:creationId xmlns:a16="http://schemas.microsoft.com/office/drawing/2014/main" id="{7D6B86AC-68E9-429B-A6F9-1B9CB87B4234}"/>
+                <a16:creationId xmlns:a16="http://schemas.microsoft.com/office/drawing/2014/main" id="{65B58134-D4D9-42E5-A98D-048A2FE1A583}"/>
               </a:ext>
             </a:extLst>
           </p:cNvPr>
@@ -8816,7 +8745,7 @@
           <p:cNvPr id="4" name="">
             <a:extLst xmlns:a="http://schemas.openxmlformats.org/drawingml/2006/main">
               <a:ext uri="{FF2B5EF4-FFF2-40B4-BE49-F238E27FC236}">
-                <a16:creationId xmlns:a16="http://schemas.microsoft.com/office/drawing/2014/main" id="{9CFC97D5-A22F-4CEA-9C65-AB891AEB9B67}"/>
+                <a16:creationId xmlns:a16="http://schemas.microsoft.com/office/drawing/2014/main" id="{B5A89D1E-8AA6-458E-889A-CF556BD890B7}"/>
               </a:ext>
             </a:extLst>
           </p:cNvPr>
@@ -8884,7 +8813,7 @@
           <p:cNvPr id="5" name="">
             <a:extLst xmlns:a="http://schemas.openxmlformats.org/drawingml/2006/main">
               <a:ext uri="{FF2B5EF4-FFF2-40B4-BE49-F238E27FC236}">
-                <a16:creationId xmlns:a16="http://schemas.microsoft.com/office/drawing/2014/main" id="{DE116EA3-0595-417D-AA41-4FF4254D4F50}"/>
+                <a16:creationId xmlns:a16="http://schemas.microsoft.com/office/drawing/2014/main" id="{E827903D-FEF7-49FE-939F-41E9C4EEDF7F}"/>
               </a:ext>
             </a:extLst>
           </p:cNvPr>
@@ -8950,7 +8879,7 @@
     </p:spTree>
     <p:extLst>
       <p:ext uri="{BB962C8B-B14F-4D97-AF65-F5344CB8AC3E}">
-        <p14:creationId xmlns:p14="http://schemas.microsoft.com/office/powerpoint/2010/main" val="412473767"/>
+        <p14:creationId xmlns:p14="http://schemas.microsoft.com/office/powerpoint/2010/main" val="1180266886"/>
       </p:ext>
     </p:extLst>
   </p:cSld>
@@ -8981,7 +8910,7 @@
           <p:cNvPr id="9" name="">
             <a:extLst xmlns:a="http://schemas.openxmlformats.org/drawingml/2006/main">
               <a:ext uri="{FF2B5EF4-FFF2-40B4-BE49-F238E27FC236}">
-                <a16:creationId xmlns:a16="http://schemas.microsoft.com/office/drawing/2014/main" id="{C7AFE32E-80A0-42E0-9842-15F7CDF7116E}"/>
+                <a16:creationId xmlns:a16="http://schemas.microsoft.com/office/drawing/2014/main" id="{DF1629A2-3361-47B4-A248-4EDA750E9773}"/>
               </a:ext>
             </a:extLst>
           </p:cNvPr>
@@ -9049,7 +8978,7 @@
           <p:cNvPr id="2" name="">
             <a:extLst xmlns:a="http://schemas.openxmlformats.org/drawingml/2006/main">
               <a:ext uri="{FF2B5EF4-FFF2-40B4-BE49-F238E27FC236}">
-                <a16:creationId xmlns:a16="http://schemas.microsoft.com/office/drawing/2014/main" id="{4A458854-30D2-4068-95B9-26D7892DA150}"/>
+                <a16:creationId xmlns:a16="http://schemas.microsoft.com/office/drawing/2014/main" id="{9979B2F3-FB3C-4207-BBFC-F4EAF4C64655}"/>
               </a:ext>
             </a:extLst>
           </p:cNvPr>
@@ -9117,7 +9046,7 @@
           <p:cNvPr id="3" name="">
             <a:extLst xmlns:a="http://schemas.openxmlformats.org/drawingml/2006/main">
               <a:ext uri="{FF2B5EF4-FFF2-40B4-BE49-F238E27FC236}">
-                <a16:creationId xmlns:a16="http://schemas.microsoft.com/office/drawing/2014/main" id="{91D66B61-0D79-4EA5-8754-E7ABF2A3A5F8}"/>
+                <a16:creationId xmlns:a16="http://schemas.microsoft.com/office/drawing/2014/main" id="{3DC40897-FD20-4661-9395-DCECAF1F8F9D}"/>
               </a:ext>
             </a:extLst>
           </p:cNvPr>
@@ -9185,7 +9114,7 @@
           <p:cNvPr id="4" name="">
             <a:extLst xmlns:a="http://schemas.openxmlformats.org/drawingml/2006/main">
               <a:ext uri="{FF2B5EF4-FFF2-40B4-BE49-F238E27FC236}">
-                <a16:creationId xmlns:a16="http://schemas.microsoft.com/office/drawing/2014/main" id="{8F5CDF98-BAE4-47A0-BA7F-00834A6D07B8}"/>
+                <a16:creationId xmlns:a16="http://schemas.microsoft.com/office/drawing/2014/main" id="{6C7C0612-2F33-46E2-85DC-D5424B17A53A}"/>
               </a:ext>
             </a:extLst>
           </p:cNvPr>
@@ -9253,7 +9182,7 @@
           <p:cNvPr id="5" name="Chart">
             <a:extLst xmlns:a="http://schemas.openxmlformats.org/drawingml/2006/main">
               <a:ext uri="{FF2B5EF4-FFF2-40B4-BE49-F238E27FC236}">
-                <a16:creationId xmlns:a16="http://schemas.microsoft.com/office/drawing/2014/main" id="{BDA016F6-E4CA-45BD-8A33-4D85876CABC2}"/>
+                <a16:creationId xmlns:a16="http://schemas.microsoft.com/office/drawing/2014/main" id="{C748A0F8-7BF3-41F9-866F-F758FB30A1DB}"/>
               </a:ext>
             </a:extLst>
           </p:cNvPr>
@@ -9266,7 +9195,7 @@
         </p:xfrm>
         <a:graphic xmlns:a="http://schemas.openxmlformats.org/drawingml/2006/main">
           <a:graphicData uri="http://schemas.openxmlformats.org/drawingml/2006/chart">
-            <c:chart xmlns:r="http://schemas.openxmlformats.org/officeDocument/2006/relationships" xmlns:c="http://schemas.openxmlformats.org/drawingml/2006/chart" r:id="Rca0e84cd2ecd4bc4"/>
+            <c:chart xmlns:r="http://schemas.openxmlformats.org/officeDocument/2006/relationships" xmlns:c="http://schemas.openxmlformats.org/drawingml/2006/chart" r:id="R5140d2a8d5bc4953"/>
           </a:graphicData>
         </a:graphic>
       </p:graphicFrame>
@@ -9275,7 +9204,7 @@
           <p:cNvPr id="6" name="">
             <a:extLst xmlns:a="http://schemas.openxmlformats.org/drawingml/2006/main">
               <a:ext uri="{FF2B5EF4-FFF2-40B4-BE49-F238E27FC236}">
-                <a16:creationId xmlns:a16="http://schemas.microsoft.com/office/drawing/2014/main" id="{3351A6E7-A134-4C24-ACF9-1A5084FEDEB9}"/>
+                <a16:creationId xmlns:a16="http://schemas.microsoft.com/office/drawing/2014/main" id="{5CFA7496-2D24-4534-8AAE-CEA0674BAB70}"/>
               </a:ext>
             </a:extLst>
           </p:cNvPr>
@@ -9343,7 +9272,7 @@
           <p:cNvPr id="7" name="Chart">
             <a:extLst xmlns:a="http://schemas.openxmlformats.org/drawingml/2006/main">
               <a:ext uri="{FF2B5EF4-FFF2-40B4-BE49-F238E27FC236}">
-                <a16:creationId xmlns:a16="http://schemas.microsoft.com/office/drawing/2014/main" id="{3856EE6A-EBBF-467F-93C8-0CA99AFE6603}"/>
+                <a16:creationId xmlns:a16="http://schemas.microsoft.com/office/drawing/2014/main" id="{CAEEA3DA-BB16-4A67-9717-868691828BB8}"/>
               </a:ext>
             </a:extLst>
           </p:cNvPr>
@@ -9356,7 +9285,7 @@
         </p:xfrm>
         <a:graphic xmlns:a="http://schemas.openxmlformats.org/drawingml/2006/main">
           <a:graphicData uri="http://schemas.openxmlformats.org/drawingml/2006/chart">
-            <c:chart xmlns:r="http://schemas.openxmlformats.org/officeDocument/2006/relationships" xmlns:c="http://schemas.openxmlformats.org/drawingml/2006/chart" r:id="Rf5637d2d93694bdb"/>
+            <c:chart xmlns:r="http://schemas.openxmlformats.org/officeDocument/2006/relationships" xmlns:c="http://schemas.openxmlformats.org/drawingml/2006/chart" r:id="R594b7f2683dc4833"/>
           </a:graphicData>
         </a:graphic>
       </p:graphicFrame>
@@ -9365,7 +9294,7 @@
           <p:cNvPr id="8" name="">
             <a:extLst xmlns:a="http://schemas.openxmlformats.org/drawingml/2006/main">
               <a:ext uri="{FF2B5EF4-FFF2-40B4-BE49-F238E27FC236}">
-                <a16:creationId xmlns:a16="http://schemas.microsoft.com/office/drawing/2014/main" id="{2BCB43C1-7305-447D-8F83-FB4E9D92BA81}"/>
+                <a16:creationId xmlns:a16="http://schemas.microsoft.com/office/drawing/2014/main" id="{6F86CF23-A598-4DDF-AEDB-DE5D7E964763}"/>
               </a:ext>
             </a:extLst>
           </p:cNvPr>
@@ -9431,7 +9360,7 @@
     </p:spTree>
     <p:extLst>
       <p:ext uri="{BB962C8B-B14F-4D97-AF65-F5344CB8AC3E}">
-        <p14:creationId xmlns:p14="http://schemas.microsoft.com/office/powerpoint/2010/main" val="453136726"/>
+        <p14:creationId xmlns:p14="http://schemas.microsoft.com/office/powerpoint/2010/main" val="668223172"/>
       </p:ext>
     </p:extLst>
   </p:cSld>
@@ -9462,7 +9391,7 @@
           <p:cNvPr id="13" name="">
             <a:extLst xmlns:a="http://schemas.openxmlformats.org/drawingml/2006/main">
               <a:ext uri="{FF2B5EF4-FFF2-40B4-BE49-F238E27FC236}">
-                <a16:creationId xmlns:a16="http://schemas.microsoft.com/office/drawing/2014/main" id="{0DC6B314-C343-41C0-8211-27F9D02D8744}"/>
+                <a16:creationId xmlns:a16="http://schemas.microsoft.com/office/drawing/2014/main" id="{75C81E80-D855-4C6E-AE24-C85D154BEC39}"/>
               </a:ext>
             </a:extLst>
           </p:cNvPr>
@@ -9530,7 +9459,7 @@
           <p:cNvPr id="2" name="">
             <a:extLst xmlns:a="http://schemas.openxmlformats.org/drawingml/2006/main">
               <a:ext uri="{FF2B5EF4-FFF2-40B4-BE49-F238E27FC236}">
-                <a16:creationId xmlns:a16="http://schemas.microsoft.com/office/drawing/2014/main" id="{D1D4CB7D-C501-43C5-8FFC-43CE9157A00A}"/>
+                <a16:creationId xmlns:a16="http://schemas.microsoft.com/office/drawing/2014/main" id="{005A2D92-DDFD-4EA9-8067-150660BA9ECD}"/>
               </a:ext>
             </a:extLst>
           </p:cNvPr>
@@ -9598,7 +9527,7 @@
           <p:cNvPr id="3" name="">
             <a:extLst xmlns:a="http://schemas.openxmlformats.org/drawingml/2006/main">
               <a:ext uri="{FF2B5EF4-FFF2-40B4-BE49-F238E27FC236}">
-                <a16:creationId xmlns:a16="http://schemas.microsoft.com/office/drawing/2014/main" id="{87EA1DB5-9F59-4223-AEF4-9214D10BB525}"/>
+                <a16:creationId xmlns:a16="http://schemas.microsoft.com/office/drawing/2014/main" id="{11F60FAE-64D6-4901-A0F7-49F7897C54C7}"/>
               </a:ext>
             </a:extLst>
           </p:cNvPr>
@@ -9666,7 +9595,7 @@
           <p:cNvPr id="4" name="">
             <a:extLst xmlns:a="http://schemas.openxmlformats.org/drawingml/2006/main">
               <a:ext uri="{FF2B5EF4-FFF2-40B4-BE49-F238E27FC236}">
-                <a16:creationId xmlns:a16="http://schemas.microsoft.com/office/drawing/2014/main" id="{186E1494-565E-41DC-A486-D11FCB1630BC}"/>
+                <a16:creationId xmlns:a16="http://schemas.microsoft.com/office/drawing/2014/main" id="{8BFAA2D5-7942-4B56-8BB4-220B3018D0C2}"/>
               </a:ext>
             </a:extLst>
           </p:cNvPr>
@@ -9734,7 +9663,7 @@
           <p:cNvPr id="5" name="">
             <a:extLst xmlns:a="http://schemas.openxmlformats.org/drawingml/2006/main">
               <a:ext uri="{FF2B5EF4-FFF2-40B4-BE49-F238E27FC236}">
-                <a16:creationId xmlns:a16="http://schemas.microsoft.com/office/drawing/2014/main" id="{87AA94A5-283B-40F3-A41F-9768DCE732AE}"/>
+                <a16:creationId xmlns:a16="http://schemas.microsoft.com/office/drawing/2014/main" id="{2F639E94-249E-4E20-B454-7799E01FD592}"/>
               </a:ext>
             </a:extLst>
           </p:cNvPr>
@@ -9802,7 +9731,7 @@
           <p:cNvPr id="6" name="">
             <a:extLst xmlns:a="http://schemas.openxmlformats.org/drawingml/2006/main">
               <a:ext uri="{FF2B5EF4-FFF2-40B4-BE49-F238E27FC236}">
-                <a16:creationId xmlns:a16="http://schemas.microsoft.com/office/drawing/2014/main" id="{8B9AB3A9-5069-4722-8828-D2D8D5A2B3F5}"/>
+                <a16:creationId xmlns:a16="http://schemas.microsoft.com/office/drawing/2014/main" id="{56CC419A-538B-451C-BC9A-0A7B04B536D4}"/>
               </a:ext>
             </a:extLst>
           </p:cNvPr>
@@ -9870,7 +9799,7 @@
           <p:cNvPr id="7" name="">
             <a:extLst xmlns:a="http://schemas.openxmlformats.org/drawingml/2006/main">
               <a:ext uri="{FF2B5EF4-FFF2-40B4-BE49-F238E27FC236}">
-                <a16:creationId xmlns:a16="http://schemas.microsoft.com/office/drawing/2014/main" id="{E24F5791-D375-44D7-8EC9-85104E6AA9EB}"/>
+                <a16:creationId xmlns:a16="http://schemas.microsoft.com/office/drawing/2014/main" id="{02460DB1-F99E-41A3-A267-83B9B4940229}"/>
               </a:ext>
             </a:extLst>
           </p:cNvPr>
@@ -9938,7 +9867,7 @@
           <p:cNvPr id="8" name="">
             <a:extLst xmlns:a="http://schemas.openxmlformats.org/drawingml/2006/main">
               <a:ext uri="{FF2B5EF4-FFF2-40B4-BE49-F238E27FC236}">
-                <a16:creationId xmlns:a16="http://schemas.microsoft.com/office/drawing/2014/main" id="{3FF77469-AC2D-4D23-8425-582D17930956}"/>
+                <a16:creationId xmlns:a16="http://schemas.microsoft.com/office/drawing/2014/main" id="{78F2C9F5-462B-4169-B0E5-96BAC0CAFED9}"/>
               </a:ext>
             </a:extLst>
           </p:cNvPr>
@@ -10006,7 +9935,7 @@
           <p:cNvPr id="9" name="">
             <a:extLst xmlns:a="http://schemas.openxmlformats.org/drawingml/2006/main">
               <a:ext uri="{FF2B5EF4-FFF2-40B4-BE49-F238E27FC236}">
-                <a16:creationId xmlns:a16="http://schemas.microsoft.com/office/drawing/2014/main" id="{EEF0FFD7-C370-46D8-A5BC-24809A670880}"/>
+                <a16:creationId xmlns:a16="http://schemas.microsoft.com/office/drawing/2014/main" id="{38C0282A-684D-4249-A0F5-EC955757B625}"/>
               </a:ext>
             </a:extLst>
           </p:cNvPr>
@@ -10074,7 +10003,7 @@
           <p:cNvPr id="10" name="">
             <a:extLst xmlns:a="http://schemas.openxmlformats.org/drawingml/2006/main">
               <a:ext uri="{FF2B5EF4-FFF2-40B4-BE49-F238E27FC236}">
-                <a16:creationId xmlns:a16="http://schemas.microsoft.com/office/drawing/2014/main" id="{901DADEB-9CB8-433D-A0D0-EB4C75F76EB9}"/>
+                <a16:creationId xmlns:a16="http://schemas.microsoft.com/office/drawing/2014/main" id="{47720D98-D1CE-4297-9FC1-448606B53788}"/>
               </a:ext>
             </a:extLst>
           </p:cNvPr>
@@ -10142,7 +10071,7 @@
           <p:cNvPr id="11" name="">
             <a:extLst xmlns:a="http://schemas.openxmlformats.org/drawingml/2006/main">
               <a:ext uri="{FF2B5EF4-FFF2-40B4-BE49-F238E27FC236}">
-                <a16:creationId xmlns:a16="http://schemas.microsoft.com/office/drawing/2014/main" id="{E32B86C3-FB67-46AD-A96A-61BAFFC56C83}"/>
+                <a16:creationId xmlns:a16="http://schemas.microsoft.com/office/drawing/2014/main" id="{00390B03-C8CC-4C3D-B1B6-7F989912E9E7}"/>
               </a:ext>
             </a:extLst>
           </p:cNvPr>
@@ -10210,7 +10139,7 @@
           <p:cNvPr id="12" name="">
             <a:extLst xmlns:a="http://schemas.openxmlformats.org/drawingml/2006/main">
               <a:ext uri="{FF2B5EF4-FFF2-40B4-BE49-F238E27FC236}">
-                <a16:creationId xmlns:a16="http://schemas.microsoft.com/office/drawing/2014/main" id="{1D86FCB7-CA26-4947-B347-1813BE04F0B7}"/>
+                <a16:creationId xmlns:a16="http://schemas.microsoft.com/office/drawing/2014/main" id="{2B3E2303-6B83-46E9-9F88-A85F0C66E824}"/>
               </a:ext>
             </a:extLst>
           </p:cNvPr>
@@ -10276,7 +10205,7 @@
     </p:spTree>
     <p:extLst>
       <p:ext uri="{BB962C8B-B14F-4D97-AF65-F5344CB8AC3E}">
-        <p14:creationId xmlns:p14="http://schemas.microsoft.com/office/powerpoint/2010/main" val="1655247047"/>
+        <p14:creationId xmlns:p14="http://schemas.microsoft.com/office/powerpoint/2010/main" val="1309165812"/>
       </p:ext>
     </p:extLst>
   </p:cSld>
@@ -10307,7 +10236,7 @@
           <p:cNvPr id="10" name="">
             <a:extLst xmlns:a="http://schemas.openxmlformats.org/drawingml/2006/main">
               <a:ext uri="{FF2B5EF4-FFF2-40B4-BE49-F238E27FC236}">
-                <a16:creationId xmlns:a16="http://schemas.microsoft.com/office/drawing/2014/main" id="{44B5EADA-90B1-4BBD-8EB0-108B8FAB755C}"/>
+                <a16:creationId xmlns:a16="http://schemas.microsoft.com/office/drawing/2014/main" id="{0D9FD59E-5347-4C64-A7AA-2AEADF75CDFF}"/>
               </a:ext>
             </a:extLst>
           </p:cNvPr>
@@ -10375,7 +10304,7 @@
           <p:cNvPr id="2" name="">
             <a:extLst xmlns:a="http://schemas.openxmlformats.org/drawingml/2006/main">
               <a:ext uri="{FF2B5EF4-FFF2-40B4-BE49-F238E27FC236}">
-                <a16:creationId xmlns:a16="http://schemas.microsoft.com/office/drawing/2014/main" id="{FA40A408-90B2-4AD9-B427-28535EEC002C}"/>
+                <a16:creationId xmlns:a16="http://schemas.microsoft.com/office/drawing/2014/main" id="{D8D58562-6A0E-4B4C-AD22-46178BDAF58F}"/>
               </a:ext>
             </a:extLst>
           </p:cNvPr>
@@ -10443,7 +10372,7 @@
           <p:cNvPr id="3" name="">
             <a:extLst xmlns:a="http://schemas.openxmlformats.org/drawingml/2006/main">
               <a:ext uri="{FF2B5EF4-FFF2-40B4-BE49-F238E27FC236}">
-                <a16:creationId xmlns:a16="http://schemas.microsoft.com/office/drawing/2014/main" id="{B1709454-BCFC-4F29-A118-06113D9DE4CC}"/>
+                <a16:creationId xmlns:a16="http://schemas.microsoft.com/office/drawing/2014/main" id="{74449E4B-C60D-4242-99B0-772C67536FD1}"/>
               </a:ext>
             </a:extLst>
           </p:cNvPr>
@@ -10511,7 +10440,7 @@
           <p:cNvPr id="4" name="">
             <a:extLst xmlns:a="http://schemas.openxmlformats.org/drawingml/2006/main">
               <a:ext uri="{FF2B5EF4-FFF2-40B4-BE49-F238E27FC236}">
-                <a16:creationId xmlns:a16="http://schemas.microsoft.com/office/drawing/2014/main" id="{209C9CBD-73C0-4DD1-8E70-968FA85012AB}"/>
+                <a16:creationId xmlns:a16="http://schemas.microsoft.com/office/drawing/2014/main" id="{45308AC6-3302-4A40-BE92-DE7FE332B35C}"/>
               </a:ext>
             </a:extLst>
           </p:cNvPr>
@@ -10789,7 +10718,7 @@
           <p:cNvPr id="5" name="">
             <a:extLst xmlns:a="http://schemas.openxmlformats.org/drawingml/2006/main">
               <a:ext uri="{FF2B5EF4-FFF2-40B4-BE49-F238E27FC236}">
-                <a16:creationId xmlns:a16="http://schemas.microsoft.com/office/drawing/2014/main" id="{D9E8CEE8-E210-4BF3-8B6E-F8FE19249703}"/>
+                <a16:creationId xmlns:a16="http://schemas.microsoft.com/office/drawing/2014/main" id="{3A439B06-BA50-496C-A4CC-943E77012358}"/>
               </a:ext>
             </a:extLst>
           </p:cNvPr>
@@ -10857,7 +10786,7 @@
           <p:cNvPr id="6" name="">
             <a:extLst xmlns:a="http://schemas.openxmlformats.org/drawingml/2006/main">
               <a:ext uri="{FF2B5EF4-FFF2-40B4-BE49-F238E27FC236}">
-                <a16:creationId xmlns:a16="http://schemas.microsoft.com/office/drawing/2014/main" id="{F24A6DBE-3358-464B-AD85-A600A0C6315A}"/>
+                <a16:creationId xmlns:a16="http://schemas.microsoft.com/office/drawing/2014/main" id="{6D6D01F9-21D8-4C7F-90BC-B7AEC8C1BC0B}"/>
               </a:ext>
             </a:extLst>
           </p:cNvPr>
@@ -10925,7 +10854,7 @@
           <p:cNvPr id="7" name="">
             <a:extLst xmlns:a="http://schemas.openxmlformats.org/drawingml/2006/main">
               <a:ext uri="{FF2B5EF4-FFF2-40B4-BE49-F238E27FC236}">
-                <a16:creationId xmlns:a16="http://schemas.microsoft.com/office/drawing/2014/main" id="{7519A212-64BD-4579-B424-BAB627B44511}"/>
+                <a16:creationId xmlns:a16="http://schemas.microsoft.com/office/drawing/2014/main" id="{5CDD8058-2512-4349-AACC-454C96AE3E7A}"/>
               </a:ext>
             </a:extLst>
           </p:cNvPr>
@@ -10993,7 +10922,7 @@
           <p:cNvPr id="8" name="">
             <a:extLst xmlns:a="http://schemas.openxmlformats.org/drawingml/2006/main">
               <a:ext uri="{FF2B5EF4-FFF2-40B4-BE49-F238E27FC236}">
-                <a16:creationId xmlns:a16="http://schemas.microsoft.com/office/drawing/2014/main" id="{982D7D38-DF14-44E7-B34F-CD1E5202B47A}"/>
+                <a16:creationId xmlns:a16="http://schemas.microsoft.com/office/drawing/2014/main" id="{A6C2626B-FB14-4482-A2ED-99C970C22F0F}"/>
               </a:ext>
             </a:extLst>
           </p:cNvPr>
@@ -11061,7 +10990,7 @@
           <p:cNvPr id="9" name="">
             <a:extLst xmlns:a="http://schemas.openxmlformats.org/drawingml/2006/main">
               <a:ext uri="{FF2B5EF4-FFF2-40B4-BE49-F238E27FC236}">
-                <a16:creationId xmlns:a16="http://schemas.microsoft.com/office/drawing/2014/main" id="{F7BBD923-0968-43C7-95FC-766CE7A3C3A6}"/>
+                <a16:creationId xmlns:a16="http://schemas.microsoft.com/office/drawing/2014/main" id="{E9FF3478-E49E-4E16-9F3A-D9E8963295D7}"/>
               </a:ext>
             </a:extLst>
           </p:cNvPr>
@@ -11127,7 +11056,7 @@
     </p:spTree>
     <p:extLst>
       <p:ext uri="{BB962C8B-B14F-4D97-AF65-F5344CB8AC3E}">
-        <p14:creationId xmlns:p14="http://schemas.microsoft.com/office/powerpoint/2010/main" val="73741307"/>
+        <p14:creationId xmlns:p14="http://schemas.microsoft.com/office/powerpoint/2010/main" val="1652827413"/>
       </p:ext>
     </p:extLst>
   </p:cSld>
@@ -11158,7 +11087,7 @@
           <p:cNvPr id="12" name="">
             <a:extLst xmlns:a="http://schemas.openxmlformats.org/drawingml/2006/main">
               <a:ext uri="{FF2B5EF4-FFF2-40B4-BE49-F238E27FC236}">
-                <a16:creationId xmlns:a16="http://schemas.microsoft.com/office/drawing/2014/main" id="{6A5D6FC5-53DB-44CD-81EA-B16761A00DAF}"/>
+                <a16:creationId xmlns:a16="http://schemas.microsoft.com/office/drawing/2014/main" id="{FB1F42B4-EDCA-418B-8FDB-CAD22504E01C}"/>
               </a:ext>
             </a:extLst>
           </p:cNvPr>
@@ -11226,7 +11155,7 @@
           <p:cNvPr id="2" name="">
             <a:extLst xmlns:a="http://schemas.openxmlformats.org/drawingml/2006/main">
               <a:ext uri="{FF2B5EF4-FFF2-40B4-BE49-F238E27FC236}">
-                <a16:creationId xmlns:a16="http://schemas.microsoft.com/office/drawing/2014/main" id="{42DBD935-0E2D-46B1-8F18-D128825A2764}"/>
+                <a16:creationId xmlns:a16="http://schemas.microsoft.com/office/drawing/2014/main" id="{213EFD66-B3AD-4332-8036-F08FA5693735}"/>
               </a:ext>
             </a:extLst>
           </p:cNvPr>
@@ -11294,7 +11223,7 @@
           <p:cNvPr id="3" name="">
             <a:extLst xmlns:a="http://schemas.openxmlformats.org/drawingml/2006/main">
               <a:ext uri="{FF2B5EF4-FFF2-40B4-BE49-F238E27FC236}">
-                <a16:creationId xmlns:a16="http://schemas.microsoft.com/office/drawing/2014/main" id="{BA750CD8-905C-4E8B-AB5C-BE3BF6F89D71}"/>
+                <a16:creationId xmlns:a16="http://schemas.microsoft.com/office/drawing/2014/main" id="{979834CC-D632-4A94-8019-E587965097BC}"/>
               </a:ext>
             </a:extLst>
           </p:cNvPr>
@@ -11362,7 +11291,7 @@
           <p:cNvPr id="4" name="">
             <a:extLst xmlns:a="http://schemas.openxmlformats.org/drawingml/2006/main">
               <a:ext uri="{FF2B5EF4-FFF2-40B4-BE49-F238E27FC236}">
-                <a16:creationId xmlns:a16="http://schemas.microsoft.com/office/drawing/2014/main" id="{63EB1426-F820-44BF-9A0A-B9BC9CF30614}"/>
+                <a16:creationId xmlns:a16="http://schemas.microsoft.com/office/drawing/2014/main" id="{09635D79-33AE-410E-814E-F63A3FBB3AF6}"/>
               </a:ext>
             </a:extLst>
           </p:cNvPr>
@@ -11430,7 +11359,7 @@
           <p:cNvPr id="5" name="Chart">
             <a:extLst xmlns:a="http://schemas.openxmlformats.org/drawingml/2006/main">
               <a:ext uri="{FF2B5EF4-FFF2-40B4-BE49-F238E27FC236}">
-                <a16:creationId xmlns:a16="http://schemas.microsoft.com/office/drawing/2014/main" id="{8ED525B5-E58E-478D-A445-C30BCBCFB495}"/>
+                <a16:creationId xmlns:a16="http://schemas.microsoft.com/office/drawing/2014/main" id="{C33E5A1E-7616-439A-9D85-866E1EC0ADE0}"/>
               </a:ext>
             </a:extLst>
           </p:cNvPr>
@@ -11443,7 +11372,7 @@
         </p:xfrm>
         <a:graphic xmlns:a="http://schemas.openxmlformats.org/drawingml/2006/main">
           <a:graphicData uri="http://schemas.openxmlformats.org/drawingml/2006/chart">
-            <c:chart xmlns:r="http://schemas.openxmlformats.org/officeDocument/2006/relationships" xmlns:c="http://schemas.openxmlformats.org/drawingml/2006/chart" r:id="Rbde9243629ea4712"/>
+            <c:chart xmlns:r="http://schemas.openxmlformats.org/officeDocument/2006/relationships" xmlns:c="http://schemas.openxmlformats.org/drawingml/2006/chart" r:id="R0180689a078e457d"/>
           </a:graphicData>
         </a:graphic>
       </p:graphicFrame>
@@ -11452,7 +11381,7 @@
           <p:cNvPr id="6" name="">
             <a:extLst xmlns:a="http://schemas.openxmlformats.org/drawingml/2006/main">
               <a:ext uri="{FF2B5EF4-FFF2-40B4-BE49-F238E27FC236}">
-                <a16:creationId xmlns:a16="http://schemas.microsoft.com/office/drawing/2014/main" id="{A1CD697D-4E95-4BF8-8358-3261F0B88D6E}"/>
+                <a16:creationId xmlns:a16="http://schemas.microsoft.com/office/drawing/2014/main" id="{94D158D6-40D4-4D37-982F-571E3923FA69}"/>
               </a:ext>
             </a:extLst>
           </p:cNvPr>
@@ -11520,7 +11449,7 @@
           <p:cNvPr id="7" name="Chart">
             <a:extLst xmlns:a="http://schemas.openxmlformats.org/drawingml/2006/main">
               <a:ext uri="{FF2B5EF4-FFF2-40B4-BE49-F238E27FC236}">
-                <a16:creationId xmlns:a16="http://schemas.microsoft.com/office/drawing/2014/main" id="{0AE178C9-7402-4B48-BA94-0AACA7ADF6E8}"/>
+                <a16:creationId xmlns:a16="http://schemas.microsoft.com/office/drawing/2014/main" id="{05D50A0F-9FD9-4F99-9D30-C8FE45254B6D}"/>
               </a:ext>
             </a:extLst>
           </p:cNvPr>
@@ -11533,7 +11462,7 @@
         </p:xfrm>
         <a:graphic xmlns:a="http://schemas.openxmlformats.org/drawingml/2006/main">
           <a:graphicData uri="http://schemas.openxmlformats.org/drawingml/2006/chart">
-            <c:chart xmlns:r="http://schemas.openxmlformats.org/officeDocument/2006/relationships" xmlns:c="http://schemas.openxmlformats.org/drawingml/2006/chart" r:id="R1135f78aba1b4566"/>
+            <c:chart xmlns:r="http://schemas.openxmlformats.org/officeDocument/2006/relationships" xmlns:c="http://schemas.openxmlformats.org/drawingml/2006/chart" r:id="R4944742eb7fb448d"/>
           </a:graphicData>
         </a:graphic>
       </p:graphicFrame>
@@ -11542,7 +11471,7 @@
           <p:cNvPr id="8" name="">
             <a:extLst xmlns:a="http://schemas.openxmlformats.org/drawingml/2006/main">
               <a:ext uri="{FF2B5EF4-FFF2-40B4-BE49-F238E27FC236}">
-                <a16:creationId xmlns:a16="http://schemas.microsoft.com/office/drawing/2014/main" id="{306610FB-1C1D-4F1E-999D-19C29F510D9E}"/>
+                <a16:creationId xmlns:a16="http://schemas.microsoft.com/office/drawing/2014/main" id="{D06B093C-6AD7-419C-B571-493BBA3138B1}"/>
               </a:ext>
             </a:extLst>
           </p:cNvPr>
@@ -11610,7 +11539,7 @@
           <p:cNvPr id="9" name="Chart">
             <a:extLst xmlns:a="http://schemas.openxmlformats.org/drawingml/2006/main">
               <a:ext uri="{FF2B5EF4-FFF2-40B4-BE49-F238E27FC236}">
-                <a16:creationId xmlns:a16="http://schemas.microsoft.com/office/drawing/2014/main" id="{531D68EE-3DC9-4CC8-BF76-D09551D27E99}"/>
+                <a16:creationId xmlns:a16="http://schemas.microsoft.com/office/drawing/2014/main" id="{19C020FD-5E88-47BB-A917-09ECBCFD1715}"/>
               </a:ext>
             </a:extLst>
           </p:cNvPr>
@@ -11623,7 +11552,7 @@
         </p:xfrm>
         <a:graphic xmlns:a="http://schemas.openxmlformats.org/drawingml/2006/main">
           <a:graphicData uri="http://schemas.openxmlformats.org/drawingml/2006/chart">
-            <c:chart xmlns:r="http://schemas.openxmlformats.org/officeDocument/2006/relationships" xmlns:c="http://schemas.openxmlformats.org/drawingml/2006/chart" r:id="Rfe19771f8b9648c1"/>
+            <c:chart xmlns:r="http://schemas.openxmlformats.org/officeDocument/2006/relationships" xmlns:c="http://schemas.openxmlformats.org/drawingml/2006/chart" r:id="R1302f8b3b3d34731"/>
           </a:graphicData>
         </a:graphic>
       </p:graphicFrame>
@@ -11632,7 +11561,7 @@
           <p:cNvPr id="10" name="">
             <a:extLst xmlns:a="http://schemas.openxmlformats.org/drawingml/2006/main">
               <a:ext uri="{FF2B5EF4-FFF2-40B4-BE49-F238E27FC236}">
-                <a16:creationId xmlns:a16="http://schemas.microsoft.com/office/drawing/2014/main" id="{37A1096B-9557-492D-BC81-0E5770868AC5}"/>
+                <a16:creationId xmlns:a16="http://schemas.microsoft.com/office/drawing/2014/main" id="{9E49026C-F811-4159-B05F-F257B2D9567F}"/>
               </a:ext>
             </a:extLst>
           </p:cNvPr>
@@ -11700,7 +11629,7 @@
           <p:cNvPr id="11" name="">
             <a:extLst xmlns:a="http://schemas.openxmlformats.org/drawingml/2006/main">
               <a:ext uri="{FF2B5EF4-FFF2-40B4-BE49-F238E27FC236}">
-                <a16:creationId xmlns:a16="http://schemas.microsoft.com/office/drawing/2014/main" id="{78628009-794A-4389-8296-FF6FC24C041F}"/>
+                <a16:creationId xmlns:a16="http://schemas.microsoft.com/office/drawing/2014/main" id="{0A282E41-9392-43D0-B097-D4CC5763FCB3}"/>
               </a:ext>
             </a:extLst>
           </p:cNvPr>
@@ -11766,7 +11695,7 @@
     </p:spTree>
     <p:extLst>
       <p:ext uri="{BB962C8B-B14F-4D97-AF65-F5344CB8AC3E}">
-        <p14:creationId xmlns:p14="http://schemas.microsoft.com/office/powerpoint/2010/main" val="1810256921"/>
+        <p14:creationId xmlns:p14="http://schemas.microsoft.com/office/powerpoint/2010/main" val="1207058902"/>
       </p:ext>
     </p:extLst>
   </p:cSld>
@@ -11797,7 +11726,7 @@
           <p:cNvPr id="14" name="">
             <a:extLst xmlns:a="http://schemas.openxmlformats.org/drawingml/2006/main">
               <a:ext uri="{FF2B5EF4-FFF2-40B4-BE49-F238E27FC236}">
-                <a16:creationId xmlns:a16="http://schemas.microsoft.com/office/drawing/2014/main" id="{58E2E1B1-FE9E-413F-9D12-81AC5A9449E6}"/>
+                <a16:creationId xmlns:a16="http://schemas.microsoft.com/office/drawing/2014/main" id="{D7B83D74-AB1D-4B35-9384-45F6DD4DACC2}"/>
               </a:ext>
             </a:extLst>
           </p:cNvPr>
@@ -11865,7 +11794,7 @@
           <p:cNvPr id="2" name="">
             <a:extLst xmlns:a="http://schemas.openxmlformats.org/drawingml/2006/main">
               <a:ext uri="{FF2B5EF4-FFF2-40B4-BE49-F238E27FC236}">
-                <a16:creationId xmlns:a16="http://schemas.microsoft.com/office/drawing/2014/main" id="{6FD8F29B-5CDD-436A-A317-083F65CD156F}"/>
+                <a16:creationId xmlns:a16="http://schemas.microsoft.com/office/drawing/2014/main" id="{69383D7E-51E6-47FF-B947-020B6B4F4FD8}"/>
               </a:ext>
             </a:extLst>
           </p:cNvPr>
@@ -11933,7 +11862,7 @@
           <p:cNvPr id="3" name="">
             <a:extLst xmlns:a="http://schemas.openxmlformats.org/drawingml/2006/main">
               <a:ext uri="{FF2B5EF4-FFF2-40B4-BE49-F238E27FC236}">
-                <a16:creationId xmlns:a16="http://schemas.microsoft.com/office/drawing/2014/main" id="{32442EF0-0F69-409D-84BE-396AF457A0F6}"/>
+                <a16:creationId xmlns:a16="http://schemas.microsoft.com/office/drawing/2014/main" id="{3403183C-BCC6-4CE1-AD40-F671D07383D8}"/>
               </a:ext>
             </a:extLst>
           </p:cNvPr>
@@ -12001,7 +11930,7 @@
           <p:cNvPr id="4" name="">
             <a:extLst xmlns:a="http://schemas.openxmlformats.org/drawingml/2006/main">
               <a:ext uri="{FF2B5EF4-FFF2-40B4-BE49-F238E27FC236}">
-                <a16:creationId xmlns:a16="http://schemas.microsoft.com/office/drawing/2014/main" id="{85C1A5C2-7165-4C78-AD16-427B067C2301}"/>
+                <a16:creationId xmlns:a16="http://schemas.microsoft.com/office/drawing/2014/main" id="{CF8D59BF-CDC1-4974-BDBD-A3D8F682B37C}"/>
               </a:ext>
             </a:extLst>
           </p:cNvPr>
@@ -12069,7 +11998,7 @@
           <p:cNvPr id="5" name="Chart">
             <a:extLst xmlns:a="http://schemas.openxmlformats.org/drawingml/2006/main">
               <a:ext uri="{FF2B5EF4-FFF2-40B4-BE49-F238E27FC236}">
-                <a16:creationId xmlns:a16="http://schemas.microsoft.com/office/drawing/2014/main" id="{63B92F69-AB1C-474A-A92E-77C0E7AB2F43}"/>
+                <a16:creationId xmlns:a16="http://schemas.microsoft.com/office/drawing/2014/main" id="{AB1BDCBC-D6CA-4665-901D-68DE6F1C2173}"/>
               </a:ext>
             </a:extLst>
           </p:cNvPr>
@@ -12082,7 +12011,7 @@
         </p:xfrm>
         <a:graphic xmlns:a="http://schemas.openxmlformats.org/drawingml/2006/main">
           <a:graphicData uri="http://schemas.openxmlformats.org/drawingml/2006/chart">
-            <c:chart xmlns:r="http://schemas.openxmlformats.org/officeDocument/2006/relationships" xmlns:c="http://schemas.openxmlformats.org/drawingml/2006/chart" r:id="Rf430a399cc14411e"/>
+            <c:chart xmlns:r="http://schemas.openxmlformats.org/officeDocument/2006/relationships" xmlns:c="http://schemas.openxmlformats.org/drawingml/2006/chart" r:id="R1c709dcae4f34d13"/>
           </a:graphicData>
         </a:graphic>
       </p:graphicFrame>
@@ -12091,7 +12020,7 @@
           <p:cNvPr id="6" name="">
             <a:extLst xmlns:a="http://schemas.openxmlformats.org/drawingml/2006/main">
               <a:ext uri="{FF2B5EF4-FFF2-40B4-BE49-F238E27FC236}">
-                <a16:creationId xmlns:a16="http://schemas.microsoft.com/office/drawing/2014/main" id="{7911E045-5FBD-4E65-909D-9F0E5145DA0B}"/>
+                <a16:creationId xmlns:a16="http://schemas.microsoft.com/office/drawing/2014/main" id="{AB848D8E-E0BA-478E-ACB6-A90A0BB61024}"/>
               </a:ext>
             </a:extLst>
           </p:cNvPr>
@@ -12159,7 +12088,7 @@
           <p:cNvPr id="7" name="">
             <a:extLst xmlns:a="http://schemas.openxmlformats.org/drawingml/2006/main">
               <a:ext uri="{FF2B5EF4-FFF2-40B4-BE49-F238E27FC236}">
-                <a16:creationId xmlns:a16="http://schemas.microsoft.com/office/drawing/2014/main" id="{9033AABB-5D35-4F13-AB69-A4C4D47469E0}"/>
+                <a16:creationId xmlns:a16="http://schemas.microsoft.com/office/drawing/2014/main" id="{7E8D5DBD-BBE9-4079-ADD2-F15078C22A27}"/>
               </a:ext>
             </a:extLst>
           </p:cNvPr>
@@ -12227,7 +12156,7 @@
           <p:cNvPr id="8" name="Chart">
             <a:extLst xmlns:a="http://schemas.openxmlformats.org/drawingml/2006/main">
               <a:ext uri="{FF2B5EF4-FFF2-40B4-BE49-F238E27FC236}">
-                <a16:creationId xmlns:a16="http://schemas.microsoft.com/office/drawing/2014/main" id="{5927AFA3-E6F0-449D-8C70-DB1619AE5E43}"/>
+                <a16:creationId xmlns:a16="http://schemas.microsoft.com/office/drawing/2014/main" id="{25616873-C3D6-4B38-88B9-EBB26E254AC2}"/>
               </a:ext>
             </a:extLst>
           </p:cNvPr>
@@ -12240,7 +12169,7 @@
         </p:xfrm>
         <a:graphic xmlns:a="http://schemas.openxmlformats.org/drawingml/2006/main">
           <a:graphicData uri="http://schemas.openxmlformats.org/drawingml/2006/chart">
-            <c:chart xmlns:r="http://schemas.openxmlformats.org/officeDocument/2006/relationships" xmlns:c="http://schemas.openxmlformats.org/drawingml/2006/chart" r:id="Rbd71579095fe4d89"/>
+            <c:chart xmlns:r="http://schemas.openxmlformats.org/officeDocument/2006/relationships" xmlns:c="http://schemas.openxmlformats.org/drawingml/2006/chart" r:id="R680edba37eda484e"/>
           </a:graphicData>
         </a:graphic>
       </p:graphicFrame>
@@ -12249,7 +12178,7 @@
           <p:cNvPr id="9" name="">
             <a:extLst xmlns:a="http://schemas.openxmlformats.org/drawingml/2006/main">
               <a:ext uri="{FF2B5EF4-FFF2-40B4-BE49-F238E27FC236}">
-                <a16:creationId xmlns:a16="http://schemas.microsoft.com/office/drawing/2014/main" id="{E0F9F1D6-CE76-4F94-91D9-BFD511339796}"/>
+                <a16:creationId xmlns:a16="http://schemas.microsoft.com/office/drawing/2014/main" id="{D9E9BE22-993B-4606-B05E-81AB8ABE34AE}"/>
               </a:ext>
             </a:extLst>
           </p:cNvPr>
@@ -12317,7 +12246,7 @@
           <p:cNvPr id="10" name="">
             <a:extLst xmlns:a="http://schemas.openxmlformats.org/drawingml/2006/main">
               <a:ext uri="{FF2B5EF4-FFF2-40B4-BE49-F238E27FC236}">
-                <a16:creationId xmlns:a16="http://schemas.microsoft.com/office/drawing/2014/main" id="{7CC2015D-81B5-4994-97AD-F57B635AB59D}"/>
+                <a16:creationId xmlns:a16="http://schemas.microsoft.com/office/drawing/2014/main" id="{A25DB4CD-E271-4FCE-9EE0-828ABE9C8176}"/>
               </a:ext>
             </a:extLst>
           </p:cNvPr>
@@ -12385,7 +12314,7 @@
           <p:cNvPr id="11" name="Chart">
             <a:extLst xmlns:a="http://schemas.openxmlformats.org/drawingml/2006/main">
               <a:ext uri="{FF2B5EF4-FFF2-40B4-BE49-F238E27FC236}">
-                <a16:creationId xmlns:a16="http://schemas.microsoft.com/office/drawing/2014/main" id="{6F0EC2E4-B4B9-479F-B6DA-05C52C2D029F}"/>
+                <a16:creationId xmlns:a16="http://schemas.microsoft.com/office/drawing/2014/main" id="{BF41C140-FD21-4F35-9261-0A07B8D636AE}"/>
               </a:ext>
             </a:extLst>
           </p:cNvPr>
@@ -12398,7 +12327,7 @@
         </p:xfrm>
         <a:graphic xmlns:a="http://schemas.openxmlformats.org/drawingml/2006/main">
           <a:graphicData uri="http://schemas.openxmlformats.org/drawingml/2006/chart">
-            <c:chart xmlns:r="http://schemas.openxmlformats.org/officeDocument/2006/relationships" xmlns:c="http://schemas.openxmlformats.org/drawingml/2006/chart" r:id="R820fe489abba4b04"/>
+            <c:chart xmlns:r="http://schemas.openxmlformats.org/officeDocument/2006/relationships" xmlns:c="http://schemas.openxmlformats.org/drawingml/2006/chart" r:id="R9fca906b88454aac"/>
           </a:graphicData>
         </a:graphic>
       </p:graphicFrame>
@@ -12407,7 +12336,7 @@
           <p:cNvPr id="12" name="">
             <a:extLst xmlns:a="http://schemas.openxmlformats.org/drawingml/2006/main">
               <a:ext uri="{FF2B5EF4-FFF2-40B4-BE49-F238E27FC236}">
-                <a16:creationId xmlns:a16="http://schemas.microsoft.com/office/drawing/2014/main" id="{D2988E04-2383-4680-B8BB-C6F81FB79F3E}"/>
+                <a16:creationId xmlns:a16="http://schemas.microsoft.com/office/drawing/2014/main" id="{7755B426-0933-4657-9C83-1EAE667FA6FE}"/>
               </a:ext>
             </a:extLst>
           </p:cNvPr>
@@ -12475,7 +12404,7 @@
           <p:cNvPr id="13" name="">
             <a:extLst xmlns:a="http://schemas.openxmlformats.org/drawingml/2006/main">
               <a:ext uri="{FF2B5EF4-FFF2-40B4-BE49-F238E27FC236}">
-                <a16:creationId xmlns:a16="http://schemas.microsoft.com/office/drawing/2014/main" id="{1DF32CA8-5542-44B9-B57F-51FAF3FD1F4D}"/>
+                <a16:creationId xmlns:a16="http://schemas.microsoft.com/office/drawing/2014/main" id="{95C52FAC-1B50-4287-9173-CC746CBF390F}"/>
               </a:ext>
             </a:extLst>
           </p:cNvPr>
@@ -12541,7 +12470,7 @@
     </p:spTree>
     <p:extLst>
       <p:ext uri="{BB962C8B-B14F-4D97-AF65-F5344CB8AC3E}">
-        <p14:creationId xmlns:p14="http://schemas.microsoft.com/office/powerpoint/2010/main" val="323469049"/>
+        <p14:creationId xmlns:p14="http://schemas.microsoft.com/office/powerpoint/2010/main" val="77881667"/>
       </p:ext>
     </p:extLst>
   </p:cSld>
@@ -12569,10 +12498,10 @@
       </p:grpSpPr>
       <p:sp>
         <p:nvSpPr>
-          <p:cNvPr id="10" name="">
+          <p:cNvPr id="8" name="">
             <a:extLst xmlns:a="http://schemas.openxmlformats.org/drawingml/2006/main">
               <a:ext uri="{FF2B5EF4-FFF2-40B4-BE49-F238E27FC236}">
-                <a16:creationId xmlns:a16="http://schemas.microsoft.com/office/drawing/2014/main" id="{9FF27B37-DC9C-48E6-BA31-D85C1752E4BF}"/>
+                <a16:creationId xmlns:a16="http://schemas.microsoft.com/office/drawing/2014/main" id="{18D64722-6D46-47C0-9DAC-D42B547DF5E7}"/>
               </a:ext>
             </a:extLst>
           </p:cNvPr>
@@ -12640,7 +12569,7 @@
           <p:cNvPr id="2" name="">
             <a:extLst xmlns:a="http://schemas.openxmlformats.org/drawingml/2006/main">
               <a:ext uri="{FF2B5EF4-FFF2-40B4-BE49-F238E27FC236}">
-                <a16:creationId xmlns:a16="http://schemas.microsoft.com/office/drawing/2014/main" id="{9157231F-2055-4F59-89CE-BCAEB670252E}"/>
+                <a16:creationId xmlns:a16="http://schemas.microsoft.com/office/drawing/2014/main" id="{FD07E1AB-C0AF-4873-807C-C1E2254A01C4}"/>
               </a:ext>
             </a:extLst>
           </p:cNvPr>
@@ -12708,7 +12637,7 @@
           <p:cNvPr id="3" name="">
             <a:extLst xmlns:a="http://schemas.openxmlformats.org/drawingml/2006/main">
               <a:ext uri="{FF2B5EF4-FFF2-40B4-BE49-F238E27FC236}">
-                <a16:creationId xmlns:a16="http://schemas.microsoft.com/office/drawing/2014/main" id="{E3E3B395-FEF6-4F37-80B6-193D4A303613}"/>
+                <a16:creationId xmlns:a16="http://schemas.microsoft.com/office/drawing/2014/main" id="{D491B036-8CB8-4E01-9DAB-8B7D44C9BE7B}"/>
               </a:ext>
             </a:extLst>
           </p:cNvPr>
@@ -12776,7 +12705,7 @@
           <p:cNvPr id="4" name="">
             <a:extLst xmlns:a="http://schemas.openxmlformats.org/drawingml/2006/main">
               <a:ext uri="{FF2B5EF4-FFF2-40B4-BE49-F238E27FC236}">
-                <a16:creationId xmlns:a16="http://schemas.microsoft.com/office/drawing/2014/main" id="{5B3EA465-3941-4509-AD83-2F924EB19E70}"/>
+                <a16:creationId xmlns:a16="http://schemas.microsoft.com/office/drawing/2014/main" id="{6BAF4837-0B6C-435A-A998-D82196A95B20}"/>
               </a:ext>
             </a:extLst>
           </p:cNvPr>
@@ -12844,7 +12773,7 @@
           <p:cNvPr id="5" name="">
             <a:extLst xmlns:a="http://schemas.openxmlformats.org/drawingml/2006/main">
               <a:ext uri="{FF2B5EF4-FFF2-40B4-BE49-F238E27FC236}">
-                <a16:creationId xmlns:a16="http://schemas.microsoft.com/office/drawing/2014/main" id="{76877868-0992-482F-90DD-2B434FF89809}"/>
+                <a16:creationId xmlns:a16="http://schemas.microsoft.com/office/drawing/2014/main" id="{8402F4BE-9302-4115-B5F5-547E9868FD23}"/>
               </a:ext>
             </a:extLst>
           </p:cNvPr>
@@ -12912,7 +12841,7 @@
           <p:cNvPr id="6" name="">
             <a:extLst xmlns:a="http://schemas.openxmlformats.org/drawingml/2006/main">
               <a:ext uri="{FF2B5EF4-FFF2-40B4-BE49-F238E27FC236}">
-                <a16:creationId xmlns:a16="http://schemas.microsoft.com/office/drawing/2014/main" id="{F9D817B1-DCE1-4B7C-ACBA-09D7BFB48849}"/>
+                <a16:creationId xmlns:a16="http://schemas.microsoft.com/office/drawing/2014/main" id="{04AD54AB-1111-4DDB-A71D-AEBF7E986423}"/>
               </a:ext>
             </a:extLst>
           </p:cNvPr>
@@ -12923,7 +12852,7 @@
         </p:nvSpPr>
         <p:spPr>
           <a:xfrm xmlns:a="http://schemas.openxmlformats.org/drawingml/2006/main">
-            <a:off x="609600" y="3286125"/>
+            <a:off x="609600" y="3667125"/>
             <a:ext cx="10668000" cy="495300"/>
           </a:xfrm>
           <a:prstGeom xmlns:a="http://schemas.openxmlformats.org/drawingml/2006/main" prst="rect">
@@ -12970,7 +12899,7 @@
                 <a:ea typeface="Heiti TC"/>
                 <a:cs typeface="Heiti TC"/>
               </a:rPr>
-              <a:t>新預測是否可靠？用未參與建模的新數據檢查</a:t>
+              <a:t>用未參與建模的新數據，比較預測與實際結果</a:t>
             </a:r>
           </a:p>
         </p:txBody>
@@ -12980,7 +12909,7 @@
           <p:cNvPr id="7" name="">
             <a:extLst xmlns:a="http://schemas.openxmlformats.org/drawingml/2006/main">
               <a:ext uri="{FF2B5EF4-FFF2-40B4-BE49-F238E27FC236}">
-                <a16:creationId xmlns:a16="http://schemas.microsoft.com/office/drawing/2014/main" id="{557298C6-FE5F-4CF0-A4A2-16915D85A5C3}"/>
+                <a16:creationId xmlns:a16="http://schemas.microsoft.com/office/drawing/2014/main" id="{2B32A9EC-25E0-4FC6-841C-54D67E0A2442}"/>
               </a:ext>
             </a:extLst>
           </p:cNvPr>
@@ -12991,7 +12920,7 @@
         </p:nvSpPr>
         <p:spPr>
           <a:xfrm xmlns:a="http://schemas.openxmlformats.org/drawingml/2006/main">
-            <a:off x="609600" y="3752850"/>
+            <a:off x="609600" y="4133850"/>
             <a:ext cx="10668000" cy="457200"/>
           </a:xfrm>
           <a:prstGeom xmlns:a="http://schemas.openxmlformats.org/drawingml/2006/main" prst="rect">
@@ -13038,151 +12967,15 @@
                 <a:ea typeface="Arial"/>
                 <a:cs typeface="Arial"/>
               </a:rPr>
-              <a:t>Reliable new predictions? Check with data not used to fit the model</a:t>
+              <a:t>Use new data kept out of fitting; compare predictions with actual results</a:t>
             </a:r>
           </a:p>
         </p:txBody>
       </p:sp>
-      <p:sp>
-        <p:nvSpPr>
-          <p:cNvPr id="8" name="">
-            <a:extLst xmlns:a="http://schemas.openxmlformats.org/drawingml/2006/main">
-              <a:ext uri="{FF2B5EF4-FFF2-40B4-BE49-F238E27FC236}">
-                <a16:creationId xmlns:a16="http://schemas.microsoft.com/office/drawing/2014/main" id="{D820E9A9-BEC9-4FA5-9D7C-591C90BD2C40}"/>
-              </a:ext>
-            </a:extLst>
-          </p:cNvPr>
-          <p:cNvSpPr>
-            <a:spLocks xmlns:a="http://schemas.openxmlformats.org/drawingml/2006/main" noGrp="1"/>
-          </p:cNvSpPr>
-          <p:nvPr/>
-        </p:nvSpPr>
-        <p:spPr>
-          <a:xfrm xmlns:a="http://schemas.openxmlformats.org/drawingml/2006/main">
-            <a:off x="609600" y="4810125"/>
-            <a:ext cx="10668000" cy="495300"/>
-          </a:xfrm>
-          <a:prstGeom xmlns:a="http://schemas.openxmlformats.org/drawingml/2006/main" prst="rect">
-            <a:avLst/>
-          </a:prstGeom>
-          <a:noFill xmlns:a="http://schemas.openxmlformats.org/drawingml/2006/main"/>
-          <a:ln xmlns:a="http://schemas.openxmlformats.org/drawingml/2006/main" w="0">
-            <a:noFill/>
-          </a:ln>
-        </p:spPr>
-        <p:txBody>
-          <a:bodyPr xmlns:a="http://schemas.openxmlformats.org/drawingml/2006/main">
-            <a:noAutofit/>
-          </a:bodyPr>
-          <a:lstStyle xmlns:a="http://schemas.openxmlformats.org/drawingml/2006/main">
-            <a:defPPr>
-              <a:defRPr sz="2400" b="0">
-                <a:solidFill>
-                  <a:srgbClr val="173C43"/>
-                </a:solidFill>
-                <a:latin typeface="Heiti TC"/>
-                <a:ea typeface="Heiti TC"/>
-                <a:cs typeface="Heiti TC"/>
-              </a:defRPr>
-            </a:defPPr>
-          </a:lstStyle>
-          <a:p xmlns:a="http://schemas.openxmlformats.org/drawingml/2006/main">
-            <a:pPr>
-              <a:defRPr sz="2400" b="0">
-                <a:solidFill>
-                  <a:srgbClr val="173C43"/>
-                </a:solidFill>
-                <a:latin typeface="Heiti TC"/>
-                <a:ea typeface="Heiti TC"/>
-                <a:cs typeface="Heiti TC"/>
-              </a:defRPr>
-            </a:pPr>
-            <a:r>
-              <a:rPr sz="2400" b="0">
-                <a:solidFill>
-                  <a:srgbClr val="173C43"/>
-                </a:solidFill>
-                <a:latin typeface="Heiti TC"/>
-                <a:ea typeface="Heiti TC"/>
-                <a:cs typeface="Heiti TC"/>
-              </a:rPr>
-              <a:t>例子太少，信心有限；關聯不能證明因果</a:t>
-            </a:r>
-          </a:p>
-        </p:txBody>
-      </p:sp>
-      <p:sp>
-        <p:nvSpPr>
-          <p:cNvPr id="9" name="">
-            <a:extLst xmlns:a="http://schemas.openxmlformats.org/drawingml/2006/main">
-              <a:ext uri="{FF2B5EF4-FFF2-40B4-BE49-F238E27FC236}">
-                <a16:creationId xmlns:a16="http://schemas.microsoft.com/office/drawing/2014/main" id="{A2DC9AF2-CADE-4CFB-AECE-D7B06646C1A6}"/>
-              </a:ext>
-            </a:extLst>
-          </p:cNvPr>
-          <p:cNvSpPr>
-            <a:spLocks xmlns:a="http://schemas.openxmlformats.org/drawingml/2006/main" noGrp="1"/>
-          </p:cNvSpPr>
-          <p:nvPr/>
-        </p:nvSpPr>
-        <p:spPr>
-          <a:xfrm xmlns:a="http://schemas.openxmlformats.org/drawingml/2006/main">
-            <a:off x="609600" y="5276850"/>
-            <a:ext cx="10668000" cy="457200"/>
-          </a:xfrm>
-          <a:prstGeom xmlns:a="http://schemas.openxmlformats.org/drawingml/2006/main" prst="rect">
-            <a:avLst/>
-          </a:prstGeom>
-          <a:noFill xmlns:a="http://schemas.openxmlformats.org/drawingml/2006/main"/>
-          <a:ln xmlns:a="http://schemas.openxmlformats.org/drawingml/2006/main" w="0">
-            <a:noFill/>
-          </a:ln>
-        </p:spPr>
-        <p:txBody>
-          <a:bodyPr xmlns:a="http://schemas.openxmlformats.org/drawingml/2006/main">
-            <a:noAutofit/>
-          </a:bodyPr>
-          <a:lstStyle xmlns:a="http://schemas.openxmlformats.org/drawingml/2006/main">
-            <a:defPPr>
-              <a:defRPr sz="1800" b="0">
-                <a:solidFill>
-                  <a:srgbClr val="526B70"/>
-                </a:solidFill>
-                <a:latin typeface="Arial"/>
-                <a:ea typeface="Arial"/>
-                <a:cs typeface="Arial"/>
-              </a:defRPr>
-            </a:defPPr>
-          </a:lstStyle>
-          <a:p xmlns:a="http://schemas.openxmlformats.org/drawingml/2006/main">
-            <a:pPr>
-              <a:defRPr sz="1800" b="0">
-                <a:solidFill>
-                  <a:srgbClr val="526B70"/>
-                </a:solidFill>
-                <a:latin typeface="Arial"/>
-                <a:ea typeface="Arial"/>
-                <a:cs typeface="Arial"/>
-              </a:defRPr>
-            </a:pPr>
-            <a:r>
-              <a:rPr sz="1800" b="0">
-                <a:solidFill>
-                  <a:srgbClr val="526B70"/>
-                </a:solidFill>
-                <a:latin typeface="Arial"/>
-                <a:ea typeface="Arial"/>
-                <a:cs typeface="Arial"/>
-              </a:rPr>
-              <a:t>Few examples limit confidence; association does not prove cause</a:t>
-            </a:r>
-          </a:p>
-        </p:txBody>
-      </p:sp>
     </p:spTree>
     <p:extLst>
       <p:ext uri="{BB962C8B-B14F-4D97-AF65-F5344CB8AC3E}">
-        <p14:creationId xmlns:p14="http://schemas.microsoft.com/office/powerpoint/2010/main" val="1995515419"/>
+        <p14:creationId xmlns:p14="http://schemas.microsoft.com/office/powerpoint/2010/main" val="122171272"/>
       </p:ext>
     </p:extLst>
   </p:cSld>
@@ -13213,7 +13006,7 @@
           <p:cNvPr id="10" name="">
             <a:extLst xmlns:a="http://schemas.openxmlformats.org/drawingml/2006/main">
               <a:ext uri="{FF2B5EF4-FFF2-40B4-BE49-F238E27FC236}">
-                <a16:creationId xmlns:a16="http://schemas.microsoft.com/office/drawing/2014/main" id="{C41FF626-49EC-43A2-8D3F-741C5CBADC73}"/>
+                <a16:creationId xmlns:a16="http://schemas.microsoft.com/office/drawing/2014/main" id="{A8518AFC-B5D0-43AE-A1DB-291C4F67F3CA}"/>
               </a:ext>
             </a:extLst>
           </p:cNvPr>
@@ -13271,7 +13064,7 @@
                 <a:ea typeface="Heiti TC"/>
                 <a:cs typeface="Heiti TC"/>
               </a:rPr>
-              <a:t>和 AI 的共同想法</a:t>
+              <a:t>帶走你的三個發現</a:t>
             </a:r>
           </a:p>
         </p:txBody>
@@ -13281,7 +13074,7 @@
           <p:cNvPr id="2" name="">
             <a:extLst xmlns:a="http://schemas.openxmlformats.org/drawingml/2006/main">
               <a:ext uri="{FF2B5EF4-FFF2-40B4-BE49-F238E27FC236}">
-                <a16:creationId xmlns:a16="http://schemas.microsoft.com/office/drawing/2014/main" id="{99830A4E-651D-4AED-B4D3-DDF822B32FC9}"/>
+                <a16:creationId xmlns:a16="http://schemas.microsoft.com/office/drawing/2014/main" id="{5438410E-343B-4209-B9FE-7645F07F5CF8}"/>
               </a:ext>
             </a:extLst>
           </p:cNvPr>
@@ -13339,7 +13132,7 @@
                 <a:ea typeface="Arial"/>
                 <a:cs typeface="Arial"/>
               </a:rPr>
-              <a:t>The shared idea behind AI</a:t>
+              <a:t>Take away three discoveries</a:t>
             </a:r>
           </a:p>
         </p:txBody>
@@ -13349,7 +13142,7 @@
           <p:cNvPr id="3" name="">
             <a:extLst xmlns:a="http://schemas.openxmlformats.org/drawingml/2006/main">
               <a:ext uri="{FF2B5EF4-FFF2-40B4-BE49-F238E27FC236}">
-                <a16:creationId xmlns:a16="http://schemas.microsoft.com/office/drawing/2014/main" id="{F2C81C2E-C4EA-4FF7-A1F3-001F0B3A5A05}"/>
+                <a16:creationId xmlns:a16="http://schemas.microsoft.com/office/drawing/2014/main" id="{019A2133-D9B3-4768-8901-553A00A87895}"/>
               </a:ext>
             </a:extLst>
           </p:cNvPr>
@@ -13417,648 +13210,7 @@
           <p:cNvPr id="4" name="">
             <a:extLst xmlns:a="http://schemas.openxmlformats.org/drawingml/2006/main">
               <a:ext uri="{FF2B5EF4-FFF2-40B4-BE49-F238E27FC236}">
-                <a16:creationId xmlns:a16="http://schemas.microsoft.com/office/drawing/2014/main" id="{BE86E6E6-768D-4288-A583-B95DC3065220}"/>
-              </a:ext>
-            </a:extLst>
-          </p:cNvPr>
-          <p:cNvSpPr>
-            <a:spLocks xmlns:a="http://schemas.openxmlformats.org/drawingml/2006/main" noGrp="1"/>
-          </p:cNvSpPr>
-          <p:nvPr/>
-        </p:nvSpPr>
-        <p:spPr>
-          <a:xfrm xmlns:a="http://schemas.openxmlformats.org/drawingml/2006/main">
-            <a:off x="609600" y="1809750"/>
-            <a:ext cx="10668000" cy="495300"/>
-          </a:xfrm>
-          <a:prstGeom xmlns:a="http://schemas.openxmlformats.org/drawingml/2006/main" prst="rect">
-            <a:avLst/>
-          </a:prstGeom>
-          <a:noFill xmlns:a="http://schemas.openxmlformats.org/drawingml/2006/main"/>
-          <a:ln xmlns:a="http://schemas.openxmlformats.org/drawingml/2006/main" w="0">
-            <a:noFill/>
-          </a:ln>
-        </p:spPr>
-        <p:txBody>
-          <a:bodyPr xmlns:a="http://schemas.openxmlformats.org/drawingml/2006/main">
-            <a:noAutofit/>
-          </a:bodyPr>
-          <a:lstStyle xmlns:a="http://schemas.openxmlformats.org/drawingml/2006/main">
-            <a:defPPr>
-              <a:defRPr sz="2325" b="0">
-                <a:solidFill>
-                  <a:srgbClr val="173C43"/>
-                </a:solidFill>
-                <a:latin typeface="Heiti TC"/>
-                <a:ea typeface="Heiti TC"/>
-                <a:cs typeface="Heiti TC"/>
-              </a:defRPr>
-            </a:defPPr>
-          </a:lstStyle>
-          <a:p xmlns:a="http://schemas.openxmlformats.org/drawingml/2006/main">
-            <a:pPr>
-              <a:defRPr sz="2325" b="0">
-                <a:solidFill>
-                  <a:srgbClr val="173C43"/>
-                </a:solidFill>
-                <a:latin typeface="Heiti TC"/>
-                <a:ea typeface="Heiti TC"/>
-                <a:cs typeface="Heiti TC"/>
-              </a:defRPr>
-            </a:pPr>
-            <a:r>
-              <a:rPr sz="2325" b="0">
-                <a:solidFill>
-                  <a:srgbClr val="173C43"/>
-                </a:solidFill>
-                <a:latin typeface="Heiti TC"/>
-                <a:ea typeface="Heiti TC"/>
-                <a:cs typeface="Heiti TC"/>
-              </a:rPr>
-              <a:t>從例子建立模型 → 用模型作估計 → 用新例子檢查</a:t>
-            </a:r>
-          </a:p>
-        </p:txBody>
-      </p:sp>
-      <p:sp>
-        <p:nvSpPr>
-          <p:cNvPr id="5" name="">
-            <a:extLst xmlns:a="http://schemas.openxmlformats.org/drawingml/2006/main">
-              <a:ext uri="{FF2B5EF4-FFF2-40B4-BE49-F238E27FC236}">
-                <a16:creationId xmlns:a16="http://schemas.microsoft.com/office/drawing/2014/main" id="{8FA4D218-25B5-4AB8-9DB4-0F8C4984B565}"/>
-              </a:ext>
-            </a:extLst>
-          </p:cNvPr>
-          <p:cNvSpPr>
-            <a:spLocks xmlns:a="http://schemas.openxmlformats.org/drawingml/2006/main" noGrp="1"/>
-          </p:cNvSpPr>
-          <p:nvPr/>
-        </p:nvSpPr>
-        <p:spPr>
-          <a:xfrm xmlns:a="http://schemas.openxmlformats.org/drawingml/2006/main">
-            <a:off x="609600" y="2276475"/>
-            <a:ext cx="10668000" cy="457200"/>
-          </a:xfrm>
-          <a:prstGeom xmlns:a="http://schemas.openxmlformats.org/drawingml/2006/main" prst="rect">
-            <a:avLst/>
-          </a:prstGeom>
-          <a:noFill xmlns:a="http://schemas.openxmlformats.org/drawingml/2006/main"/>
-          <a:ln xmlns:a="http://schemas.openxmlformats.org/drawingml/2006/main" w="0">
-            <a:noFill/>
-          </a:ln>
-        </p:spPr>
-        <p:txBody>
-          <a:bodyPr xmlns:a="http://schemas.openxmlformats.org/drawingml/2006/main">
-            <a:noAutofit/>
-          </a:bodyPr>
-          <a:lstStyle xmlns:a="http://schemas.openxmlformats.org/drawingml/2006/main">
-            <a:defPPr>
-              <a:defRPr sz="1800" b="0">
-                <a:solidFill>
-                  <a:srgbClr val="526B70"/>
-                </a:solidFill>
-                <a:latin typeface="Arial"/>
-                <a:ea typeface="Arial"/>
-                <a:cs typeface="Arial"/>
-              </a:defRPr>
-            </a:defPPr>
-          </a:lstStyle>
-          <a:p xmlns:a="http://schemas.openxmlformats.org/drawingml/2006/main">
-            <a:pPr>
-              <a:defRPr sz="1800" b="0">
-                <a:solidFill>
-                  <a:srgbClr val="526B70"/>
-                </a:solidFill>
-                <a:latin typeface="Arial"/>
-                <a:ea typeface="Arial"/>
-                <a:cs typeface="Arial"/>
-              </a:defRPr>
-            </a:pPr>
-            <a:r>
-              <a:rPr sz="1800" b="0">
-                <a:solidFill>
-                  <a:srgbClr val="526B70"/>
-                </a:solidFill>
-                <a:latin typeface="Arial"/>
-                <a:ea typeface="Arial"/>
-                <a:cs typeface="Arial"/>
-              </a:rPr>
-              <a:t>Learn from examples → make estimates → check new examples</a:t>
-            </a:r>
-          </a:p>
-        </p:txBody>
-      </p:sp>
-      <p:sp>
-        <p:nvSpPr>
-          <p:cNvPr id="6" name="">
-            <a:extLst xmlns:a="http://schemas.openxmlformats.org/drawingml/2006/main">
-              <a:ext uri="{FF2B5EF4-FFF2-40B4-BE49-F238E27FC236}">
-                <a16:creationId xmlns:a16="http://schemas.microsoft.com/office/drawing/2014/main" id="{CD2B15BE-CFEC-4AD3-BAC4-E5D9025E3D07}"/>
-              </a:ext>
-            </a:extLst>
-          </p:cNvPr>
-          <p:cNvSpPr>
-            <a:spLocks xmlns:a="http://schemas.openxmlformats.org/drawingml/2006/main" noGrp="1"/>
-          </p:cNvSpPr>
-          <p:nvPr/>
-        </p:nvSpPr>
-        <p:spPr>
-          <a:xfrm xmlns:a="http://schemas.openxmlformats.org/drawingml/2006/main">
-            <a:off x="609600" y="3286125"/>
-            <a:ext cx="10668000" cy="495300"/>
-          </a:xfrm>
-          <a:prstGeom xmlns:a="http://schemas.openxmlformats.org/drawingml/2006/main" prst="rect">
-            <a:avLst/>
-          </a:prstGeom>
-          <a:noFill xmlns:a="http://schemas.openxmlformats.org/drawingml/2006/main"/>
-          <a:ln xmlns:a="http://schemas.openxmlformats.org/drawingml/2006/main" w="0">
-            <a:noFill/>
-          </a:ln>
-        </p:spPr>
-        <p:txBody>
-          <a:bodyPr xmlns:a="http://schemas.openxmlformats.org/drawingml/2006/main">
-            <a:noAutofit/>
-          </a:bodyPr>
-          <a:lstStyle xmlns:a="http://schemas.openxmlformats.org/drawingml/2006/main">
-            <a:defPPr>
-              <a:defRPr sz="2325" b="0">
-                <a:solidFill>
-                  <a:srgbClr val="173C43"/>
-                </a:solidFill>
-                <a:latin typeface="Heiti TC"/>
-                <a:ea typeface="Heiti TC"/>
-                <a:cs typeface="Heiti TC"/>
-              </a:defRPr>
-            </a:defPPr>
-          </a:lstStyle>
-          <a:p xmlns:a="http://schemas.openxmlformats.org/drawingml/2006/main">
-            <a:pPr>
-              <a:defRPr sz="2325" b="0">
-                <a:solidFill>
-                  <a:srgbClr val="173C43"/>
-                </a:solidFill>
-                <a:latin typeface="Heiti TC"/>
-                <a:ea typeface="Heiti TC"/>
-                <a:cs typeface="Heiti TC"/>
-              </a:defRPr>
-            </a:pPr>
-            <a:r>
-              <a:rPr sz="2325" b="0">
-                <a:solidFill>
-                  <a:srgbClr val="173C43"/>
-                </a:solidFill>
-                <a:latin typeface="Heiti TC"/>
-                <a:ea typeface="Heiti TC"/>
-                <a:cs typeface="Heiti TC"/>
-              </a:rPr>
-              <a:t>現代 AI 更複雜，也需要合適的數據和測試</a:t>
-            </a:r>
-          </a:p>
-        </p:txBody>
-      </p:sp>
-      <p:sp>
-        <p:nvSpPr>
-          <p:cNvPr id="7" name="">
-            <a:extLst xmlns:a="http://schemas.openxmlformats.org/drawingml/2006/main">
-              <a:ext uri="{FF2B5EF4-FFF2-40B4-BE49-F238E27FC236}">
-                <a16:creationId xmlns:a16="http://schemas.microsoft.com/office/drawing/2014/main" id="{CEEC26F9-F65A-476F-9141-DB474A1800FE}"/>
-              </a:ext>
-            </a:extLst>
-          </p:cNvPr>
-          <p:cNvSpPr>
-            <a:spLocks xmlns:a="http://schemas.openxmlformats.org/drawingml/2006/main" noGrp="1"/>
-          </p:cNvSpPr>
-          <p:nvPr/>
-        </p:nvSpPr>
-        <p:spPr>
-          <a:xfrm xmlns:a="http://schemas.openxmlformats.org/drawingml/2006/main">
-            <a:off x="609600" y="3752850"/>
-            <a:ext cx="10668000" cy="457200"/>
-          </a:xfrm>
-          <a:prstGeom xmlns:a="http://schemas.openxmlformats.org/drawingml/2006/main" prst="rect">
-            <a:avLst/>
-          </a:prstGeom>
-          <a:noFill xmlns:a="http://schemas.openxmlformats.org/drawingml/2006/main"/>
-          <a:ln xmlns:a="http://schemas.openxmlformats.org/drawingml/2006/main" w="0">
-            <a:noFill/>
-          </a:ln>
-        </p:spPr>
-        <p:txBody>
-          <a:bodyPr xmlns:a="http://schemas.openxmlformats.org/drawingml/2006/main">
-            <a:noAutofit/>
-          </a:bodyPr>
-          <a:lstStyle xmlns:a="http://schemas.openxmlformats.org/drawingml/2006/main">
-            <a:defPPr>
-              <a:defRPr sz="1800" b="0">
-                <a:solidFill>
-                  <a:srgbClr val="526B70"/>
-                </a:solidFill>
-                <a:latin typeface="Arial"/>
-                <a:ea typeface="Arial"/>
-                <a:cs typeface="Arial"/>
-              </a:defRPr>
-            </a:defPPr>
-          </a:lstStyle>
-          <a:p xmlns:a="http://schemas.openxmlformats.org/drawingml/2006/main">
-            <a:pPr>
-              <a:defRPr sz="1800" b="0">
-                <a:solidFill>
-                  <a:srgbClr val="526B70"/>
-                </a:solidFill>
-                <a:latin typeface="Arial"/>
-                <a:ea typeface="Arial"/>
-                <a:cs typeface="Arial"/>
-              </a:defRPr>
-            </a:pPr>
-            <a:r>
-              <a:rPr sz="1800" b="0">
-                <a:solidFill>
-                  <a:srgbClr val="526B70"/>
-                </a:solidFill>
-                <a:latin typeface="Arial"/>
-                <a:ea typeface="Arial"/>
-                <a:cs typeface="Arial"/>
-              </a:rPr>
-              <a:t>Modern AI is more complex and also needs suitable data and testing</a:t>
-            </a:r>
-          </a:p>
-        </p:txBody>
-      </p:sp>
-      <p:sp>
-        <p:nvSpPr>
-          <p:cNvPr id="8" name="">
-            <a:extLst xmlns:a="http://schemas.openxmlformats.org/drawingml/2006/main">
-              <a:ext uri="{FF2B5EF4-FFF2-40B4-BE49-F238E27FC236}">
-                <a16:creationId xmlns:a16="http://schemas.microsoft.com/office/drawing/2014/main" id="{BF53593F-36A0-4F17-A036-DD400F662776}"/>
-              </a:ext>
-            </a:extLst>
-          </p:cNvPr>
-          <p:cNvSpPr>
-            <a:spLocks xmlns:a="http://schemas.openxmlformats.org/drawingml/2006/main" noGrp="1"/>
-          </p:cNvSpPr>
-          <p:nvPr/>
-        </p:nvSpPr>
-        <p:spPr>
-          <a:xfrm xmlns:a="http://schemas.openxmlformats.org/drawingml/2006/main">
-            <a:off x="609600" y="4810125"/>
-            <a:ext cx="10668000" cy="495300"/>
-          </a:xfrm>
-          <a:prstGeom xmlns:a="http://schemas.openxmlformats.org/drawingml/2006/main" prst="rect">
-            <a:avLst/>
-          </a:prstGeom>
-          <a:noFill xmlns:a="http://schemas.openxmlformats.org/drawingml/2006/main"/>
-          <a:ln xmlns:a="http://schemas.openxmlformats.org/drawingml/2006/main" w="0">
-            <a:noFill/>
-          </a:ln>
-        </p:spPr>
-        <p:txBody>
-          <a:bodyPr xmlns:a="http://schemas.openxmlformats.org/drawingml/2006/main">
-            <a:noAutofit/>
-          </a:bodyPr>
-          <a:lstStyle xmlns:a="http://schemas.openxmlformats.org/drawingml/2006/main">
-            <a:defPPr>
-              <a:defRPr sz="2250" b="0">
-                <a:solidFill>
-                  <a:srgbClr val="173C43"/>
-                </a:solidFill>
-                <a:latin typeface="Heiti TC"/>
-                <a:ea typeface="Heiti TC"/>
-                <a:cs typeface="Heiti TC"/>
-              </a:defRPr>
-            </a:defPPr>
-          </a:lstStyle>
-          <a:p xmlns:a="http://schemas.openxmlformats.org/drawingml/2006/main">
-            <a:pPr>
-              <a:defRPr sz="2250" b="0">
-                <a:solidFill>
-                  <a:srgbClr val="173C43"/>
-                </a:solidFill>
-                <a:latin typeface="Heiti TC"/>
-                <a:ea typeface="Heiti TC"/>
-                <a:cs typeface="Heiti TC"/>
-              </a:defRPr>
-            </a:pPr>
-            <a:r>
-              <a:rPr sz="2250" b="0">
-                <a:solidFill>
-                  <a:srgbClr val="173C43"/>
-                </a:solidFill>
-                <a:latin typeface="Heiti TC"/>
-                <a:ea typeface="Heiti TC"/>
-                <a:cs typeface="Heiti TC"/>
-              </a:rPr>
-              <a:t>下一堂：猜「是哪一類」。R² 不是所有 AI 的評分</a:t>
-            </a:r>
-          </a:p>
-        </p:txBody>
-      </p:sp>
-      <p:sp>
-        <p:nvSpPr>
-          <p:cNvPr id="9" name="">
-            <a:extLst xmlns:a="http://schemas.openxmlformats.org/drawingml/2006/main">
-              <a:ext uri="{FF2B5EF4-FFF2-40B4-BE49-F238E27FC236}">
-                <a16:creationId xmlns:a16="http://schemas.microsoft.com/office/drawing/2014/main" id="{95532EC4-5EF8-4ABE-A295-4C159EDA5E3A}"/>
-              </a:ext>
-            </a:extLst>
-          </p:cNvPr>
-          <p:cNvSpPr>
-            <a:spLocks xmlns:a="http://schemas.openxmlformats.org/drawingml/2006/main" noGrp="1"/>
-          </p:cNvSpPr>
-          <p:nvPr/>
-        </p:nvSpPr>
-        <p:spPr>
-          <a:xfrm xmlns:a="http://schemas.openxmlformats.org/drawingml/2006/main">
-            <a:off x="609600" y="5276850"/>
-            <a:ext cx="10668000" cy="457200"/>
-          </a:xfrm>
-          <a:prstGeom xmlns:a="http://schemas.openxmlformats.org/drawingml/2006/main" prst="rect">
-            <a:avLst/>
-          </a:prstGeom>
-          <a:noFill xmlns:a="http://schemas.openxmlformats.org/drawingml/2006/main"/>
-          <a:ln xmlns:a="http://schemas.openxmlformats.org/drawingml/2006/main" w="0">
-            <a:noFill/>
-          </a:ln>
-        </p:spPr>
-        <p:txBody>
-          <a:bodyPr xmlns:a="http://schemas.openxmlformats.org/drawingml/2006/main">
-            <a:noAutofit/>
-          </a:bodyPr>
-          <a:lstStyle xmlns:a="http://schemas.openxmlformats.org/drawingml/2006/main">
-            <a:defPPr>
-              <a:defRPr sz="1800" b="0">
-                <a:solidFill>
-                  <a:srgbClr val="526B70"/>
-                </a:solidFill>
-                <a:latin typeface="Arial"/>
-                <a:ea typeface="Arial"/>
-                <a:cs typeface="Arial"/>
-              </a:defRPr>
-            </a:defPPr>
-          </a:lstStyle>
-          <a:p xmlns:a="http://schemas.openxmlformats.org/drawingml/2006/main">
-            <a:pPr>
-              <a:defRPr sz="1800" b="0">
-                <a:solidFill>
-                  <a:srgbClr val="526B70"/>
-                </a:solidFill>
-                <a:latin typeface="Arial"/>
-                <a:ea typeface="Arial"/>
-                <a:cs typeface="Arial"/>
-              </a:defRPr>
-            </a:pPr>
-            <a:r>
-              <a:rPr sz="1800" b="0">
-                <a:solidFill>
-                  <a:srgbClr val="526B70"/>
-                </a:solidFill>
-                <a:latin typeface="Arial"/>
-                <a:ea typeface="Arial"/>
-                <a:cs typeface="Arial"/>
-              </a:rPr>
-              <a:t>Next: predict a class. R² is not a score for every AI task</a:t>
-            </a:r>
-          </a:p>
-        </p:txBody>
-      </p:sp>
-    </p:spTree>
-    <p:extLst>
-      <p:ext uri="{BB962C8B-B14F-4D97-AF65-F5344CB8AC3E}">
-        <p14:creationId xmlns:p14="http://schemas.microsoft.com/office/powerpoint/2010/main" val="326325466"/>
-      </p:ext>
-    </p:extLst>
-  </p:cSld>
-</p:sld>
-</file>
-
-<file path=ppt/slides/slide17.xml><?xml version="1.0" encoding="utf-8"?>
-<p:sld xmlns:p="http://schemas.openxmlformats.org/presentationml/2006/main">
-  <p:cSld>
-    <p:bg>
-      <p:bgPr>
-        <a:solidFill xmlns:a="http://schemas.openxmlformats.org/drawingml/2006/main">
-          <a:srgbClr val="F5F7F4"/>
-        </a:solidFill>
-      </p:bgPr>
-    </p:bg>
-    <p:spTree>
-      <p:nvGrpSpPr>
-        <p:cNvPr id="1" name=""/>
-        <p:cNvGrpSpPr/>
-        <p:nvPr/>
-      </p:nvGrpSpPr>
-      <p:grpSpPr>
-        <a:xfrm xmlns:a="http://schemas.openxmlformats.org/drawingml/2006/main"/>
-      </p:grpSpPr>
-      <p:sp>
-        <p:nvSpPr>
-          <p:cNvPr id="10" name="">
-            <a:extLst xmlns:a="http://schemas.openxmlformats.org/drawingml/2006/main">
-              <a:ext uri="{FF2B5EF4-FFF2-40B4-BE49-F238E27FC236}">
-                <a16:creationId xmlns:a16="http://schemas.microsoft.com/office/drawing/2014/main" id="{C2BB9847-F010-435A-86E8-123086A8B551}"/>
-              </a:ext>
-            </a:extLst>
-          </p:cNvPr>
-          <p:cNvSpPr>
-            <a:spLocks xmlns:a="http://schemas.openxmlformats.org/drawingml/2006/main" noGrp="1"/>
-          </p:cNvSpPr>
-          <p:nvPr/>
-        </p:nvSpPr>
-        <p:spPr>
-          <a:xfrm xmlns:a="http://schemas.openxmlformats.org/drawingml/2006/main">
-            <a:off x="609600" y="400050"/>
-            <a:ext cx="10972800" cy="495300"/>
-          </a:xfrm>
-          <a:prstGeom xmlns:a="http://schemas.openxmlformats.org/drawingml/2006/main" prst="rect">
-            <a:avLst/>
-          </a:prstGeom>
-          <a:noFill xmlns:a="http://schemas.openxmlformats.org/drawingml/2006/main"/>
-          <a:ln xmlns:a="http://schemas.openxmlformats.org/drawingml/2006/main" w="0">
-            <a:noFill/>
-          </a:ln>
-        </p:spPr>
-        <p:txBody>
-          <a:bodyPr xmlns:a="http://schemas.openxmlformats.org/drawingml/2006/main">
-            <a:noAutofit/>
-          </a:bodyPr>
-          <a:lstStyle xmlns:a="http://schemas.openxmlformats.org/drawingml/2006/main">
-            <a:defPPr>
-              <a:defRPr sz="3300" b="0">
-                <a:solidFill>
-                  <a:srgbClr val="173C43"/>
-                </a:solidFill>
-                <a:latin typeface="Heiti TC"/>
-                <a:ea typeface="Heiti TC"/>
-                <a:cs typeface="Heiti TC"/>
-              </a:defRPr>
-            </a:defPPr>
-          </a:lstStyle>
-          <a:p xmlns:a="http://schemas.openxmlformats.org/drawingml/2006/main">
-            <a:pPr>
-              <a:defRPr sz="3300" b="0">
-                <a:solidFill>
-                  <a:srgbClr val="173C43"/>
-                </a:solidFill>
-                <a:latin typeface="Heiti TC"/>
-                <a:ea typeface="Heiti TC"/>
-                <a:cs typeface="Heiti TC"/>
-              </a:defRPr>
-            </a:pPr>
-            <a:r>
-              <a:rPr sz="3300" b="0">
-                <a:solidFill>
-                  <a:srgbClr val="173C43"/>
-                </a:solidFill>
-                <a:latin typeface="Heiti TC"/>
-                <a:ea typeface="Heiti TC"/>
-                <a:cs typeface="Heiti TC"/>
-              </a:rPr>
-              <a:t>帶走你的三個發現</a:t>
-            </a:r>
-          </a:p>
-        </p:txBody>
-      </p:sp>
-      <p:sp>
-        <p:nvSpPr>
-          <p:cNvPr id="2" name="">
-            <a:extLst xmlns:a="http://schemas.openxmlformats.org/drawingml/2006/main">
-              <a:ext uri="{FF2B5EF4-FFF2-40B4-BE49-F238E27FC236}">
-                <a16:creationId xmlns:a16="http://schemas.microsoft.com/office/drawing/2014/main" id="{2BE45712-23C3-4D2E-AE9A-A028AF25531E}"/>
-              </a:ext>
-            </a:extLst>
-          </p:cNvPr>
-          <p:cNvSpPr>
-            <a:spLocks xmlns:a="http://schemas.openxmlformats.org/drawingml/2006/main" noGrp="1"/>
-          </p:cNvSpPr>
-          <p:nvPr/>
-        </p:nvSpPr>
-        <p:spPr>
-          <a:xfrm xmlns:a="http://schemas.openxmlformats.org/drawingml/2006/main">
-            <a:off x="609600" y="866775"/>
-            <a:ext cx="10972800" cy="457200"/>
-          </a:xfrm>
-          <a:prstGeom xmlns:a="http://schemas.openxmlformats.org/drawingml/2006/main" prst="rect">
-            <a:avLst/>
-          </a:prstGeom>
-          <a:noFill xmlns:a="http://schemas.openxmlformats.org/drawingml/2006/main"/>
-          <a:ln xmlns:a="http://schemas.openxmlformats.org/drawingml/2006/main" w="0">
-            <a:noFill/>
-          </a:ln>
-        </p:spPr>
-        <p:txBody>
-          <a:bodyPr xmlns:a="http://schemas.openxmlformats.org/drawingml/2006/main">
-            <a:noAutofit/>
-          </a:bodyPr>
-          <a:lstStyle xmlns:a="http://schemas.openxmlformats.org/drawingml/2006/main">
-            <a:defPPr>
-              <a:defRPr sz="2700" b="0">
-                <a:solidFill>
-                  <a:srgbClr val="526B70"/>
-                </a:solidFill>
-                <a:latin typeface="Arial"/>
-                <a:ea typeface="Arial"/>
-                <a:cs typeface="Arial"/>
-              </a:defRPr>
-            </a:defPPr>
-          </a:lstStyle>
-          <a:p xmlns:a="http://schemas.openxmlformats.org/drawingml/2006/main">
-            <a:pPr>
-              <a:defRPr sz="2700" b="0">
-                <a:solidFill>
-                  <a:srgbClr val="526B70"/>
-                </a:solidFill>
-                <a:latin typeface="Arial"/>
-                <a:ea typeface="Arial"/>
-                <a:cs typeface="Arial"/>
-              </a:defRPr>
-            </a:pPr>
-            <a:r>
-              <a:rPr sz="2700" b="0">
-                <a:solidFill>
-                  <a:srgbClr val="526B70"/>
-                </a:solidFill>
-                <a:latin typeface="Arial"/>
-                <a:ea typeface="Arial"/>
-                <a:cs typeface="Arial"/>
-              </a:rPr>
-              <a:t>Take away three discoveries</a:t>
-            </a:r>
-          </a:p>
-        </p:txBody>
-      </p:sp>
-      <p:sp>
-        <p:nvSpPr>
-          <p:cNvPr id="3" name="">
-            <a:extLst xmlns:a="http://schemas.openxmlformats.org/drawingml/2006/main">
-              <a:ext uri="{FF2B5EF4-FFF2-40B4-BE49-F238E27FC236}">
-                <a16:creationId xmlns:a16="http://schemas.microsoft.com/office/drawing/2014/main" id="{93D58164-BA24-448C-B45D-DF836CE75853}"/>
-              </a:ext>
-            </a:extLst>
-          </p:cNvPr>
-          <p:cNvSpPr>
-            <a:spLocks xmlns:a="http://schemas.openxmlformats.org/drawingml/2006/main" noGrp="1"/>
-          </p:cNvSpPr>
-          <p:nvPr/>
-        </p:nvSpPr>
-        <p:spPr>
-          <a:xfrm xmlns:a="http://schemas.openxmlformats.org/drawingml/2006/main">
-            <a:off x="11144250" y="6381750"/>
-            <a:ext cx="523875" cy="266700"/>
-          </a:xfrm>
-          <a:prstGeom xmlns:a="http://schemas.openxmlformats.org/drawingml/2006/main" prst="rect">
-            <a:avLst/>
-          </a:prstGeom>
-          <a:noFill xmlns:a="http://schemas.openxmlformats.org/drawingml/2006/main"/>
-          <a:ln xmlns:a="http://schemas.openxmlformats.org/drawingml/2006/main" w="0">
-            <a:noFill/>
-          </a:ln>
-        </p:spPr>
-        <p:txBody>
-          <a:bodyPr xmlns:a="http://schemas.openxmlformats.org/drawingml/2006/main">
-            <a:noAutofit/>
-          </a:bodyPr>
-          <a:lstStyle xmlns:a="http://schemas.openxmlformats.org/drawingml/2006/main">
-            <a:defPPr>
-              <a:defRPr sz="1350" b="0">
-                <a:solidFill>
-                  <a:srgbClr val="526B70"/>
-                </a:solidFill>
-                <a:latin typeface="Arial"/>
-                <a:ea typeface="Arial"/>
-                <a:cs typeface="Arial"/>
-              </a:defRPr>
-            </a:defPPr>
-          </a:lstStyle>
-          <a:p xmlns:a="http://schemas.openxmlformats.org/drawingml/2006/main">
-            <a:pPr>
-              <a:defRPr sz="1350" b="0">
-                <a:solidFill>
-                  <a:srgbClr val="526B70"/>
-                </a:solidFill>
-                <a:latin typeface="Arial"/>
-                <a:ea typeface="Arial"/>
-                <a:cs typeface="Arial"/>
-              </a:defRPr>
-            </a:pPr>
-            <a:r>
-              <a:rPr sz="1350" b="0">
-                <a:solidFill>
-                  <a:srgbClr val="526B70"/>
-                </a:solidFill>
-                <a:latin typeface="Arial"/>
-                <a:ea typeface="Arial"/>
-                <a:cs typeface="Arial"/>
-              </a:rPr>
-              <a:t>17</a:t>
-            </a:r>
-          </a:p>
-        </p:txBody>
-      </p:sp>
-      <p:sp>
-        <p:nvSpPr>
-          <p:cNvPr id="4" name="">
-            <a:extLst xmlns:a="http://schemas.openxmlformats.org/drawingml/2006/main">
-              <a:ext uri="{FF2B5EF4-FFF2-40B4-BE49-F238E27FC236}">
-                <a16:creationId xmlns:a16="http://schemas.microsoft.com/office/drawing/2014/main" id="{879DE610-3B84-49D9-A85D-98323E5C7E16}"/>
+                <a16:creationId xmlns:a16="http://schemas.microsoft.com/office/drawing/2014/main" id="{6C0E285B-A094-48FF-BB94-25FD1F9EA6DD}"/>
               </a:ext>
             </a:extLst>
           </p:cNvPr>
@@ -14126,7 +13278,7 @@
           <p:cNvPr id="5" name="">
             <a:extLst xmlns:a="http://schemas.openxmlformats.org/drawingml/2006/main">
               <a:ext uri="{FF2B5EF4-FFF2-40B4-BE49-F238E27FC236}">
-                <a16:creationId xmlns:a16="http://schemas.microsoft.com/office/drawing/2014/main" id="{1BFFFEC9-7BE8-4D27-8442-A75753418380}"/>
+                <a16:creationId xmlns:a16="http://schemas.microsoft.com/office/drawing/2014/main" id="{6163DED0-0E14-4E98-91B7-756D06C1E832}"/>
               </a:ext>
             </a:extLst>
           </p:cNvPr>
@@ -14194,7 +13346,7 @@
           <p:cNvPr id="6" name="">
             <a:extLst xmlns:a="http://schemas.openxmlformats.org/drawingml/2006/main">
               <a:ext uri="{FF2B5EF4-FFF2-40B4-BE49-F238E27FC236}">
-                <a16:creationId xmlns:a16="http://schemas.microsoft.com/office/drawing/2014/main" id="{C690E1A1-DFEC-4ECF-8629-0017BB736FD9}"/>
+                <a16:creationId xmlns:a16="http://schemas.microsoft.com/office/drawing/2014/main" id="{656C4F7C-45E9-46EB-8AA8-B7565959AB0E}"/>
               </a:ext>
             </a:extLst>
           </p:cNvPr>
@@ -14262,7 +13414,7 @@
           <p:cNvPr id="7" name="">
             <a:extLst xmlns:a="http://schemas.openxmlformats.org/drawingml/2006/main">
               <a:ext uri="{FF2B5EF4-FFF2-40B4-BE49-F238E27FC236}">
-                <a16:creationId xmlns:a16="http://schemas.microsoft.com/office/drawing/2014/main" id="{5DF7866C-5A2A-4199-BED9-E57FB85A4178}"/>
+                <a16:creationId xmlns:a16="http://schemas.microsoft.com/office/drawing/2014/main" id="{2E37866A-2743-4F3E-8FA8-9764CDE933AE}"/>
               </a:ext>
             </a:extLst>
           </p:cNvPr>
@@ -14330,7 +13482,7 @@
           <p:cNvPr id="8" name="">
             <a:extLst xmlns:a="http://schemas.openxmlformats.org/drawingml/2006/main">
               <a:ext uri="{FF2B5EF4-FFF2-40B4-BE49-F238E27FC236}">
-                <a16:creationId xmlns:a16="http://schemas.microsoft.com/office/drawing/2014/main" id="{FA9AB4D6-8215-4C8B-8B12-091D47BBEC25}"/>
+                <a16:creationId xmlns:a16="http://schemas.microsoft.com/office/drawing/2014/main" id="{737A4870-85ED-492F-8DA2-8C976219C9E4}"/>
               </a:ext>
             </a:extLst>
           </p:cNvPr>
@@ -14398,7 +13550,7 @@
           <p:cNvPr id="9" name="">
             <a:extLst xmlns:a="http://schemas.openxmlformats.org/drawingml/2006/main">
               <a:ext uri="{FF2B5EF4-FFF2-40B4-BE49-F238E27FC236}">
-                <a16:creationId xmlns:a16="http://schemas.microsoft.com/office/drawing/2014/main" id="{AAD4A86D-6A90-4DC5-A7B4-D205AA917899}"/>
+                <a16:creationId xmlns:a16="http://schemas.microsoft.com/office/drawing/2014/main" id="{0BA6B29E-369D-4F83-95D1-8425BFFEE234}"/>
               </a:ext>
             </a:extLst>
           </p:cNvPr>
@@ -14456,7 +13608,7 @@
                 <a:ea typeface="Arial"/>
                 <a:cs typeface="Arial"/>
               </a:rPr>
-              <a:t>Good fit still needs a check on new data</a:t>
+              <a:t>Check new predictions against actual results</a:t>
             </a:r>
           </a:p>
         </p:txBody>
@@ -14464,7 +13616,7 @@
     </p:spTree>
     <p:extLst>
       <p:ext uri="{BB962C8B-B14F-4D97-AF65-F5344CB8AC3E}">
-        <p14:creationId xmlns:p14="http://schemas.microsoft.com/office/powerpoint/2010/main" val="1162153812"/>
+        <p14:creationId xmlns:p14="http://schemas.microsoft.com/office/powerpoint/2010/main" val="1807824241"/>
       </p:ext>
     </p:extLst>
   </p:cSld>
@@ -14495,7 +13647,7 @@
           <p:cNvPr id="10" name="">
             <a:extLst xmlns:a="http://schemas.openxmlformats.org/drawingml/2006/main">
               <a:ext uri="{FF2B5EF4-FFF2-40B4-BE49-F238E27FC236}">
-                <a16:creationId xmlns:a16="http://schemas.microsoft.com/office/drawing/2014/main" id="{6F30B5D0-4214-46AE-912B-79CA7F0224BD}"/>
+                <a16:creationId xmlns:a16="http://schemas.microsoft.com/office/drawing/2014/main" id="{9E8E5305-8BF4-426A-B3B4-F00E9906387B}"/>
               </a:ext>
             </a:extLst>
           </p:cNvPr>
@@ -14553,7 +13705,7 @@
                 <a:ea typeface="Heiti TC"/>
                 <a:cs typeface="Heiti TC"/>
               </a:rPr>
-              <a:t>程式在哪裏跑？雲端運算</a:t>
+              <a:t>Python 和 Jupyter Notebook</a:t>
             </a:r>
           </a:p>
         </p:txBody>
@@ -14563,7 +13715,7 @@
           <p:cNvPr id="2" name="">
             <a:extLst xmlns:a="http://schemas.openxmlformats.org/drawingml/2006/main">
               <a:ext uri="{FF2B5EF4-FFF2-40B4-BE49-F238E27FC236}">
-                <a16:creationId xmlns:a16="http://schemas.microsoft.com/office/drawing/2014/main" id="{BE5D923A-2E9A-43A9-92DF-709E87A8E72A}"/>
+                <a16:creationId xmlns:a16="http://schemas.microsoft.com/office/drawing/2014/main" id="{0FECF192-133F-40DD-88E8-0CE55EA98CAE}"/>
               </a:ext>
             </a:extLst>
           </p:cNvPr>
@@ -14621,7 +13773,7 @@
                 <a:ea typeface="Arial"/>
                 <a:cs typeface="Arial"/>
               </a:rPr>
-              <a:t>Where does code run? Cloud computing</a:t>
+              <a:t>Python and Jupyter Notebook</a:t>
             </a:r>
           </a:p>
         </p:txBody>
@@ -14631,7 +13783,7 @@
           <p:cNvPr id="3" name="">
             <a:extLst xmlns:a="http://schemas.openxmlformats.org/drawingml/2006/main">
               <a:ext uri="{FF2B5EF4-FFF2-40B4-BE49-F238E27FC236}">
-                <a16:creationId xmlns:a16="http://schemas.microsoft.com/office/drawing/2014/main" id="{4FC009CE-37C6-44CF-A6E4-97C4A2D1708A}"/>
+                <a16:creationId xmlns:a16="http://schemas.microsoft.com/office/drawing/2014/main" id="{0A4AA24B-0503-4EA5-84B6-A4B2FE08BA95}"/>
               </a:ext>
             </a:extLst>
           </p:cNvPr>
@@ -14699,7 +13851,7 @@
           <p:cNvPr id="4" name="">
             <a:extLst xmlns:a="http://schemas.openxmlformats.org/drawingml/2006/main">
               <a:ext uri="{FF2B5EF4-FFF2-40B4-BE49-F238E27FC236}">
-                <a16:creationId xmlns:a16="http://schemas.microsoft.com/office/drawing/2014/main" id="{6BA22BCF-7880-42CA-9ED4-5131C921923B}"/>
+                <a16:creationId xmlns:a16="http://schemas.microsoft.com/office/drawing/2014/main" id="{FAE39184-F647-4ACB-971F-3DB4974CFFBF}"/>
               </a:ext>
             </a:extLst>
           </p:cNvPr>
@@ -14727,7 +13879,7 @@
           </a:bodyPr>
           <a:lstStyle xmlns:a="http://schemas.openxmlformats.org/drawingml/2006/main">
             <a:defPPr>
-              <a:defRPr sz="2550" b="0">
+              <a:defRPr sz="2625" b="0">
                 <a:solidFill>
                   <a:srgbClr val="173C43"/>
                 </a:solidFill>
@@ -14739,7 +13891,7 @@
           </a:lstStyle>
           <a:p xmlns:a="http://schemas.openxmlformats.org/drawingml/2006/main">
             <a:pPr>
-              <a:defRPr sz="2550" b="0">
+              <a:defRPr sz="2625" b="0">
                 <a:solidFill>
                   <a:srgbClr val="173C43"/>
                 </a:solidFill>
@@ -14749,7 +13901,7 @@
               </a:defRPr>
             </a:pPr>
             <a:r>
-              <a:rPr sz="2550" b="0">
+              <a:rPr sz="2625" b="0">
                 <a:solidFill>
                   <a:srgbClr val="173C43"/>
                 </a:solidFill>
@@ -14757,7 +13909,7 @@
                 <a:ea typeface="Heiti TC"/>
                 <a:cs typeface="Heiti TC"/>
               </a:rPr>
-              <a:t>雲端運算：透過網絡，使用遠端電腦的運算能力</a:t>
+              <a:t>Python：用程式給電腦指令，例如「畫出這些點」</a:t>
             </a:r>
           </a:p>
         </p:txBody>
@@ -14767,7 +13919,7 @@
           <p:cNvPr id="5" name="">
             <a:extLst xmlns:a="http://schemas.openxmlformats.org/drawingml/2006/main">
               <a:ext uri="{FF2B5EF4-FFF2-40B4-BE49-F238E27FC236}">
-                <a16:creationId xmlns:a16="http://schemas.microsoft.com/office/drawing/2014/main" id="{6D8BF8D4-22EB-4913-A54A-E33F686A577B}"/>
+                <a16:creationId xmlns:a16="http://schemas.microsoft.com/office/drawing/2014/main" id="{A6808F65-3C11-4B75-AB24-A7FC4FB75762}"/>
               </a:ext>
             </a:extLst>
           </p:cNvPr>
@@ -14795,7 +13947,7 @@
           </a:bodyPr>
           <a:lstStyle xmlns:a="http://schemas.openxmlformats.org/drawingml/2006/main">
             <a:defPPr>
-              <a:defRPr sz="1950" b="0">
+              <a:defRPr sz="2025" b="0">
                 <a:solidFill>
                   <a:srgbClr val="526B70"/>
                 </a:solidFill>
@@ -14807,7 +13959,7 @@
           </a:lstStyle>
           <a:p xmlns:a="http://schemas.openxmlformats.org/drawingml/2006/main">
             <a:pPr>
-              <a:defRPr sz="1950" b="0">
+              <a:defRPr sz="2025" b="0">
                 <a:solidFill>
                   <a:srgbClr val="526B70"/>
                 </a:solidFill>
@@ -14817,7 +13969,7 @@
               </a:defRPr>
             </a:pPr>
             <a:r>
-              <a:rPr sz="1950" b="0">
+              <a:rPr sz="2025" b="0">
                 <a:solidFill>
                   <a:srgbClr val="526B70"/>
                 </a:solidFill>
@@ -14825,7 +13977,7 @@
                 <a:ea typeface="Arial"/>
                 <a:cs typeface="Arial"/>
               </a:rPr>
-              <a:t>Cloud computing: use a remote computer over the internet</a:t>
+              <a:t>Python: instructions such as “plot these dots”</a:t>
             </a:r>
           </a:p>
         </p:txBody>
@@ -14835,7 +13987,7 @@
           <p:cNvPr id="6" name="">
             <a:extLst xmlns:a="http://schemas.openxmlformats.org/drawingml/2006/main">
               <a:ext uri="{FF2B5EF4-FFF2-40B4-BE49-F238E27FC236}">
-                <a16:creationId xmlns:a16="http://schemas.microsoft.com/office/drawing/2014/main" id="{3C7D7868-3D6B-4F00-B5DE-19FAFECC2EBD}"/>
+                <a16:creationId xmlns:a16="http://schemas.microsoft.com/office/drawing/2014/main" id="{3E32CA33-AB1B-4191-98B7-A2960F0C2B10}"/>
               </a:ext>
             </a:extLst>
           </p:cNvPr>
@@ -14863,7 +14015,7 @@
           </a:bodyPr>
           <a:lstStyle xmlns:a="http://schemas.openxmlformats.org/drawingml/2006/main">
             <a:defPPr>
-              <a:defRPr sz="2325" b="0">
+              <a:defRPr sz="2400" b="0">
                 <a:solidFill>
                   <a:srgbClr val="173C43"/>
                 </a:solidFill>
@@ -14875,7 +14027,7 @@
           </a:lstStyle>
           <a:p xmlns:a="http://schemas.openxmlformats.org/drawingml/2006/main">
             <a:pPr>
-              <a:defRPr sz="2325" b="0">
+              <a:defRPr sz="2400" b="0">
                 <a:solidFill>
                   <a:srgbClr val="173C43"/>
                 </a:solidFill>
@@ -14885,7 +14037,7 @@
               </a:defRPr>
             </a:pPr>
             <a:r>
-              <a:rPr sz="2325" b="0">
+              <a:rPr sz="2400" b="0">
                 <a:solidFill>
                   <a:srgbClr val="173C43"/>
                 </a:solidFill>
@@ -14893,7 +14045,7 @@
                 <a:ea typeface="Heiti TC"/>
                 <a:cs typeface="Heiti TC"/>
               </a:rPr>
-              <a:t>Colab：在瀏覽器開啟 Notebook，讓雲端電腦執行程式</a:t>
+              <a:t>Jupyter Notebook：把說明、程式格和結果放在一起</a:t>
             </a:r>
           </a:p>
         </p:txBody>
@@ -14903,7 +14055,7 @@
           <p:cNvPr id="7" name="">
             <a:extLst xmlns:a="http://schemas.openxmlformats.org/drawingml/2006/main">
               <a:ext uri="{FF2B5EF4-FFF2-40B4-BE49-F238E27FC236}">
-                <a16:creationId xmlns:a16="http://schemas.microsoft.com/office/drawing/2014/main" id="{04C1045A-3B76-4C5D-B270-01235A731DDC}"/>
+                <a16:creationId xmlns:a16="http://schemas.microsoft.com/office/drawing/2014/main" id="{00B09755-6372-4ECC-B285-15E8D85F3D39}"/>
               </a:ext>
             </a:extLst>
           </p:cNvPr>
@@ -14961,7 +14113,7 @@
                 <a:ea typeface="Arial"/>
                 <a:cs typeface="Arial"/>
               </a:rPr>
-              <a:t>Colab: open a notebook in a browser; run code on a cloud computer</a:t>
+              <a:t>Jupyter Notebook: explanations, code cells and results together</a:t>
             </a:r>
           </a:p>
         </p:txBody>
@@ -14971,7 +14123,7 @@
           <p:cNvPr id="8" name="">
             <a:extLst xmlns:a="http://schemas.openxmlformats.org/drawingml/2006/main">
               <a:ext uri="{FF2B5EF4-FFF2-40B4-BE49-F238E27FC236}">
-                <a16:creationId xmlns:a16="http://schemas.microsoft.com/office/drawing/2014/main" id="{65F6FDF4-4EF4-48D0-BE91-7D3944B27B80}"/>
+                <a16:creationId xmlns:a16="http://schemas.microsoft.com/office/drawing/2014/main" id="{32ECEFB8-7A53-4B5F-ACE4-3AB9186208BD}"/>
               </a:ext>
             </a:extLst>
           </p:cNvPr>
@@ -14999,7 +14151,7 @@
           </a:bodyPr>
           <a:lstStyle xmlns:a="http://schemas.openxmlformats.org/drawingml/2006/main">
             <a:defPPr>
-              <a:defRPr sz="2250" b="0">
+              <a:defRPr sz="2475" b="0">
                 <a:solidFill>
                   <a:srgbClr val="173C43"/>
                 </a:solidFill>
@@ -15011,7 +14163,7 @@
           </a:lstStyle>
           <a:p xmlns:a="http://schemas.openxmlformats.org/drawingml/2006/main">
             <a:pPr>
-              <a:defRPr sz="2250" b="0">
+              <a:defRPr sz="2475" b="0">
                 <a:solidFill>
                   <a:srgbClr val="173C43"/>
                 </a:solidFill>
@@ -15021,7 +14173,7 @@
               </a:defRPr>
             </a:pPr>
             <a:r>
-              <a:rPr sz="2250" b="0">
+              <a:rPr sz="2475" b="0">
                 <a:solidFill>
                   <a:srgbClr val="173C43"/>
                 </a:solidFill>
@@ -15029,7 +14181,7 @@
                 <a:ea typeface="Heiti TC"/>
                 <a:cs typeface="Heiti TC"/>
               </a:rPr>
-              <a:t>你的畫面顯示指令和結果</a:t>
+              <a:t>今天只需按播放、看結果；不用背誦程式</a:t>
             </a:r>
           </a:p>
         </p:txBody>
@@ -15039,7 +14191,7 @@
           <p:cNvPr id="9" name="">
             <a:extLst xmlns:a="http://schemas.openxmlformats.org/drawingml/2006/main">
               <a:ext uri="{FF2B5EF4-FFF2-40B4-BE49-F238E27FC236}">
-                <a16:creationId xmlns:a16="http://schemas.microsoft.com/office/drawing/2014/main" id="{095A25B7-EF56-49D3-93D5-88D99611C97D}"/>
+                <a16:creationId xmlns:a16="http://schemas.microsoft.com/office/drawing/2014/main" id="{74F8B413-E18A-4F86-BEA8-8EB96A1A5ED4}"/>
               </a:ext>
             </a:extLst>
           </p:cNvPr>
@@ -15067,7 +14219,7 @@
           </a:bodyPr>
           <a:lstStyle xmlns:a="http://schemas.openxmlformats.org/drawingml/2006/main">
             <a:defPPr>
-              <a:defRPr sz="1800" b="0">
+              <a:defRPr sz="1875" b="0">
                 <a:solidFill>
                   <a:srgbClr val="526B70"/>
                 </a:solidFill>
@@ -15079,7 +14231,7 @@
           </a:lstStyle>
           <a:p xmlns:a="http://schemas.openxmlformats.org/drawingml/2006/main">
             <a:pPr>
-              <a:defRPr sz="1800" b="0">
+              <a:defRPr sz="1875" b="0">
                 <a:solidFill>
                   <a:srgbClr val="526B70"/>
                 </a:solidFill>
@@ -15089,7 +14241,7 @@
               </a:defRPr>
             </a:pPr>
             <a:r>
-              <a:rPr sz="1800" b="0">
+              <a:rPr sz="1875" b="0">
                 <a:solidFill>
                   <a:srgbClr val="526B70"/>
                 </a:solidFill>
@@ -15097,7 +14249,7 @@
                 <a:ea typeface="Arial"/>
                 <a:cs typeface="Arial"/>
               </a:rPr>
-              <a:t>Your screen shows instructions and results</a:t>
+              <a:t>Today: press play and inspect the result. No memorising code</a:t>
             </a:r>
           </a:p>
         </p:txBody>
@@ -15105,7 +14257,7 @@
     </p:spTree>
     <p:extLst>
       <p:ext uri="{BB962C8B-B14F-4D97-AF65-F5344CB8AC3E}">
-        <p14:creationId xmlns:p14="http://schemas.microsoft.com/office/powerpoint/2010/main" val="1072571504"/>
+        <p14:creationId xmlns:p14="http://schemas.microsoft.com/office/powerpoint/2010/main" val="1027775967"/>
       </p:ext>
     </p:extLst>
   </p:cSld>
@@ -15136,7 +14288,7 @@
           <p:cNvPr id="10" name="">
             <a:extLst xmlns:a="http://schemas.openxmlformats.org/drawingml/2006/main">
               <a:ext uri="{FF2B5EF4-FFF2-40B4-BE49-F238E27FC236}">
-                <a16:creationId xmlns:a16="http://schemas.microsoft.com/office/drawing/2014/main" id="{40AECE14-0B93-4BC2-ACDB-841915CB31BF}"/>
+                <a16:creationId xmlns:a16="http://schemas.microsoft.com/office/drawing/2014/main" id="{C8760E97-1514-420F-9AC9-C0D2F41FEFB4}"/>
               </a:ext>
             </a:extLst>
           </p:cNvPr>
@@ -15194,7 +14346,7 @@
                 <a:ea typeface="Heiti TC"/>
                 <a:cs typeface="Heiti TC"/>
               </a:rPr>
-              <a:t>Python 和 Jupyter Notebook</a:t>
+              <a:t>程式在哪裏跑？雲端運算</a:t>
             </a:r>
           </a:p>
         </p:txBody>
@@ -15204,7 +14356,7 @@
           <p:cNvPr id="2" name="">
             <a:extLst xmlns:a="http://schemas.openxmlformats.org/drawingml/2006/main">
               <a:ext uri="{FF2B5EF4-FFF2-40B4-BE49-F238E27FC236}">
-                <a16:creationId xmlns:a16="http://schemas.microsoft.com/office/drawing/2014/main" id="{567D1F3C-280E-4CD3-A632-37571EF86482}"/>
+                <a16:creationId xmlns:a16="http://schemas.microsoft.com/office/drawing/2014/main" id="{7020B002-74AE-47EF-8E65-C5496CB4051B}"/>
               </a:ext>
             </a:extLst>
           </p:cNvPr>
@@ -15262,7 +14414,7 @@
                 <a:ea typeface="Arial"/>
                 <a:cs typeface="Arial"/>
               </a:rPr>
-              <a:t>Python and Jupyter Notebook</a:t>
+              <a:t>Where does code run? Cloud computing</a:t>
             </a:r>
           </a:p>
         </p:txBody>
@@ -15272,7 +14424,7 @@
           <p:cNvPr id="3" name="">
             <a:extLst xmlns:a="http://schemas.openxmlformats.org/drawingml/2006/main">
               <a:ext uri="{FF2B5EF4-FFF2-40B4-BE49-F238E27FC236}">
-                <a16:creationId xmlns:a16="http://schemas.microsoft.com/office/drawing/2014/main" id="{31871470-D630-40A0-8B02-2CF0F826FA8B}"/>
+                <a16:creationId xmlns:a16="http://schemas.microsoft.com/office/drawing/2014/main" id="{B62DD4D9-4521-454A-9E83-B81509BDEF16}"/>
               </a:ext>
             </a:extLst>
           </p:cNvPr>
@@ -15340,7 +14492,7 @@
           <p:cNvPr id="4" name="">
             <a:extLst xmlns:a="http://schemas.openxmlformats.org/drawingml/2006/main">
               <a:ext uri="{FF2B5EF4-FFF2-40B4-BE49-F238E27FC236}">
-                <a16:creationId xmlns:a16="http://schemas.microsoft.com/office/drawing/2014/main" id="{DA649232-5157-4583-B4B0-0116BD2F3E33}"/>
+                <a16:creationId xmlns:a16="http://schemas.microsoft.com/office/drawing/2014/main" id="{566083E0-D18F-4EC5-A5A5-D627E354BF18}"/>
               </a:ext>
             </a:extLst>
           </p:cNvPr>
@@ -15368,7 +14520,7 @@
           </a:bodyPr>
           <a:lstStyle xmlns:a="http://schemas.openxmlformats.org/drawingml/2006/main">
             <a:defPPr>
-              <a:defRPr sz="2625" b="0">
+              <a:defRPr sz="2550" b="0">
                 <a:solidFill>
                   <a:srgbClr val="173C43"/>
                 </a:solidFill>
@@ -15380,7 +14532,7 @@
           </a:lstStyle>
           <a:p xmlns:a="http://schemas.openxmlformats.org/drawingml/2006/main">
             <a:pPr>
-              <a:defRPr sz="2625" b="0">
+              <a:defRPr sz="2550" b="0">
                 <a:solidFill>
                   <a:srgbClr val="173C43"/>
                 </a:solidFill>
@@ -15390,7 +14542,7 @@
               </a:defRPr>
             </a:pPr>
             <a:r>
-              <a:rPr sz="2625" b="0">
+              <a:rPr sz="2550" b="0">
                 <a:solidFill>
                   <a:srgbClr val="173C43"/>
                 </a:solidFill>
@@ -15398,7 +14550,7 @@
                 <a:ea typeface="Heiti TC"/>
                 <a:cs typeface="Heiti TC"/>
               </a:rPr>
-              <a:t>Python：用程式給電腦指令，例如「畫出這些點」</a:t>
+              <a:t>雲端運算：透過網絡，使用遠端電腦的運算能力</a:t>
             </a:r>
           </a:p>
         </p:txBody>
@@ -15408,7 +14560,7 @@
           <p:cNvPr id="5" name="">
             <a:extLst xmlns:a="http://schemas.openxmlformats.org/drawingml/2006/main">
               <a:ext uri="{FF2B5EF4-FFF2-40B4-BE49-F238E27FC236}">
-                <a16:creationId xmlns:a16="http://schemas.microsoft.com/office/drawing/2014/main" id="{8AE25CD0-363D-45E3-BC5A-BE8910DAFA94}"/>
+                <a16:creationId xmlns:a16="http://schemas.microsoft.com/office/drawing/2014/main" id="{3A165044-CFD1-4C2C-8DD6-20CB6EC95C1E}"/>
               </a:ext>
             </a:extLst>
           </p:cNvPr>
@@ -15436,7 +14588,7 @@
           </a:bodyPr>
           <a:lstStyle xmlns:a="http://schemas.openxmlformats.org/drawingml/2006/main">
             <a:defPPr>
-              <a:defRPr sz="2025" b="0">
+              <a:defRPr sz="1950" b="0">
                 <a:solidFill>
                   <a:srgbClr val="526B70"/>
                 </a:solidFill>
@@ -15448,7 +14600,7 @@
           </a:lstStyle>
           <a:p xmlns:a="http://schemas.openxmlformats.org/drawingml/2006/main">
             <a:pPr>
-              <a:defRPr sz="2025" b="0">
+              <a:defRPr sz="1950" b="0">
                 <a:solidFill>
                   <a:srgbClr val="526B70"/>
                 </a:solidFill>
@@ -15458,7 +14610,7 @@
               </a:defRPr>
             </a:pPr>
             <a:r>
-              <a:rPr sz="2025" b="0">
+              <a:rPr sz="1950" b="0">
                 <a:solidFill>
                   <a:srgbClr val="526B70"/>
                 </a:solidFill>
@@ -15466,7 +14618,7 @@
                 <a:ea typeface="Arial"/>
                 <a:cs typeface="Arial"/>
               </a:rPr>
-              <a:t>Python: instructions such as “plot these dots”</a:t>
+              <a:t>Cloud computing: use a remote computer over the internet</a:t>
             </a:r>
           </a:p>
         </p:txBody>
@@ -15476,7 +14628,7 @@
           <p:cNvPr id="6" name="">
             <a:extLst xmlns:a="http://schemas.openxmlformats.org/drawingml/2006/main">
               <a:ext uri="{FF2B5EF4-FFF2-40B4-BE49-F238E27FC236}">
-                <a16:creationId xmlns:a16="http://schemas.microsoft.com/office/drawing/2014/main" id="{287A62B2-92A3-45EF-8F27-97211DF3D68E}"/>
+                <a16:creationId xmlns:a16="http://schemas.microsoft.com/office/drawing/2014/main" id="{EB7DD014-07A6-4BD4-A673-138B0E9D7B42}"/>
               </a:ext>
             </a:extLst>
           </p:cNvPr>
@@ -15504,7 +14656,7 @@
           </a:bodyPr>
           <a:lstStyle xmlns:a="http://schemas.openxmlformats.org/drawingml/2006/main">
             <a:defPPr>
-              <a:defRPr sz="2400" b="0">
+              <a:defRPr sz="2325" b="0">
                 <a:solidFill>
                   <a:srgbClr val="173C43"/>
                 </a:solidFill>
@@ -15516,7 +14668,7 @@
           </a:lstStyle>
           <a:p xmlns:a="http://schemas.openxmlformats.org/drawingml/2006/main">
             <a:pPr>
-              <a:defRPr sz="2400" b="0">
+              <a:defRPr sz="2325" b="0">
                 <a:solidFill>
                   <a:srgbClr val="173C43"/>
                 </a:solidFill>
@@ -15526,7 +14678,7 @@
               </a:defRPr>
             </a:pPr>
             <a:r>
-              <a:rPr sz="2400" b="0">
+              <a:rPr sz="2325" b="0">
                 <a:solidFill>
                   <a:srgbClr val="173C43"/>
                 </a:solidFill>
@@ -15534,7 +14686,7 @@
                 <a:ea typeface="Heiti TC"/>
                 <a:cs typeface="Heiti TC"/>
               </a:rPr>
-              <a:t>Jupyter Notebook：把說明、程式格和結果放在一起</a:t>
+              <a:t>Colab：在瀏覽器開啟 Notebook，讓雲端電腦執行程式</a:t>
             </a:r>
           </a:p>
         </p:txBody>
@@ -15544,7 +14696,7 @@
           <p:cNvPr id="7" name="">
             <a:extLst xmlns:a="http://schemas.openxmlformats.org/drawingml/2006/main">
               <a:ext uri="{FF2B5EF4-FFF2-40B4-BE49-F238E27FC236}">
-                <a16:creationId xmlns:a16="http://schemas.microsoft.com/office/drawing/2014/main" id="{8233B3D4-8D20-409D-BA4E-E3B9E5143E9D}"/>
+                <a16:creationId xmlns:a16="http://schemas.microsoft.com/office/drawing/2014/main" id="{CAB2969F-634A-4298-8204-FC3491191B53}"/>
               </a:ext>
             </a:extLst>
           </p:cNvPr>
@@ -15602,7 +14754,7 @@
                 <a:ea typeface="Arial"/>
                 <a:cs typeface="Arial"/>
               </a:rPr>
-              <a:t>Jupyter Notebook: explanations, code cells and results together</a:t>
+              <a:t>Colab: open a notebook in a browser; run code on a cloud computer</a:t>
             </a:r>
           </a:p>
         </p:txBody>
@@ -15612,7 +14764,7 @@
           <p:cNvPr id="8" name="">
             <a:extLst xmlns:a="http://schemas.openxmlformats.org/drawingml/2006/main">
               <a:ext uri="{FF2B5EF4-FFF2-40B4-BE49-F238E27FC236}">
-                <a16:creationId xmlns:a16="http://schemas.microsoft.com/office/drawing/2014/main" id="{A708428F-5888-4DE7-983C-F0CBDCDBF4FF}"/>
+                <a16:creationId xmlns:a16="http://schemas.microsoft.com/office/drawing/2014/main" id="{2F2A2FAD-4FED-4086-932B-55E3941FB359}"/>
               </a:ext>
             </a:extLst>
           </p:cNvPr>
@@ -15640,7 +14792,7 @@
           </a:bodyPr>
           <a:lstStyle xmlns:a="http://schemas.openxmlformats.org/drawingml/2006/main">
             <a:defPPr>
-              <a:defRPr sz="2475" b="0">
+              <a:defRPr sz="2250" b="0">
                 <a:solidFill>
                   <a:srgbClr val="173C43"/>
                 </a:solidFill>
@@ -15652,7 +14804,7 @@
           </a:lstStyle>
           <a:p xmlns:a="http://schemas.openxmlformats.org/drawingml/2006/main">
             <a:pPr>
-              <a:defRPr sz="2475" b="0">
+              <a:defRPr sz="2250" b="0">
                 <a:solidFill>
                   <a:srgbClr val="173C43"/>
                 </a:solidFill>
@@ -15662,7 +14814,7 @@
               </a:defRPr>
             </a:pPr>
             <a:r>
-              <a:rPr sz="2475" b="0">
+              <a:rPr sz="2250" b="0">
                 <a:solidFill>
                   <a:srgbClr val="173C43"/>
                 </a:solidFill>
@@ -15670,7 +14822,7 @@
                 <a:ea typeface="Heiti TC"/>
                 <a:cs typeface="Heiti TC"/>
               </a:rPr>
-              <a:t>今天只需按播放、看結果；不用背誦程式</a:t>
+              <a:t>你的畫面顯示指令和結果</a:t>
             </a:r>
           </a:p>
         </p:txBody>
@@ -15680,7 +14832,7 @@
           <p:cNvPr id="9" name="">
             <a:extLst xmlns:a="http://schemas.openxmlformats.org/drawingml/2006/main">
               <a:ext uri="{FF2B5EF4-FFF2-40B4-BE49-F238E27FC236}">
-                <a16:creationId xmlns:a16="http://schemas.microsoft.com/office/drawing/2014/main" id="{3F2C2747-213D-441B-9F22-67EC72F12D8B}"/>
+                <a16:creationId xmlns:a16="http://schemas.microsoft.com/office/drawing/2014/main" id="{43C83547-2E7D-4600-87A0-500D8EE432C9}"/>
               </a:ext>
             </a:extLst>
           </p:cNvPr>
@@ -15708,7 +14860,7 @@
           </a:bodyPr>
           <a:lstStyle xmlns:a="http://schemas.openxmlformats.org/drawingml/2006/main">
             <a:defPPr>
-              <a:defRPr sz="1875" b="0">
+              <a:defRPr sz="1800" b="0">
                 <a:solidFill>
                   <a:srgbClr val="526B70"/>
                 </a:solidFill>
@@ -15720,7 +14872,7 @@
           </a:lstStyle>
           <a:p xmlns:a="http://schemas.openxmlformats.org/drawingml/2006/main">
             <a:pPr>
-              <a:defRPr sz="1875" b="0">
+              <a:defRPr sz="1800" b="0">
                 <a:solidFill>
                   <a:srgbClr val="526B70"/>
                 </a:solidFill>
@@ -15730,7 +14882,7 @@
               </a:defRPr>
             </a:pPr>
             <a:r>
-              <a:rPr sz="1875" b="0">
+              <a:rPr sz="1800" b="0">
                 <a:solidFill>
                   <a:srgbClr val="526B70"/>
                 </a:solidFill>
@@ -15738,7 +14890,7 @@
                 <a:ea typeface="Arial"/>
                 <a:cs typeface="Arial"/>
               </a:rPr>
-              <a:t>Today: press play and inspect the result. No memorising code</a:t>
+              <a:t>Your screen shows instructions and results</a:t>
             </a:r>
           </a:p>
         </p:txBody>
@@ -15746,7 +14898,7 @@
     </p:spTree>
     <p:extLst>
       <p:ext uri="{BB962C8B-B14F-4D97-AF65-F5344CB8AC3E}">
-        <p14:creationId xmlns:p14="http://schemas.microsoft.com/office/powerpoint/2010/main" val="1384579563"/>
+        <p14:creationId xmlns:p14="http://schemas.microsoft.com/office/powerpoint/2010/main" val="638327481"/>
       </p:ext>
     </p:extLst>
   </p:cSld>
@@ -15777,7 +14929,7 @@
           <p:cNvPr id="10" name="">
             <a:extLst xmlns:a="http://schemas.openxmlformats.org/drawingml/2006/main">
               <a:ext uri="{FF2B5EF4-FFF2-40B4-BE49-F238E27FC236}">
-                <a16:creationId xmlns:a16="http://schemas.microsoft.com/office/drawing/2014/main" id="{A5F4CFA5-68CC-4C0E-AD48-AAB419235114}"/>
+                <a16:creationId xmlns:a16="http://schemas.microsoft.com/office/drawing/2014/main" id="{A8557A55-49E4-4CEC-9FF2-F106B23898AE}"/>
               </a:ext>
             </a:extLst>
           </p:cNvPr>
@@ -15845,7 +14997,7 @@
           <p:cNvPr id="2" name="">
             <a:extLst xmlns:a="http://schemas.openxmlformats.org/drawingml/2006/main">
               <a:ext uri="{FF2B5EF4-FFF2-40B4-BE49-F238E27FC236}">
-                <a16:creationId xmlns:a16="http://schemas.microsoft.com/office/drawing/2014/main" id="{A9C3B6D7-4AA1-40D2-A4B2-FC57C1C123B3}"/>
+                <a16:creationId xmlns:a16="http://schemas.microsoft.com/office/drawing/2014/main" id="{20A68E9E-05F3-4FFC-B858-F0F67A2B94B1}"/>
               </a:ext>
             </a:extLst>
           </p:cNvPr>
@@ -15913,7 +15065,7 @@
           <p:cNvPr id="3" name="">
             <a:extLst xmlns:a="http://schemas.openxmlformats.org/drawingml/2006/main">
               <a:ext uri="{FF2B5EF4-FFF2-40B4-BE49-F238E27FC236}">
-                <a16:creationId xmlns:a16="http://schemas.microsoft.com/office/drawing/2014/main" id="{44BFD031-79D5-4A10-8623-2353246BF562}"/>
+                <a16:creationId xmlns:a16="http://schemas.microsoft.com/office/drawing/2014/main" id="{4A3CE200-9251-42D9-BC5C-60A9002AB336}"/>
               </a:ext>
             </a:extLst>
           </p:cNvPr>
@@ -15981,7 +15133,7 @@
           <p:cNvPr id="4" name="">
             <a:extLst xmlns:a="http://schemas.openxmlformats.org/drawingml/2006/main">
               <a:ext uri="{FF2B5EF4-FFF2-40B4-BE49-F238E27FC236}">
-                <a16:creationId xmlns:a16="http://schemas.microsoft.com/office/drawing/2014/main" id="{B70ECCCB-9850-436B-91C6-DC1D4787477D}"/>
+                <a16:creationId xmlns:a16="http://schemas.microsoft.com/office/drawing/2014/main" id="{E755FDBB-FA88-416B-88FC-AA7C305FD014}"/>
               </a:ext>
             </a:extLst>
           </p:cNvPr>
@@ -16049,7 +15201,7 @@
           <p:cNvPr id="5" name="">
             <a:extLst xmlns:a="http://schemas.openxmlformats.org/drawingml/2006/main">
               <a:ext uri="{FF2B5EF4-FFF2-40B4-BE49-F238E27FC236}">
-                <a16:creationId xmlns:a16="http://schemas.microsoft.com/office/drawing/2014/main" id="{50D3D553-2A41-40FC-84E5-BA41BCCA8354}"/>
+                <a16:creationId xmlns:a16="http://schemas.microsoft.com/office/drawing/2014/main" id="{1D671546-E0FE-4369-861E-4F20185F6457}"/>
               </a:ext>
             </a:extLst>
           </p:cNvPr>
@@ -16117,7 +15269,7 @@
           <p:cNvPr id="6" name="">
             <a:extLst xmlns:a="http://schemas.openxmlformats.org/drawingml/2006/main">
               <a:ext uri="{FF2B5EF4-FFF2-40B4-BE49-F238E27FC236}">
-                <a16:creationId xmlns:a16="http://schemas.microsoft.com/office/drawing/2014/main" id="{A7B889CB-507F-4345-A4E7-5A1711AAE4F4}"/>
+                <a16:creationId xmlns:a16="http://schemas.microsoft.com/office/drawing/2014/main" id="{CE4D2996-993E-41D7-BCF6-84F28827F1E7}"/>
               </a:ext>
             </a:extLst>
           </p:cNvPr>
@@ -16185,7 +15337,7 @@
           <p:cNvPr id="7" name="">
             <a:extLst xmlns:a="http://schemas.openxmlformats.org/drawingml/2006/main">
               <a:ext uri="{FF2B5EF4-FFF2-40B4-BE49-F238E27FC236}">
-                <a16:creationId xmlns:a16="http://schemas.microsoft.com/office/drawing/2014/main" id="{96BD90AF-187C-40D0-B9B1-DD0F695B3C2A}"/>
+                <a16:creationId xmlns:a16="http://schemas.microsoft.com/office/drawing/2014/main" id="{EBF37475-4995-491C-9D69-235775E93417}"/>
               </a:ext>
             </a:extLst>
           </p:cNvPr>
@@ -16253,7 +15405,7 @@
           <p:cNvPr id="8" name="">
             <a:extLst xmlns:a="http://schemas.openxmlformats.org/drawingml/2006/main">
               <a:ext uri="{FF2B5EF4-FFF2-40B4-BE49-F238E27FC236}">
-                <a16:creationId xmlns:a16="http://schemas.microsoft.com/office/drawing/2014/main" id="{4182905E-6B8F-4C8B-A90E-E72A6511DEAE}"/>
+                <a16:creationId xmlns:a16="http://schemas.microsoft.com/office/drawing/2014/main" id="{2B34E4D8-6916-478D-B6FB-76518D1CBF7D}"/>
               </a:ext>
             </a:extLst>
           </p:cNvPr>
@@ -16321,7 +15473,7 @@
           <p:cNvPr id="9" name="">
             <a:extLst xmlns:a="http://schemas.openxmlformats.org/drawingml/2006/main">
               <a:ext uri="{FF2B5EF4-FFF2-40B4-BE49-F238E27FC236}">
-                <a16:creationId xmlns:a16="http://schemas.microsoft.com/office/drawing/2014/main" id="{46022B15-5D71-48D0-BF1B-357BDD0C0C20}"/>
+                <a16:creationId xmlns:a16="http://schemas.microsoft.com/office/drawing/2014/main" id="{1DCDC378-6658-4619-9902-56FBA2BD70E2}"/>
               </a:ext>
             </a:extLst>
           </p:cNvPr>
@@ -16387,7 +15539,7 @@
     </p:spTree>
     <p:extLst>
       <p:ext uri="{BB962C8B-B14F-4D97-AF65-F5344CB8AC3E}">
-        <p14:creationId xmlns:p14="http://schemas.microsoft.com/office/powerpoint/2010/main" val="2088922402"/>
+        <p14:creationId xmlns:p14="http://schemas.microsoft.com/office/powerpoint/2010/main" val="226332460"/>
       </p:ext>
     </p:extLst>
   </p:cSld>
@@ -16418,7 +15570,7 @@
           <p:cNvPr id="11" name="">
             <a:extLst xmlns:a="http://schemas.openxmlformats.org/drawingml/2006/main">
               <a:ext uri="{FF2B5EF4-FFF2-40B4-BE49-F238E27FC236}">
-                <a16:creationId xmlns:a16="http://schemas.microsoft.com/office/drawing/2014/main" id="{F5012C8B-EF9D-45DE-83CD-A715CF12F08D}"/>
+                <a16:creationId xmlns:a16="http://schemas.microsoft.com/office/drawing/2014/main" id="{33285B85-4B6C-49AE-A392-8996D5E6E921}"/>
               </a:ext>
             </a:extLst>
           </p:cNvPr>
@@ -16486,7 +15638,7 @@
           <p:cNvPr id="2" name="">
             <a:extLst xmlns:a="http://schemas.openxmlformats.org/drawingml/2006/main">
               <a:ext uri="{FF2B5EF4-FFF2-40B4-BE49-F238E27FC236}">
-                <a16:creationId xmlns:a16="http://schemas.microsoft.com/office/drawing/2014/main" id="{E1AF4158-F4EF-408D-B148-1EA778E47420}"/>
+                <a16:creationId xmlns:a16="http://schemas.microsoft.com/office/drawing/2014/main" id="{79E171B1-1707-441B-B5D8-DB74B9879F41}"/>
               </a:ext>
             </a:extLst>
           </p:cNvPr>
@@ -16554,7 +15706,7 @@
           <p:cNvPr id="3" name="">
             <a:extLst xmlns:a="http://schemas.openxmlformats.org/drawingml/2006/main">
               <a:ext uri="{FF2B5EF4-FFF2-40B4-BE49-F238E27FC236}">
-                <a16:creationId xmlns:a16="http://schemas.microsoft.com/office/drawing/2014/main" id="{9C44F115-BF3D-46C7-96E6-3B9AC734F6C0}"/>
+                <a16:creationId xmlns:a16="http://schemas.microsoft.com/office/drawing/2014/main" id="{CDA7CE67-5AC8-4369-881B-DBD1AB221717}"/>
               </a:ext>
             </a:extLst>
           </p:cNvPr>
@@ -16622,7 +15774,7 @@
           <p:cNvPr id="4" name="">
             <a:extLst xmlns:a="http://schemas.openxmlformats.org/drawingml/2006/main">
               <a:ext uri="{FF2B5EF4-FFF2-40B4-BE49-F238E27FC236}">
-                <a16:creationId xmlns:a16="http://schemas.microsoft.com/office/drawing/2014/main" id="{DEC12665-509F-41D7-A871-8ABF2E2B3AB6}"/>
+                <a16:creationId xmlns:a16="http://schemas.microsoft.com/office/drawing/2014/main" id="{8DA41553-4B38-46A9-AB2A-136B3A799E7F}"/>
               </a:ext>
             </a:extLst>
           </p:cNvPr>
@@ -16690,7 +15842,7 @@
           <p:cNvPr id="5" name="">
             <a:extLst xmlns:a="http://schemas.openxmlformats.org/drawingml/2006/main">
               <a:ext uri="{FF2B5EF4-FFF2-40B4-BE49-F238E27FC236}">
-                <a16:creationId xmlns:a16="http://schemas.microsoft.com/office/drawing/2014/main" id="{CD20B1B2-DCD7-4435-B62F-1172DC956AAD}"/>
+                <a16:creationId xmlns:a16="http://schemas.microsoft.com/office/drawing/2014/main" id="{C0E99446-29CF-4A50-A166-4D295519A0E8}"/>
               </a:ext>
             </a:extLst>
           </p:cNvPr>
@@ -16758,7 +15910,7 @@
           <p:cNvPr id="6" name="">
             <a:extLst xmlns:a="http://schemas.openxmlformats.org/drawingml/2006/main">
               <a:ext uri="{FF2B5EF4-FFF2-40B4-BE49-F238E27FC236}">
-                <a16:creationId xmlns:a16="http://schemas.microsoft.com/office/drawing/2014/main" id="{453F275E-30C1-4BF4-8462-9C39D02A90FC}"/>
+                <a16:creationId xmlns:a16="http://schemas.microsoft.com/office/drawing/2014/main" id="{80C63EB0-B114-4193-98BB-47042BF651A5}"/>
               </a:ext>
             </a:extLst>
           </p:cNvPr>
@@ -16826,7 +15978,7 @@
           <p:cNvPr id="7" name="">
             <a:extLst xmlns:a="http://schemas.openxmlformats.org/drawingml/2006/main">
               <a:ext uri="{FF2B5EF4-FFF2-40B4-BE49-F238E27FC236}">
-                <a16:creationId xmlns:a16="http://schemas.microsoft.com/office/drawing/2014/main" id="{A68570F5-AE0E-4814-80EF-2CAB5F8B5944}"/>
+                <a16:creationId xmlns:a16="http://schemas.microsoft.com/office/drawing/2014/main" id="{B3D2AD02-5590-4D51-9B2A-D28B3D67256E}"/>
               </a:ext>
             </a:extLst>
           </p:cNvPr>
@@ -16894,7 +16046,7 @@
           <p:cNvPr id="8" name="">
             <a:extLst xmlns:a="http://schemas.openxmlformats.org/drawingml/2006/main">
               <a:ext uri="{FF2B5EF4-FFF2-40B4-BE49-F238E27FC236}">
-                <a16:creationId xmlns:a16="http://schemas.microsoft.com/office/drawing/2014/main" id="{4D0C70DC-0783-449C-A9B0-98D71244B898}"/>
+                <a16:creationId xmlns:a16="http://schemas.microsoft.com/office/drawing/2014/main" id="{E6527C0F-6B30-4ACF-A403-50D70A4266CD}"/>
               </a:ext>
             </a:extLst>
           </p:cNvPr>
@@ -16962,7 +16114,7 @@
           <p:cNvPr id="9" name="">
             <a:extLst xmlns:a="http://schemas.openxmlformats.org/drawingml/2006/main">
               <a:ext uri="{FF2B5EF4-FFF2-40B4-BE49-F238E27FC236}">
-                <a16:creationId xmlns:a16="http://schemas.microsoft.com/office/drawing/2014/main" id="{8EEA23F5-4745-4B9A-A025-B76A3B47244B}"/>
+                <a16:creationId xmlns:a16="http://schemas.microsoft.com/office/drawing/2014/main" id="{A260834E-0EB1-4D04-9086-D13F122C862B}"/>
               </a:ext>
             </a:extLst>
           </p:cNvPr>
@@ -17030,7 +16182,7 @@
           <p:cNvPr id="10" name="">
             <a:extLst xmlns:a="http://schemas.openxmlformats.org/drawingml/2006/main">
               <a:ext uri="{FF2B5EF4-FFF2-40B4-BE49-F238E27FC236}">
-                <a16:creationId xmlns:a16="http://schemas.microsoft.com/office/drawing/2014/main" id="{B52DACDB-EA46-4B01-9568-B539B93F87BF}"/>
+                <a16:creationId xmlns:a16="http://schemas.microsoft.com/office/drawing/2014/main" id="{17C3A9CB-3FB0-49B6-9C62-783041067E07}"/>
               </a:ext>
             </a:extLst>
           </p:cNvPr>
@@ -17041,8 +16193,8 @@
         </p:nvSpPr>
         <p:spPr>
           <a:xfrm xmlns:a="http://schemas.openxmlformats.org/drawingml/2006/main">
-            <a:off x="609600" y="5905500"/>
-            <a:ext cx="10858500" cy="333375"/>
+            <a:off x="609600" y="5753100"/>
+            <a:ext cx="10858500" cy="666750"/>
           </a:xfrm>
           <a:prstGeom xmlns:a="http://schemas.openxmlformats.org/drawingml/2006/main" prst="rect">
             <a:avLst/>
@@ -17058,7 +16210,7 @@
           </a:bodyPr>
           <a:lstStyle xmlns:a="http://schemas.openxmlformats.org/drawingml/2006/main">
             <a:defPPr>
-              <a:defRPr sz="1875" b="0">
+              <a:defRPr sz="3000" b="0">
                 <a:solidFill>
                   <a:srgbClr val="086C61"/>
                 </a:solidFill>
@@ -17070,7 +16222,7 @@
           </a:lstStyle>
           <a:p xmlns:a="http://schemas.openxmlformats.org/drawingml/2006/main">
             <a:pPr>
-              <a:defRPr sz="1875" b="0">
+              <a:defRPr sz="3000" b="0">
                 <a:solidFill>
                   <a:srgbClr val="086C61"/>
                 </a:solidFill>
@@ -17080,15 +16232,16 @@
               </a:defRPr>
             </a:pPr>
             <a:r>
-              <a:rPr sz="1875" b="0">
+              <a:rPr sz="3000" b="0">
                 <a:solidFill>
                   <a:srgbClr val="086C61"/>
                 </a:solidFill>
                 <a:latin typeface="Arial"/>
                 <a:ea typeface="Arial"/>
                 <a:cs typeface="Arial"/>
+                <a:hlinkClick xmlns:ns0="http://schemas.openxmlformats.org/officeDocument/2006/relationships" ns0:id="rIdColabShortLink"/>
               </a:rPr>
-              <a:t>gordany.github.io/f2-linear-regression/workshop-2/</a:t>
+              <a:t>Colab: tinyurl.com/26jdbxfb</a:t>
             </a:r>
           </a:p>
         </p:txBody>
@@ -17096,7 +16249,7 @@
     </p:spTree>
     <p:extLst>
       <p:ext uri="{BB962C8B-B14F-4D97-AF65-F5344CB8AC3E}">
-        <p14:creationId xmlns:p14="http://schemas.microsoft.com/office/powerpoint/2010/main" val="1817768579"/>
+        <p14:creationId xmlns:p14="http://schemas.microsoft.com/office/powerpoint/2010/main" val="918721594"/>
       </p:ext>
     </p:extLst>
   </p:cSld>
@@ -17127,7 +16280,7 @@
           <p:cNvPr id="11" name="">
             <a:extLst xmlns:a="http://schemas.openxmlformats.org/drawingml/2006/main">
               <a:ext uri="{FF2B5EF4-FFF2-40B4-BE49-F238E27FC236}">
-                <a16:creationId xmlns:a16="http://schemas.microsoft.com/office/drawing/2014/main" id="{F053168A-47E4-43F3-86F5-2DD49363758E}"/>
+                <a16:creationId xmlns:a16="http://schemas.microsoft.com/office/drawing/2014/main" id="{E96EC304-D334-4ACA-BABC-25E620D19915}"/>
               </a:ext>
             </a:extLst>
           </p:cNvPr>
@@ -17195,7 +16348,7 @@
           <p:cNvPr id="2" name="">
             <a:extLst xmlns:a="http://schemas.openxmlformats.org/drawingml/2006/main">
               <a:ext uri="{FF2B5EF4-FFF2-40B4-BE49-F238E27FC236}">
-                <a16:creationId xmlns:a16="http://schemas.microsoft.com/office/drawing/2014/main" id="{13523BE1-5560-4B58-9E8D-CC1E693D99BB}"/>
+                <a16:creationId xmlns:a16="http://schemas.microsoft.com/office/drawing/2014/main" id="{6C317292-CAB0-4E4E-8C96-ECC06FBA4062}"/>
               </a:ext>
             </a:extLst>
           </p:cNvPr>
@@ -17263,7 +16416,7 @@
           <p:cNvPr id="3" name="">
             <a:extLst xmlns:a="http://schemas.openxmlformats.org/drawingml/2006/main">
               <a:ext uri="{FF2B5EF4-FFF2-40B4-BE49-F238E27FC236}">
-                <a16:creationId xmlns:a16="http://schemas.microsoft.com/office/drawing/2014/main" id="{EC519115-7315-4712-8331-AD9910497102}"/>
+                <a16:creationId xmlns:a16="http://schemas.microsoft.com/office/drawing/2014/main" id="{C8441489-AC55-456F-A14D-0358949F36F7}"/>
               </a:ext>
             </a:extLst>
           </p:cNvPr>
@@ -17331,7 +16484,7 @@
           <p:cNvPr id="4" name="Chart">
             <a:extLst xmlns:a="http://schemas.openxmlformats.org/drawingml/2006/main">
               <a:ext uri="{FF2B5EF4-FFF2-40B4-BE49-F238E27FC236}">
-                <a16:creationId xmlns:a16="http://schemas.microsoft.com/office/drawing/2014/main" id="{05B0685D-87E6-4F04-A18F-903D470C7200}"/>
+                <a16:creationId xmlns:a16="http://schemas.microsoft.com/office/drawing/2014/main" id="{B1E23719-CD97-4740-B6DC-E3EFB348137F}"/>
               </a:ext>
             </a:extLst>
           </p:cNvPr>
@@ -17344,7 +16497,7 @@
         </p:xfrm>
         <a:graphic xmlns:a="http://schemas.openxmlformats.org/drawingml/2006/main">
           <a:graphicData uri="http://schemas.openxmlformats.org/drawingml/2006/chart">
-            <c:chart xmlns:r="http://schemas.openxmlformats.org/officeDocument/2006/relationships" xmlns:c="http://schemas.openxmlformats.org/drawingml/2006/chart" r:id="Rb682a9d9ff984430"/>
+            <c:chart xmlns:r="http://schemas.openxmlformats.org/officeDocument/2006/relationships" xmlns:c="http://schemas.openxmlformats.org/drawingml/2006/chart" r:id="R0c7acf0b0e414184"/>
           </a:graphicData>
         </a:graphic>
       </p:graphicFrame>
@@ -17353,7 +16506,7 @@
           <p:cNvPr id="5" name="">
             <a:extLst xmlns:a="http://schemas.openxmlformats.org/drawingml/2006/main">
               <a:ext uri="{FF2B5EF4-FFF2-40B4-BE49-F238E27FC236}">
-                <a16:creationId xmlns:a16="http://schemas.microsoft.com/office/drawing/2014/main" id="{2A2DCEF4-55A5-446C-86C4-EDD9690B2361}"/>
+                <a16:creationId xmlns:a16="http://schemas.microsoft.com/office/drawing/2014/main" id="{69994D15-FE43-4753-B328-3AA472FF0F2F}"/>
               </a:ext>
             </a:extLst>
           </p:cNvPr>
@@ -17421,7 +16574,7 @@
           <p:cNvPr id="6" name="">
             <a:extLst xmlns:a="http://schemas.openxmlformats.org/drawingml/2006/main">
               <a:ext uri="{FF2B5EF4-FFF2-40B4-BE49-F238E27FC236}">
-                <a16:creationId xmlns:a16="http://schemas.microsoft.com/office/drawing/2014/main" id="{8E75FEBC-AA4B-42EC-9E4B-0C29B1213D1B}"/>
+                <a16:creationId xmlns:a16="http://schemas.microsoft.com/office/drawing/2014/main" id="{0A82712F-5D1E-4BBC-B695-A657B32C1D59}"/>
               </a:ext>
             </a:extLst>
           </p:cNvPr>
@@ -17489,7 +16642,7 @@
           <p:cNvPr id="7" name="">
             <a:extLst xmlns:a="http://schemas.openxmlformats.org/drawingml/2006/main">
               <a:ext uri="{FF2B5EF4-FFF2-40B4-BE49-F238E27FC236}">
-                <a16:creationId xmlns:a16="http://schemas.microsoft.com/office/drawing/2014/main" id="{93DD656C-0145-46EA-AB8E-B04F72C12BEE}"/>
+                <a16:creationId xmlns:a16="http://schemas.microsoft.com/office/drawing/2014/main" id="{0979B71F-711D-4F5A-A149-C56E0E14DF24}"/>
               </a:ext>
             </a:extLst>
           </p:cNvPr>
@@ -17557,7 +16710,7 @@
           <p:cNvPr id="8" name="">
             <a:extLst xmlns:a="http://schemas.openxmlformats.org/drawingml/2006/main">
               <a:ext uri="{FF2B5EF4-FFF2-40B4-BE49-F238E27FC236}">
-                <a16:creationId xmlns:a16="http://schemas.microsoft.com/office/drawing/2014/main" id="{BDC141C4-7EB0-4286-992C-E3B70CF66D24}"/>
+                <a16:creationId xmlns:a16="http://schemas.microsoft.com/office/drawing/2014/main" id="{21F983DF-D19F-4D8D-B273-AD04760AEF4E}"/>
               </a:ext>
             </a:extLst>
           </p:cNvPr>
@@ -17625,7 +16778,7 @@
           <p:cNvPr id="9" name="">
             <a:extLst xmlns:a="http://schemas.openxmlformats.org/drawingml/2006/main">
               <a:ext uri="{FF2B5EF4-FFF2-40B4-BE49-F238E27FC236}">
-                <a16:creationId xmlns:a16="http://schemas.microsoft.com/office/drawing/2014/main" id="{89E140D3-9408-4F91-8B87-12F5C1CA20F4}"/>
+                <a16:creationId xmlns:a16="http://schemas.microsoft.com/office/drawing/2014/main" id="{9ADD2C63-F486-485E-B2D7-DD353EF686D5}"/>
               </a:ext>
             </a:extLst>
           </p:cNvPr>
@@ -17693,7 +16846,7 @@
           <p:cNvPr id="10" name="">
             <a:extLst xmlns:a="http://schemas.openxmlformats.org/drawingml/2006/main">
               <a:ext uri="{FF2B5EF4-FFF2-40B4-BE49-F238E27FC236}">
-                <a16:creationId xmlns:a16="http://schemas.microsoft.com/office/drawing/2014/main" id="{1AF46C8E-7FF1-49A4-A29E-27450406290B}"/>
+                <a16:creationId xmlns:a16="http://schemas.microsoft.com/office/drawing/2014/main" id="{2D3B1FEE-4E9B-44D1-8B92-4862AA7FAF35}"/>
               </a:ext>
             </a:extLst>
           </p:cNvPr>
@@ -17759,7 +16912,7 @@
     </p:spTree>
     <p:extLst>
       <p:ext uri="{BB962C8B-B14F-4D97-AF65-F5344CB8AC3E}">
-        <p14:creationId xmlns:p14="http://schemas.microsoft.com/office/powerpoint/2010/main" val="1389079171"/>
+        <p14:creationId xmlns:p14="http://schemas.microsoft.com/office/powerpoint/2010/main" val="1543304383"/>
       </p:ext>
     </p:extLst>
   </p:cSld>
@@ -17790,7 +16943,7 @@
           <p:cNvPr id="11" name="">
             <a:extLst xmlns:a="http://schemas.openxmlformats.org/drawingml/2006/main">
               <a:ext uri="{FF2B5EF4-FFF2-40B4-BE49-F238E27FC236}">
-                <a16:creationId xmlns:a16="http://schemas.microsoft.com/office/drawing/2014/main" id="{9FC9134B-5293-4EB7-A15F-88EDB6EC7E37}"/>
+                <a16:creationId xmlns:a16="http://schemas.microsoft.com/office/drawing/2014/main" id="{AC4761C7-1CAD-4803-9474-466CA73D405D}"/>
               </a:ext>
             </a:extLst>
           </p:cNvPr>
@@ -17858,7 +17011,7 @@
           <p:cNvPr id="2" name="">
             <a:extLst xmlns:a="http://schemas.openxmlformats.org/drawingml/2006/main">
               <a:ext uri="{FF2B5EF4-FFF2-40B4-BE49-F238E27FC236}">
-                <a16:creationId xmlns:a16="http://schemas.microsoft.com/office/drawing/2014/main" id="{3B3CEF3B-8290-4C2E-B99B-623658875115}"/>
+                <a16:creationId xmlns:a16="http://schemas.microsoft.com/office/drawing/2014/main" id="{8A995800-B8A7-4165-9C0D-3EB7E7B64933}"/>
               </a:ext>
             </a:extLst>
           </p:cNvPr>
@@ -17926,7 +17079,7 @@
           <p:cNvPr id="3" name="">
             <a:extLst xmlns:a="http://schemas.openxmlformats.org/drawingml/2006/main">
               <a:ext uri="{FF2B5EF4-FFF2-40B4-BE49-F238E27FC236}">
-                <a16:creationId xmlns:a16="http://schemas.microsoft.com/office/drawing/2014/main" id="{A63C286A-417E-48B6-B04D-D37526AB974D}"/>
+                <a16:creationId xmlns:a16="http://schemas.microsoft.com/office/drawing/2014/main" id="{A2F74909-C827-41F3-9DD8-777117D52D7F}"/>
               </a:ext>
             </a:extLst>
           </p:cNvPr>
@@ -17994,7 +17147,7 @@
           <p:cNvPr id="4" name="Chart">
             <a:extLst xmlns:a="http://schemas.openxmlformats.org/drawingml/2006/main">
               <a:ext uri="{FF2B5EF4-FFF2-40B4-BE49-F238E27FC236}">
-                <a16:creationId xmlns:a16="http://schemas.microsoft.com/office/drawing/2014/main" id="{59AA8022-9C6E-4F53-80B7-2210F4CA215C}"/>
+                <a16:creationId xmlns:a16="http://schemas.microsoft.com/office/drawing/2014/main" id="{527B754C-4DD1-4374-B72E-D56731C85B9D}"/>
               </a:ext>
             </a:extLst>
           </p:cNvPr>
@@ -18007,7 +17160,7 @@
         </p:xfrm>
         <a:graphic xmlns:a="http://schemas.openxmlformats.org/drawingml/2006/main">
           <a:graphicData uri="http://schemas.openxmlformats.org/drawingml/2006/chart">
-            <c:chart xmlns:r="http://schemas.openxmlformats.org/officeDocument/2006/relationships" xmlns:c="http://schemas.openxmlformats.org/drawingml/2006/chart" r:id="R59fc927ba6fd442a"/>
+            <c:chart xmlns:r="http://schemas.openxmlformats.org/officeDocument/2006/relationships" xmlns:c="http://schemas.openxmlformats.org/drawingml/2006/chart" r:id="Rde553efa15dd41ad"/>
           </a:graphicData>
         </a:graphic>
       </p:graphicFrame>
@@ -18016,7 +17169,7 @@
           <p:cNvPr id="5" name="">
             <a:extLst xmlns:a="http://schemas.openxmlformats.org/drawingml/2006/main">
               <a:ext uri="{FF2B5EF4-FFF2-40B4-BE49-F238E27FC236}">
-                <a16:creationId xmlns:a16="http://schemas.microsoft.com/office/drawing/2014/main" id="{1E37A06A-3493-47F2-B295-11A566DE07BD}"/>
+                <a16:creationId xmlns:a16="http://schemas.microsoft.com/office/drawing/2014/main" id="{E1D25EBF-FF50-4917-8381-682732F4B8CC}"/>
               </a:ext>
             </a:extLst>
           </p:cNvPr>
@@ -18084,7 +17237,7 @@
           <p:cNvPr id="6" name="">
             <a:extLst xmlns:a="http://schemas.openxmlformats.org/drawingml/2006/main">
               <a:ext uri="{FF2B5EF4-FFF2-40B4-BE49-F238E27FC236}">
-                <a16:creationId xmlns:a16="http://schemas.microsoft.com/office/drawing/2014/main" id="{0C74B4BF-F216-42E9-97AD-3BEFEE74C5B7}"/>
+                <a16:creationId xmlns:a16="http://schemas.microsoft.com/office/drawing/2014/main" id="{F903CA7B-7322-4DC8-BF42-B11B9F2386AD}"/>
               </a:ext>
             </a:extLst>
           </p:cNvPr>
@@ -18152,7 +17305,7 @@
           <p:cNvPr id="7" name="">
             <a:extLst xmlns:a="http://schemas.openxmlformats.org/drawingml/2006/main">
               <a:ext uri="{FF2B5EF4-FFF2-40B4-BE49-F238E27FC236}">
-                <a16:creationId xmlns:a16="http://schemas.microsoft.com/office/drawing/2014/main" id="{C2EA5C0D-03DE-40ED-A889-BBEF365169F2}"/>
+                <a16:creationId xmlns:a16="http://schemas.microsoft.com/office/drawing/2014/main" id="{569ED653-4CEF-4F35-A078-B3358924EE3D}"/>
               </a:ext>
             </a:extLst>
           </p:cNvPr>
@@ -18220,7 +17373,7 @@
           <p:cNvPr id="8" name="">
             <a:extLst xmlns:a="http://schemas.openxmlformats.org/drawingml/2006/main">
               <a:ext uri="{FF2B5EF4-FFF2-40B4-BE49-F238E27FC236}">
-                <a16:creationId xmlns:a16="http://schemas.microsoft.com/office/drawing/2014/main" id="{886F4528-5076-41C5-9ABB-BF3A15566B83}"/>
+                <a16:creationId xmlns:a16="http://schemas.microsoft.com/office/drawing/2014/main" id="{85BC0DEF-DB8E-4358-A835-48542D0EBAEF}"/>
               </a:ext>
             </a:extLst>
           </p:cNvPr>
@@ -18288,7 +17441,7 @@
           <p:cNvPr id="9" name="">
             <a:extLst xmlns:a="http://schemas.openxmlformats.org/drawingml/2006/main">
               <a:ext uri="{FF2B5EF4-FFF2-40B4-BE49-F238E27FC236}">
-                <a16:creationId xmlns:a16="http://schemas.microsoft.com/office/drawing/2014/main" id="{1263B49A-2B53-48AB-80D7-CDC6A7FBA748}"/>
+                <a16:creationId xmlns:a16="http://schemas.microsoft.com/office/drawing/2014/main" id="{7FB69251-B23E-4307-8295-49A7F9BEE1A2}"/>
               </a:ext>
             </a:extLst>
           </p:cNvPr>
@@ -18356,7 +17509,7 @@
           <p:cNvPr id="10" name="">
             <a:extLst xmlns:a="http://schemas.openxmlformats.org/drawingml/2006/main">
               <a:ext uri="{FF2B5EF4-FFF2-40B4-BE49-F238E27FC236}">
-                <a16:creationId xmlns:a16="http://schemas.microsoft.com/office/drawing/2014/main" id="{7A13634E-513C-49CE-B5B7-DDEDEB56AEF8}"/>
+                <a16:creationId xmlns:a16="http://schemas.microsoft.com/office/drawing/2014/main" id="{546E8417-C716-4CA0-9C0A-E66AF8D00F7F}"/>
               </a:ext>
             </a:extLst>
           </p:cNvPr>
@@ -18422,7 +17575,7 @@
     </p:spTree>
     <p:extLst>
       <p:ext uri="{BB962C8B-B14F-4D97-AF65-F5344CB8AC3E}">
-        <p14:creationId xmlns:p14="http://schemas.microsoft.com/office/powerpoint/2010/main" val="186478955"/>
+        <p14:creationId xmlns:p14="http://schemas.microsoft.com/office/powerpoint/2010/main" val="1461170803"/>
       </p:ext>
     </p:extLst>
   </p:cSld>
@@ -18453,7 +17606,7 @@
           <p:cNvPr id="10" name="">
             <a:extLst xmlns:a="http://schemas.openxmlformats.org/drawingml/2006/main">
               <a:ext uri="{FF2B5EF4-FFF2-40B4-BE49-F238E27FC236}">
-                <a16:creationId xmlns:a16="http://schemas.microsoft.com/office/drawing/2014/main" id="{3C1159C0-915D-419B-A0A9-667339B4D6E8}"/>
+                <a16:creationId xmlns:a16="http://schemas.microsoft.com/office/drawing/2014/main" id="{F6833B48-F43E-491A-BEAA-47C796AED2BB}"/>
               </a:ext>
             </a:extLst>
           </p:cNvPr>
@@ -18521,7 +17674,7 @@
           <p:cNvPr id="2" name="">
             <a:extLst xmlns:a="http://schemas.openxmlformats.org/drawingml/2006/main">
               <a:ext uri="{FF2B5EF4-FFF2-40B4-BE49-F238E27FC236}">
-                <a16:creationId xmlns:a16="http://schemas.microsoft.com/office/drawing/2014/main" id="{DD3CF887-D47D-4C74-B1C9-19638CFF2500}"/>
+                <a16:creationId xmlns:a16="http://schemas.microsoft.com/office/drawing/2014/main" id="{FDC66BA1-2285-4A42-B5E6-022E2A414AF6}"/>
               </a:ext>
             </a:extLst>
           </p:cNvPr>
@@ -18589,7 +17742,7 @@
           <p:cNvPr id="3" name="">
             <a:extLst xmlns:a="http://schemas.openxmlformats.org/drawingml/2006/main">
               <a:ext uri="{FF2B5EF4-FFF2-40B4-BE49-F238E27FC236}">
-                <a16:creationId xmlns:a16="http://schemas.microsoft.com/office/drawing/2014/main" id="{0E241DAB-84F6-4A32-86C5-9F79AFE48AF1}"/>
+                <a16:creationId xmlns:a16="http://schemas.microsoft.com/office/drawing/2014/main" id="{18414F70-78A6-4387-9BD9-BD93F0BE7011}"/>
               </a:ext>
             </a:extLst>
           </p:cNvPr>
@@ -18657,7 +17810,7 @@
           <p:cNvPr id="4" name="Chart">
             <a:extLst xmlns:a="http://schemas.openxmlformats.org/drawingml/2006/main">
               <a:ext uri="{FF2B5EF4-FFF2-40B4-BE49-F238E27FC236}">
-                <a16:creationId xmlns:a16="http://schemas.microsoft.com/office/drawing/2014/main" id="{33B10940-4CB2-4DCA-9556-958C9C0EE94F}"/>
+                <a16:creationId xmlns:a16="http://schemas.microsoft.com/office/drawing/2014/main" id="{9E1D405A-F65C-4B76-96D0-5CD25071A681}"/>
               </a:ext>
             </a:extLst>
           </p:cNvPr>
@@ -18670,7 +17823,7 @@
         </p:xfrm>
         <a:graphic xmlns:a="http://schemas.openxmlformats.org/drawingml/2006/main">
           <a:graphicData uri="http://schemas.openxmlformats.org/drawingml/2006/chart">
-            <c:chart xmlns:r="http://schemas.openxmlformats.org/officeDocument/2006/relationships" xmlns:c="http://schemas.openxmlformats.org/drawingml/2006/chart" r:id="R3c5d964186624b57"/>
+            <c:chart xmlns:r="http://schemas.openxmlformats.org/officeDocument/2006/relationships" xmlns:c="http://schemas.openxmlformats.org/drawingml/2006/chart" r:id="R489c6a31090148ce"/>
           </a:graphicData>
         </a:graphic>
       </p:graphicFrame>
@@ -18679,7 +17832,7 @@
           <p:cNvPr id="5" name="">
             <a:extLst xmlns:a="http://schemas.openxmlformats.org/drawingml/2006/main">
               <a:ext uri="{FF2B5EF4-FFF2-40B4-BE49-F238E27FC236}">
-                <a16:creationId xmlns:a16="http://schemas.microsoft.com/office/drawing/2014/main" id="{FF5CEC53-88A2-474C-A77E-D9F1D224F7DE}"/>
+                <a16:creationId xmlns:a16="http://schemas.microsoft.com/office/drawing/2014/main" id="{08A6B93D-3BE7-4B5D-B2F5-1885E1EFD759}"/>
               </a:ext>
             </a:extLst>
           </p:cNvPr>
@@ -18747,7 +17900,7 @@
           <p:cNvPr id="6" name="">
             <a:extLst xmlns:a="http://schemas.openxmlformats.org/drawingml/2006/main">
               <a:ext uri="{FF2B5EF4-FFF2-40B4-BE49-F238E27FC236}">
-                <a16:creationId xmlns:a16="http://schemas.microsoft.com/office/drawing/2014/main" id="{41603FAE-D1EE-4BDA-827E-C009F02575CE}"/>
+                <a16:creationId xmlns:a16="http://schemas.microsoft.com/office/drawing/2014/main" id="{C7F70D99-5DF8-4E82-876A-43134F422697}"/>
               </a:ext>
             </a:extLst>
           </p:cNvPr>
@@ -18815,7 +17968,7 @@
           <p:cNvPr id="7" name="">
             <a:extLst xmlns:a="http://schemas.openxmlformats.org/drawingml/2006/main">
               <a:ext uri="{FF2B5EF4-FFF2-40B4-BE49-F238E27FC236}">
-                <a16:creationId xmlns:a16="http://schemas.microsoft.com/office/drawing/2014/main" id="{B36D5D57-1AC0-4079-BBB0-8BDFF995846D}"/>
+                <a16:creationId xmlns:a16="http://schemas.microsoft.com/office/drawing/2014/main" id="{9A350124-1FB9-4567-9E35-A8FB88CE63B9}"/>
               </a:ext>
             </a:extLst>
           </p:cNvPr>
@@ -18883,7 +18036,7 @@
           <p:cNvPr id="8" name="">
             <a:extLst xmlns:a="http://schemas.openxmlformats.org/drawingml/2006/main">
               <a:ext uri="{FF2B5EF4-FFF2-40B4-BE49-F238E27FC236}">
-                <a16:creationId xmlns:a16="http://schemas.microsoft.com/office/drawing/2014/main" id="{6DF9DD1B-0D09-4BCF-8887-481A410B2FDB}"/>
+                <a16:creationId xmlns:a16="http://schemas.microsoft.com/office/drawing/2014/main" id="{F3DFA8DF-78C8-4B38-B433-B27ABB971614}"/>
               </a:ext>
             </a:extLst>
           </p:cNvPr>
@@ -18951,7 +18104,7 @@
           <p:cNvPr id="9" name="">
             <a:extLst xmlns:a="http://schemas.openxmlformats.org/drawingml/2006/main">
               <a:ext uri="{FF2B5EF4-FFF2-40B4-BE49-F238E27FC236}">
-                <a16:creationId xmlns:a16="http://schemas.microsoft.com/office/drawing/2014/main" id="{A9E20267-73E4-4A48-8445-1E7A8E31D390}"/>
+                <a16:creationId xmlns:a16="http://schemas.microsoft.com/office/drawing/2014/main" id="{3C7D9799-34BA-4052-97A1-F9F98CA0D8B9}"/>
               </a:ext>
             </a:extLst>
           </p:cNvPr>
@@ -19017,7 +18170,7 @@
     </p:spTree>
     <p:extLst>
       <p:ext uri="{BB962C8B-B14F-4D97-AF65-F5344CB8AC3E}">
-        <p14:creationId xmlns:p14="http://schemas.microsoft.com/office/powerpoint/2010/main" val="767325160"/>
+        <p14:creationId xmlns:p14="http://schemas.microsoft.com/office/powerpoint/2010/main" val="1445655988"/>
       </p:ext>
     </p:extLst>
   </p:cSld>
@@ -19048,7 +18201,7 @@
           <p:cNvPr id="11" name="">
             <a:extLst xmlns:a="http://schemas.openxmlformats.org/drawingml/2006/main">
               <a:ext uri="{FF2B5EF4-FFF2-40B4-BE49-F238E27FC236}">
-                <a16:creationId xmlns:a16="http://schemas.microsoft.com/office/drawing/2014/main" id="{F2336794-1AF9-44AD-924D-7DF778200A35}"/>
+                <a16:creationId xmlns:a16="http://schemas.microsoft.com/office/drawing/2014/main" id="{F405D8CC-AA53-49CC-A267-51F4678F4773}"/>
               </a:ext>
             </a:extLst>
           </p:cNvPr>
@@ -19116,7 +18269,7 @@
           <p:cNvPr id="2" name="">
             <a:extLst xmlns:a="http://schemas.openxmlformats.org/drawingml/2006/main">
               <a:ext uri="{FF2B5EF4-FFF2-40B4-BE49-F238E27FC236}">
-                <a16:creationId xmlns:a16="http://schemas.microsoft.com/office/drawing/2014/main" id="{98A18154-1602-4F51-9810-37BAABDCA5CB}"/>
+                <a16:creationId xmlns:a16="http://schemas.microsoft.com/office/drawing/2014/main" id="{55BD679D-D166-4BAB-B333-592D308D8BBC}"/>
               </a:ext>
             </a:extLst>
           </p:cNvPr>
@@ -19184,7 +18337,7 @@
           <p:cNvPr id="3" name="">
             <a:extLst xmlns:a="http://schemas.openxmlformats.org/drawingml/2006/main">
               <a:ext uri="{FF2B5EF4-FFF2-40B4-BE49-F238E27FC236}">
-                <a16:creationId xmlns:a16="http://schemas.microsoft.com/office/drawing/2014/main" id="{65A0844E-2B85-4BBC-9BE4-69CF1E5E1E6A}"/>
+                <a16:creationId xmlns:a16="http://schemas.microsoft.com/office/drawing/2014/main" id="{E2A235DC-F420-496A-9383-1EE9BA2CDA1B}"/>
               </a:ext>
             </a:extLst>
           </p:cNvPr>
@@ -19252,7 +18405,7 @@
           <p:cNvPr id="4" name="Chart">
             <a:extLst xmlns:a="http://schemas.openxmlformats.org/drawingml/2006/main">
               <a:ext uri="{FF2B5EF4-FFF2-40B4-BE49-F238E27FC236}">
-                <a16:creationId xmlns:a16="http://schemas.microsoft.com/office/drawing/2014/main" id="{44E87F86-6462-4DA5-BA10-A399846B2AC9}"/>
+                <a16:creationId xmlns:a16="http://schemas.microsoft.com/office/drawing/2014/main" id="{F0B2C037-379F-48D5-9E50-AAFF73F5DA39}"/>
               </a:ext>
             </a:extLst>
           </p:cNvPr>
@@ -19265,7 +18418,7 @@
         </p:xfrm>
         <a:graphic xmlns:a="http://schemas.openxmlformats.org/drawingml/2006/main">
           <a:graphicData uri="http://schemas.openxmlformats.org/drawingml/2006/chart">
-            <c:chart xmlns:r="http://schemas.openxmlformats.org/officeDocument/2006/relationships" xmlns:c="http://schemas.openxmlformats.org/drawingml/2006/chart" r:id="R05d582b95090411e"/>
+            <c:chart xmlns:r="http://schemas.openxmlformats.org/officeDocument/2006/relationships" xmlns:c="http://schemas.openxmlformats.org/drawingml/2006/chart" r:id="Rc87af662bb7041b5"/>
           </a:graphicData>
         </a:graphic>
       </p:graphicFrame>
@@ -19274,7 +18427,7 @@
           <p:cNvPr id="5" name="">
             <a:extLst xmlns:a="http://schemas.openxmlformats.org/drawingml/2006/main">
               <a:ext uri="{FF2B5EF4-FFF2-40B4-BE49-F238E27FC236}">
-                <a16:creationId xmlns:a16="http://schemas.microsoft.com/office/drawing/2014/main" id="{FA40D220-4470-4115-8488-92313C3247DF}"/>
+                <a16:creationId xmlns:a16="http://schemas.microsoft.com/office/drawing/2014/main" id="{B98A8F4A-C5EA-4459-9243-30D223869227}"/>
               </a:ext>
             </a:extLst>
           </p:cNvPr>
@@ -19342,7 +18495,7 @@
           <p:cNvPr id="6" name="">
             <a:extLst xmlns:a="http://schemas.openxmlformats.org/drawingml/2006/main">
               <a:ext uri="{FF2B5EF4-FFF2-40B4-BE49-F238E27FC236}">
-                <a16:creationId xmlns:a16="http://schemas.microsoft.com/office/drawing/2014/main" id="{EB90F793-12D1-444F-B737-BA608217D2A7}"/>
+                <a16:creationId xmlns:a16="http://schemas.microsoft.com/office/drawing/2014/main" id="{03926D4D-AA46-47CF-BD34-9CF6FF8FA407}"/>
               </a:ext>
             </a:extLst>
           </p:cNvPr>
@@ -19410,7 +18563,7 @@
           <p:cNvPr id="7" name="">
             <a:extLst xmlns:a="http://schemas.openxmlformats.org/drawingml/2006/main">
               <a:ext uri="{FF2B5EF4-FFF2-40B4-BE49-F238E27FC236}">
-                <a16:creationId xmlns:a16="http://schemas.microsoft.com/office/drawing/2014/main" id="{C8B3790A-FB92-4435-A265-6B29529774E7}"/>
+                <a16:creationId xmlns:a16="http://schemas.microsoft.com/office/drawing/2014/main" id="{1F9AADB7-805B-49E0-AF3A-AA0F278D3589}"/>
               </a:ext>
             </a:extLst>
           </p:cNvPr>
@@ -19478,7 +18631,7 @@
           <p:cNvPr id="8" name="">
             <a:extLst xmlns:a="http://schemas.openxmlformats.org/drawingml/2006/main">
               <a:ext uri="{FF2B5EF4-FFF2-40B4-BE49-F238E27FC236}">
-                <a16:creationId xmlns:a16="http://schemas.microsoft.com/office/drawing/2014/main" id="{87B534F2-1FD6-453A-9E25-ED66AA018FD6}"/>
+                <a16:creationId xmlns:a16="http://schemas.microsoft.com/office/drawing/2014/main" id="{69D3BE1F-69BC-4BCA-A451-7F0A9C4377AD}"/>
               </a:ext>
             </a:extLst>
           </p:cNvPr>
@@ -19546,7 +18699,7 @@
           <p:cNvPr id="9" name="">
             <a:extLst xmlns:a="http://schemas.openxmlformats.org/drawingml/2006/main">
               <a:ext uri="{FF2B5EF4-FFF2-40B4-BE49-F238E27FC236}">
-                <a16:creationId xmlns:a16="http://schemas.microsoft.com/office/drawing/2014/main" id="{4D4013A2-E38C-4137-A9E6-541784871F87}"/>
+                <a16:creationId xmlns:a16="http://schemas.microsoft.com/office/drawing/2014/main" id="{59635F0D-31E8-4E33-A946-7CA7B585CDB1}"/>
               </a:ext>
             </a:extLst>
           </p:cNvPr>
@@ -19614,7 +18767,7 @@
           <p:cNvPr id="10" name="">
             <a:extLst xmlns:a="http://schemas.openxmlformats.org/drawingml/2006/main">
               <a:ext uri="{FF2B5EF4-FFF2-40B4-BE49-F238E27FC236}">
-                <a16:creationId xmlns:a16="http://schemas.microsoft.com/office/drawing/2014/main" id="{F80D5A72-4555-4E4D-8F93-07F2B90B6BB0}"/>
+                <a16:creationId xmlns:a16="http://schemas.microsoft.com/office/drawing/2014/main" id="{D1B676E8-74EF-4A89-8456-A1FC6FC60AC5}"/>
               </a:ext>
             </a:extLst>
           </p:cNvPr>
@@ -19680,7 +18833,7 @@
     </p:spTree>
     <p:extLst>
       <p:ext uri="{BB962C8B-B14F-4D97-AF65-F5344CB8AC3E}">
-        <p14:creationId xmlns:p14="http://schemas.microsoft.com/office/powerpoint/2010/main" val="495483766"/>
+        <p14:creationId xmlns:p14="http://schemas.microsoft.com/office/powerpoint/2010/main" val="327457317"/>
       </p:ext>
     </p:extLst>
   </p:cSld>

</xml_diff>